<commit_message>
Initial merge using Copilot
</commit_message>
<xml_diff>
--- a/pptfiles/Git Fun(damentals).pptx
+++ b/pptfiles/Git Fun(damentals).pptx
@@ -206,7 +206,7 @@
           <a:p>
             <a:fld id="{0DEEF836-1B92-4BB9-A026-840A0CC45D27}" type="datetimeFigureOut">
               <a:rPr lang="en-US" smtClean="0"/>
-              <a:t>3/12/2025</a:t>
+              <a:t>4/4/2026</a:t>
             </a:fld>
             <a:endParaRPr lang="en-US"/>
           </a:p>
@@ -932,10 +932,9 @@
           <a:lstStyle/>
           <a:p>
             <a:r>
-              <a:rPr lang="en-US"/>
+              <a:rPr lang="en-US" dirty="0"/>
               <a:t>git status</a:t>
             </a:r>
-            <a:endParaRPr lang="en-US" dirty="0"/>
           </a:p>
         </p:txBody>
       </p:sp>
@@ -1122,7 +1121,7 @@
           <a:p>
             <a:fld id="{21313E3A-D863-467D-A8AF-65230468DBE3}" type="datetimeFigureOut">
               <a:rPr lang="en-US" smtClean="0"/>
-              <a:t>3/12/2025</a:t>
+              <a:t>4/4/2026</a:t>
             </a:fld>
             <a:endParaRPr lang="en-US"/>
           </a:p>
@@ -1320,7 +1319,7 @@
           <a:p>
             <a:fld id="{21313E3A-D863-467D-A8AF-65230468DBE3}" type="datetimeFigureOut">
               <a:rPr lang="en-US" smtClean="0"/>
-              <a:t>3/12/2025</a:t>
+              <a:t>4/4/2026</a:t>
             </a:fld>
             <a:endParaRPr lang="en-US"/>
           </a:p>
@@ -1528,7 +1527,7 @@
           <a:p>
             <a:fld id="{21313E3A-D863-467D-A8AF-65230468DBE3}" type="datetimeFigureOut">
               <a:rPr lang="en-US" smtClean="0"/>
-              <a:t>3/12/2025</a:t>
+              <a:t>4/4/2026</a:t>
             </a:fld>
             <a:endParaRPr lang="en-US"/>
           </a:p>
@@ -1726,7 +1725,7 @@
           <a:p>
             <a:fld id="{21313E3A-D863-467D-A8AF-65230468DBE3}" type="datetimeFigureOut">
               <a:rPr lang="en-US" smtClean="0"/>
-              <a:t>3/12/2025</a:t>
+              <a:t>4/4/2026</a:t>
             </a:fld>
             <a:endParaRPr lang="en-US"/>
           </a:p>
@@ -2001,7 +2000,7 @@
           <a:p>
             <a:fld id="{21313E3A-D863-467D-A8AF-65230468DBE3}" type="datetimeFigureOut">
               <a:rPr lang="en-US" smtClean="0"/>
-              <a:t>3/12/2025</a:t>
+              <a:t>4/4/2026</a:t>
             </a:fld>
             <a:endParaRPr lang="en-US"/>
           </a:p>
@@ -2266,7 +2265,7 @@
           <a:p>
             <a:fld id="{21313E3A-D863-467D-A8AF-65230468DBE3}" type="datetimeFigureOut">
               <a:rPr lang="en-US" smtClean="0"/>
-              <a:t>3/12/2025</a:t>
+              <a:t>4/4/2026</a:t>
             </a:fld>
             <a:endParaRPr lang="en-US"/>
           </a:p>
@@ -2678,7 +2677,7 @@
           <a:p>
             <a:fld id="{21313E3A-D863-467D-A8AF-65230468DBE3}" type="datetimeFigureOut">
               <a:rPr lang="en-US" smtClean="0"/>
-              <a:t>3/12/2025</a:t>
+              <a:t>4/4/2026</a:t>
             </a:fld>
             <a:endParaRPr lang="en-US"/>
           </a:p>
@@ -2819,7 +2818,7 @@
           <a:p>
             <a:fld id="{21313E3A-D863-467D-A8AF-65230468DBE3}" type="datetimeFigureOut">
               <a:rPr lang="en-US" smtClean="0"/>
-              <a:t>3/12/2025</a:t>
+              <a:t>4/4/2026</a:t>
             </a:fld>
             <a:endParaRPr lang="en-US"/>
           </a:p>
@@ -2932,7 +2931,7 @@
           <a:p>
             <a:fld id="{21313E3A-D863-467D-A8AF-65230468DBE3}" type="datetimeFigureOut">
               <a:rPr lang="en-US" smtClean="0"/>
-              <a:t>3/12/2025</a:t>
+              <a:t>4/4/2026</a:t>
             </a:fld>
             <a:endParaRPr lang="en-US"/>
           </a:p>
@@ -3243,7 +3242,7 @@
           <a:p>
             <a:fld id="{21313E3A-D863-467D-A8AF-65230468DBE3}" type="datetimeFigureOut">
               <a:rPr lang="en-US" smtClean="0"/>
-              <a:t>3/12/2025</a:t>
+              <a:t>4/4/2026</a:t>
             </a:fld>
             <a:endParaRPr lang="en-US"/>
           </a:p>
@@ -3531,7 +3530,7 @@
           <a:p>
             <a:fld id="{21313E3A-D863-467D-A8AF-65230468DBE3}" type="datetimeFigureOut">
               <a:rPr lang="en-US" smtClean="0"/>
-              <a:t>3/12/2025</a:t>
+              <a:t>4/4/2026</a:t>
             </a:fld>
             <a:endParaRPr lang="en-US"/>
           </a:p>
@@ -3772,7 +3771,7 @@
           <a:p>
             <a:fld id="{21313E3A-D863-467D-A8AF-65230468DBE3}" type="datetimeFigureOut">
               <a:rPr lang="en-US" smtClean="0"/>
-              <a:t>3/12/2025</a:t>
+              <a:t>4/4/2026</a:t>
             </a:fld>
             <a:endParaRPr lang="en-US"/>
           </a:p>
@@ -4287,8 +4286,16 @@
           <a:p>
             <a:pPr algn="l"/>
             <a:r>
-              <a:rPr lang="en-US" sz="6600"/>
-              <a:t>Git Fun(damentals)</a:t>
+              <a:rPr lang="en-US" sz="6600" dirty="0"/>
+              <a:t>Source Control Fun(</a:t>
+            </a:r>
+            <a:r>
+              <a:rPr lang="en-US" sz="6600" dirty="0" err="1"/>
+              <a:t>damentals</a:t>
+            </a:r>
+            <a:r>
+              <a:rPr lang="en-US" sz="6600" dirty="0"/>
+              <a:t>)</a:t>
             </a:r>
           </a:p>
         </p:txBody>
@@ -4324,7 +4331,7 @@
             <a:pPr algn="l"/>
             <a:r>
               <a:rPr lang="en-US" dirty="0"/>
-              <a:t>Have fun with Git without going mental!</a:t>
+              <a:t>Have fun with Git and GitHub without going mental!</a:t>
             </a:r>
           </a:p>
         </p:txBody>
@@ -4360,93 +4367,93 @@
           <a:custGeom>
             <a:avLst/>
             <a:gdLst>
-              <a:gd name="connsiteX0" fmla="*/ 0 w 4243589"/>
-              <a:gd name="connsiteY0" fmla="*/ 0 h 18288"/>
-              <a:gd name="connsiteX1" fmla="*/ 563791 w 4243589"/>
-              <a:gd name="connsiteY1" fmla="*/ 0 h 18288"/>
-              <a:gd name="connsiteX2" fmla="*/ 1042710 w 4243589"/>
-              <a:gd name="connsiteY2" fmla="*/ 0 h 18288"/>
-              <a:gd name="connsiteX3" fmla="*/ 1564066 w 4243589"/>
-              <a:gd name="connsiteY3" fmla="*/ 0 h 18288"/>
-              <a:gd name="connsiteX4" fmla="*/ 2212729 w 4243589"/>
-              <a:gd name="connsiteY4" fmla="*/ 0 h 18288"/>
-              <a:gd name="connsiteX5" fmla="*/ 2776520 w 4243589"/>
-              <a:gd name="connsiteY5" fmla="*/ 0 h 18288"/>
-              <a:gd name="connsiteX6" fmla="*/ 3297875 w 4243589"/>
-              <a:gd name="connsiteY6" fmla="*/ 0 h 18288"/>
-              <a:gd name="connsiteX7" fmla="*/ 4243589 w 4243589"/>
-              <a:gd name="connsiteY7" fmla="*/ 0 h 18288"/>
-              <a:gd name="connsiteX8" fmla="*/ 4243589 w 4243589"/>
-              <a:gd name="connsiteY8" fmla="*/ 18288 h 18288"/>
-              <a:gd name="connsiteX9" fmla="*/ 3637362 w 4243589"/>
-              <a:gd name="connsiteY9" fmla="*/ 18288 h 18288"/>
-              <a:gd name="connsiteX10" fmla="*/ 3116007 w 4243589"/>
-              <a:gd name="connsiteY10" fmla="*/ 18288 h 18288"/>
-              <a:gd name="connsiteX11" fmla="*/ 2424908 w 4243589"/>
-              <a:gd name="connsiteY11" fmla="*/ 18288 h 18288"/>
-              <a:gd name="connsiteX12" fmla="*/ 1861117 w 4243589"/>
-              <a:gd name="connsiteY12" fmla="*/ 18288 h 18288"/>
-              <a:gd name="connsiteX13" fmla="*/ 1382198 w 4243589"/>
-              <a:gd name="connsiteY13" fmla="*/ 18288 h 18288"/>
-              <a:gd name="connsiteX14" fmla="*/ 733535 w 4243589"/>
-              <a:gd name="connsiteY14" fmla="*/ 18288 h 18288"/>
-              <a:gd name="connsiteX15" fmla="*/ 0 w 4243589"/>
-              <a:gd name="connsiteY15" fmla="*/ 18288 h 18288"/>
-              <a:gd name="connsiteX16" fmla="*/ 0 w 4243589"/>
-              <a:gd name="connsiteY16" fmla="*/ 0 h 18288"/>
+              <a:gd name="csX0" fmla="*/ 0 w 4243589"/>
+              <a:gd name="csY0" fmla="*/ 0 h 18288"/>
+              <a:gd name="csX1" fmla="*/ 563791 w 4243589"/>
+              <a:gd name="csY1" fmla="*/ 0 h 18288"/>
+              <a:gd name="csX2" fmla="*/ 1042710 w 4243589"/>
+              <a:gd name="csY2" fmla="*/ 0 h 18288"/>
+              <a:gd name="csX3" fmla="*/ 1564066 w 4243589"/>
+              <a:gd name="csY3" fmla="*/ 0 h 18288"/>
+              <a:gd name="csX4" fmla="*/ 2212729 w 4243589"/>
+              <a:gd name="csY4" fmla="*/ 0 h 18288"/>
+              <a:gd name="csX5" fmla="*/ 2776520 w 4243589"/>
+              <a:gd name="csY5" fmla="*/ 0 h 18288"/>
+              <a:gd name="csX6" fmla="*/ 3297875 w 4243589"/>
+              <a:gd name="csY6" fmla="*/ 0 h 18288"/>
+              <a:gd name="csX7" fmla="*/ 4243589 w 4243589"/>
+              <a:gd name="csY7" fmla="*/ 0 h 18288"/>
+              <a:gd name="csX8" fmla="*/ 4243589 w 4243589"/>
+              <a:gd name="csY8" fmla="*/ 18288 h 18288"/>
+              <a:gd name="csX9" fmla="*/ 3637362 w 4243589"/>
+              <a:gd name="csY9" fmla="*/ 18288 h 18288"/>
+              <a:gd name="csX10" fmla="*/ 3116007 w 4243589"/>
+              <a:gd name="csY10" fmla="*/ 18288 h 18288"/>
+              <a:gd name="csX11" fmla="*/ 2424908 w 4243589"/>
+              <a:gd name="csY11" fmla="*/ 18288 h 18288"/>
+              <a:gd name="csX12" fmla="*/ 1861117 w 4243589"/>
+              <a:gd name="csY12" fmla="*/ 18288 h 18288"/>
+              <a:gd name="csX13" fmla="*/ 1382198 w 4243589"/>
+              <a:gd name="csY13" fmla="*/ 18288 h 18288"/>
+              <a:gd name="csX14" fmla="*/ 733535 w 4243589"/>
+              <a:gd name="csY14" fmla="*/ 18288 h 18288"/>
+              <a:gd name="csX15" fmla="*/ 0 w 4243589"/>
+              <a:gd name="csY15" fmla="*/ 18288 h 18288"/>
+              <a:gd name="csX16" fmla="*/ 0 w 4243589"/>
+              <a:gd name="csY16" fmla="*/ 0 h 18288"/>
             </a:gdLst>
             <a:ahLst/>
             <a:cxnLst>
               <a:cxn ang="0">
-                <a:pos x="connsiteX0" y="connsiteY0"/>
+                <a:pos x="csX0" y="csY0"/>
               </a:cxn>
               <a:cxn ang="0">
-                <a:pos x="connsiteX1" y="connsiteY1"/>
+                <a:pos x="csX1" y="csY1"/>
               </a:cxn>
               <a:cxn ang="0">
-                <a:pos x="connsiteX2" y="connsiteY2"/>
+                <a:pos x="csX2" y="csY2"/>
               </a:cxn>
               <a:cxn ang="0">
-                <a:pos x="connsiteX3" y="connsiteY3"/>
+                <a:pos x="csX3" y="csY3"/>
               </a:cxn>
               <a:cxn ang="0">
-                <a:pos x="connsiteX4" y="connsiteY4"/>
+                <a:pos x="csX4" y="csY4"/>
               </a:cxn>
               <a:cxn ang="0">
-                <a:pos x="connsiteX5" y="connsiteY5"/>
+                <a:pos x="csX5" y="csY5"/>
               </a:cxn>
               <a:cxn ang="0">
-                <a:pos x="connsiteX6" y="connsiteY6"/>
+                <a:pos x="csX6" y="csY6"/>
               </a:cxn>
               <a:cxn ang="0">
-                <a:pos x="connsiteX7" y="connsiteY7"/>
+                <a:pos x="csX7" y="csY7"/>
               </a:cxn>
               <a:cxn ang="0">
-                <a:pos x="connsiteX8" y="connsiteY8"/>
+                <a:pos x="csX8" y="csY8"/>
               </a:cxn>
               <a:cxn ang="0">
-                <a:pos x="connsiteX9" y="connsiteY9"/>
+                <a:pos x="csX9" y="csY9"/>
               </a:cxn>
               <a:cxn ang="0">
-                <a:pos x="connsiteX10" y="connsiteY10"/>
+                <a:pos x="csX10" y="csY10"/>
               </a:cxn>
               <a:cxn ang="0">
-                <a:pos x="connsiteX11" y="connsiteY11"/>
+                <a:pos x="csX11" y="csY11"/>
               </a:cxn>
               <a:cxn ang="0">
-                <a:pos x="connsiteX12" y="connsiteY12"/>
+                <a:pos x="csX12" y="csY12"/>
               </a:cxn>
               <a:cxn ang="0">
-                <a:pos x="connsiteX13" y="connsiteY13"/>
+                <a:pos x="csX13" y="csY13"/>
               </a:cxn>
               <a:cxn ang="0">
-                <a:pos x="connsiteX14" y="connsiteY14"/>
+                <a:pos x="csX14" y="csY14"/>
               </a:cxn>
               <a:cxn ang="0">
-                <a:pos x="connsiteX15" y="connsiteY15"/>
+                <a:pos x="csX15" y="csY15"/>
               </a:cxn>
               <a:cxn ang="0">
-                <a:pos x="connsiteX16" y="connsiteY16"/>
+                <a:pos x="csX16" y="csY16"/>
               </a:cxn>
             </a:cxnLst>
             <a:rect l="l" t="t" r="r" b="b"/>
@@ -4687,10 +4694,10 @@
           <p:nvPr/>
         </p:nvPicPr>
         <p:blipFill>
-          <a:blip r:embed="rId2">
+          <a:blip>
             <a:extLst>
               <a:ext uri="{96DAC541-7B7A-43D3-8B79-37D633B846F1}">
-                <asvg:svgBlip xmlns:asvg="http://schemas.microsoft.com/office/drawing/2016/SVG/main" r:embed="rId3"/>
+                <asvg:svgBlip xmlns:asvg="http://schemas.microsoft.com/office/drawing/2016/SVG/main" r:embed="rId2"/>
               </a:ext>
             </a:extLst>
           </a:blip>
@@ -5356,8 +5363,8 @@
         </p:nvSpPr>
         <p:spPr>
           <a:xfrm>
-            <a:off x="4290217" y="489509"/>
-            <a:ext cx="5754896" cy="833784"/>
+            <a:off x="750643" y="489509"/>
+            <a:ext cx="10690713" cy="833784"/>
           </a:xfrm>
         </p:spPr>
         <p:txBody>
@@ -5368,7 +5375,7 @@
           <a:p>
             <a:r>
               <a:rPr lang="en-US" sz="4000" dirty="0"/>
-              <a:t>What is Git?</a:t>
+              <a:t>What are Git and GitHub?</a:t>
             </a:r>
           </a:p>
         </p:txBody>
@@ -5388,10 +5395,10 @@
           <p:nvPr/>
         </p:nvPicPr>
         <p:blipFill>
-          <a:blip r:embed="rId2">
+          <a:blip>
             <a:extLst>
               <a:ext uri="{96DAC541-7B7A-43D3-8B79-37D633B846F1}">
-                <asvg:svgBlip xmlns:asvg="http://schemas.microsoft.com/office/drawing/2016/SVG/main" r:embed="rId3"/>
+                <asvg:svgBlip xmlns:asvg="http://schemas.microsoft.com/office/drawing/2016/SVG/main" r:embed="rId2"/>
               </a:ext>
             </a:extLst>
           </a:blip>
@@ -5401,8 +5408,8 @@
         </p:blipFill>
         <p:spPr>
           <a:xfrm>
-            <a:off x="750643" y="1323292"/>
-            <a:ext cx="2788930" cy="2788930"/>
+            <a:off x="750643" y="1681432"/>
+            <a:ext cx="1305608" cy="1305608"/>
           </a:xfrm>
           <a:prstGeom prst="rect">
             <a:avLst/>
@@ -5427,8 +5434,8 @@
         </p:nvSpPr>
         <p:spPr>
           <a:xfrm>
-            <a:off x="4290216" y="1412981"/>
-            <a:ext cx="5754896" cy="4955510"/>
+            <a:off x="2545081" y="1412981"/>
+            <a:ext cx="8896276" cy="4081039"/>
           </a:xfrm>
         </p:spPr>
         <p:txBody>
@@ -5437,40 +5444,256 @@
           </a:bodyPr>
           <a:lstStyle/>
           <a:p>
-            <a:r>
-              <a:rPr lang="en-US" dirty="0"/>
-              <a:t>A distributed version control system</a:t>
-            </a:r>
-          </a:p>
-          <a:p>
-            <a:r>
-              <a:rPr lang="en-US" dirty="0"/>
-              <a:t>Tracks the history of changes from multiple contributors</a:t>
-            </a:r>
-          </a:p>
-          <a:p>
-            <a:r>
-              <a:rPr lang="en-US" dirty="0"/>
-              <a:t>Any earlier version of the project can be recovered at any time</a:t>
-            </a:r>
-          </a:p>
-          <a:p>
-            <a:r>
-              <a:rPr lang="en-US" dirty="0"/>
-              <a:t>Each contributor has a full copy of the project and history</a:t>
-            </a:r>
-          </a:p>
-          <a:p>
-            <a:r>
-              <a:rPr lang="en-US" dirty="0"/>
-              <a:t>DVCSs don’t need a constant connection with a central repository</a:t>
-            </a:r>
-          </a:p>
-          <a:p>
-            <a:pPr marL="0" indent="0">
+            <a:pPr marL="0" indent="0" algn="l" rtl="0" eaLnBrk="1" latinLnBrk="0" hangingPunct="1">
+              <a:lnSpc>
+                <a:spcPct val="90000"/>
+              </a:lnSpc>
+              <a:spcBef>
+                <a:spcPts val="1000"/>
+              </a:spcBef>
               <a:buNone/>
             </a:pPr>
-            <a:endParaRPr lang="en-US" dirty="0"/>
+            <a:r>
+              <a:rPr lang="en-US" sz="1800" b="1" dirty="0">
+                <a:solidFill>
+                  <a:srgbClr val="000000"/>
+                </a:solidFill>
+                <a:effectLst/>
+                <a:latin typeface="Segoe UI" panose="020B0502040204020203" pitchFamily="34" charset="0"/>
+              </a:rPr>
+              <a:t>What is Git?</a:t>
+            </a:r>
+          </a:p>
+          <a:p>
+            <a:pPr marL="228600" indent="-228600" algn="l" rtl="0" eaLnBrk="1" latinLnBrk="0" hangingPunct="1">
+              <a:lnSpc>
+                <a:spcPct val="90000"/>
+              </a:lnSpc>
+              <a:spcBef>
+                <a:spcPts val="1000"/>
+              </a:spcBef>
+              <a:buFont typeface="Arial" panose="020B0604020202020204" pitchFamily="34" charset="0"/>
+              <a:buChar char="•"/>
+            </a:pPr>
+            <a:r>
+              <a:rPr lang="en-US" sz="1800" dirty="0">
+                <a:solidFill>
+                  <a:srgbClr val="000000"/>
+                </a:solidFill>
+                <a:effectLst/>
+                <a:latin typeface="Segoe UI" panose="020B0502040204020203" pitchFamily="34" charset="0"/>
+              </a:rPr>
+              <a:t>A distributed version control system tracking changes from multiple contributors</a:t>
+            </a:r>
+          </a:p>
+          <a:p>
+            <a:pPr marL="228600" indent="-228600" algn="l" rtl="0" eaLnBrk="1" latinLnBrk="0" hangingPunct="1">
+              <a:lnSpc>
+                <a:spcPct val="90000"/>
+              </a:lnSpc>
+              <a:spcBef>
+                <a:spcPts val="1000"/>
+              </a:spcBef>
+              <a:buFont typeface="Arial" panose="020B0604020202020204" pitchFamily="34" charset="0"/>
+              <a:buChar char="•"/>
+            </a:pPr>
+            <a:r>
+              <a:rPr lang="en-US" sz="1800" dirty="0">
+                <a:solidFill>
+                  <a:srgbClr val="000000"/>
+                </a:solidFill>
+                <a:effectLst/>
+                <a:latin typeface="Segoe UI" panose="020B0502040204020203" pitchFamily="34" charset="0"/>
+              </a:rPr>
+              <a:t>Allows recovery of any previous version</a:t>
+            </a:r>
+          </a:p>
+          <a:p>
+            <a:pPr marL="228600" indent="-228600" algn="l" rtl="0" eaLnBrk="1" latinLnBrk="0" hangingPunct="1">
+              <a:lnSpc>
+                <a:spcPct val="90000"/>
+              </a:lnSpc>
+              <a:spcBef>
+                <a:spcPts val="1000"/>
+              </a:spcBef>
+              <a:buFont typeface="Arial" panose="020B0604020202020204" pitchFamily="34" charset="0"/>
+              <a:buChar char="•"/>
+            </a:pPr>
+            <a:r>
+              <a:rPr lang="en-US" sz="1800" dirty="0">
+                <a:solidFill>
+                  <a:srgbClr val="000000"/>
+                </a:solidFill>
+                <a:effectLst/>
+                <a:latin typeface="Segoe UI" panose="020B0502040204020203" pitchFamily="34" charset="0"/>
+              </a:rPr>
+              <a:t>Each contributor has a full project copy and history</a:t>
+            </a:r>
+          </a:p>
+          <a:p>
+            <a:pPr marL="228600" indent="-228600" algn="l" rtl="0" eaLnBrk="1" latinLnBrk="0" hangingPunct="1">
+              <a:lnSpc>
+                <a:spcPct val="90000"/>
+              </a:lnSpc>
+              <a:spcBef>
+                <a:spcPts val="1000"/>
+              </a:spcBef>
+              <a:buFont typeface="Arial" panose="020B0604020202020204" pitchFamily="34" charset="0"/>
+              <a:buChar char="•"/>
+            </a:pPr>
+            <a:r>
+              <a:rPr lang="en-US" sz="1800" dirty="0">
+                <a:solidFill>
+                  <a:srgbClr val="000000"/>
+                </a:solidFill>
+                <a:effectLst/>
+                <a:latin typeface="Segoe UI" panose="020B0502040204020203" pitchFamily="34" charset="0"/>
+              </a:rPr>
+              <a:t>Does not require constant connection to a central repository</a:t>
+            </a:r>
+            <a:endParaRPr lang="en-US" sz="1800" b="1" dirty="0">
+              <a:solidFill>
+                <a:srgbClr val="000000"/>
+              </a:solidFill>
+              <a:effectLst/>
+              <a:latin typeface="Segoe UI" panose="020B0502040204020203" pitchFamily="34" charset="0"/>
+            </a:endParaRPr>
+          </a:p>
+          <a:p>
+            <a:pPr marL="0" indent="0" algn="l" rtl="0" eaLnBrk="1" latinLnBrk="0" hangingPunct="1">
+              <a:lnSpc>
+                <a:spcPct val="90000"/>
+              </a:lnSpc>
+              <a:spcBef>
+                <a:spcPts val="1000"/>
+              </a:spcBef>
+              <a:buNone/>
+            </a:pPr>
+            <a:r>
+              <a:rPr lang="en-US" sz="1800" b="1" dirty="0">
+                <a:solidFill>
+                  <a:srgbClr val="000000"/>
+                </a:solidFill>
+                <a:effectLst/>
+                <a:latin typeface="Segoe UI" panose="020B0502040204020203" pitchFamily="34" charset="0"/>
+              </a:rPr>
+              <a:t>What is GitHub?</a:t>
+            </a:r>
+          </a:p>
+          <a:p>
+            <a:pPr marL="228600" indent="-228600" algn="l" rtl="0" eaLnBrk="1" latinLnBrk="0" hangingPunct="1">
+              <a:lnSpc>
+                <a:spcPct val="90000"/>
+              </a:lnSpc>
+              <a:spcBef>
+                <a:spcPts val="1000"/>
+              </a:spcBef>
+              <a:buFont typeface="Arial" panose="020B0604020202020204" pitchFamily="34" charset="0"/>
+              <a:buChar char="•"/>
+            </a:pPr>
+            <a:r>
+              <a:rPr lang="en-US" sz="1800" dirty="0">
+                <a:solidFill>
+                  <a:srgbClr val="000000"/>
+                </a:solidFill>
+                <a:effectLst/>
+                <a:latin typeface="Segoe UI" panose="020B0502040204020203" pitchFamily="34" charset="0"/>
+              </a:rPr>
+              <a:t>Cloud hosting for Git repositories</a:t>
+            </a:r>
+          </a:p>
+          <a:p>
+            <a:pPr marL="228600" indent="-228600" algn="l" rtl="0" eaLnBrk="1" latinLnBrk="0" hangingPunct="1">
+              <a:lnSpc>
+                <a:spcPct val="90000"/>
+              </a:lnSpc>
+              <a:spcBef>
+                <a:spcPts val="1000"/>
+              </a:spcBef>
+              <a:buFont typeface="Arial" panose="020B0604020202020204" pitchFamily="34" charset="0"/>
+              <a:buChar char="•"/>
+            </a:pPr>
+            <a:r>
+              <a:rPr lang="en-US" sz="1800" dirty="0">
+                <a:solidFill>
+                  <a:srgbClr val="000000"/>
+                </a:solidFill>
+                <a:effectLst/>
+                <a:latin typeface="Segoe UI" panose="020B0502040204020203" pitchFamily="34" charset="0"/>
+              </a:rPr>
+              <a:t>Web interface for browsing repositories</a:t>
+            </a:r>
+          </a:p>
+          <a:p>
+            <a:pPr marL="228600" indent="-228600" algn="l" rtl="0" eaLnBrk="1" latinLnBrk="0" hangingPunct="1">
+              <a:lnSpc>
+                <a:spcPct val="90000"/>
+              </a:lnSpc>
+              <a:spcBef>
+                <a:spcPts val="1000"/>
+              </a:spcBef>
+              <a:buFont typeface="Arial" panose="020B0604020202020204" pitchFamily="34" charset="0"/>
+              <a:buChar char="•"/>
+            </a:pPr>
+            <a:r>
+              <a:rPr lang="en-US" sz="1800" dirty="0">
+                <a:solidFill>
+                  <a:srgbClr val="000000"/>
+                </a:solidFill>
+                <a:effectLst/>
+                <a:latin typeface="Segoe UI" panose="020B0502040204020203" pitchFamily="34" charset="0"/>
+              </a:rPr>
+              <a:t>Supports collaboration via pull requests and code reviews</a:t>
+            </a:r>
+          </a:p>
+          <a:p>
+            <a:pPr marL="228600" indent="-228600" algn="l" rtl="0" eaLnBrk="1" latinLnBrk="0" hangingPunct="1">
+              <a:lnSpc>
+                <a:spcPct val="90000"/>
+              </a:lnSpc>
+              <a:spcBef>
+                <a:spcPts val="1000"/>
+              </a:spcBef>
+              <a:buFont typeface="Arial" panose="020B0604020202020204" pitchFamily="34" charset="0"/>
+              <a:buChar char="•"/>
+            </a:pPr>
+            <a:r>
+              <a:rPr lang="en-US" sz="1800" dirty="0">
+                <a:solidFill>
+                  <a:srgbClr val="000000"/>
+                </a:solidFill>
+                <a:effectLst/>
+                <a:latin typeface="Segoe UI" panose="020B0502040204020203" pitchFamily="34" charset="0"/>
+              </a:rPr>
+              <a:t>Includes issue tracking and project management</a:t>
+            </a:r>
+          </a:p>
+          <a:p>
+            <a:pPr marL="228600" indent="-228600" algn="l" rtl="0" eaLnBrk="1" latinLnBrk="0" hangingPunct="1">
+              <a:lnSpc>
+                <a:spcPct val="90000"/>
+              </a:lnSpc>
+              <a:spcBef>
+                <a:spcPts val="1000"/>
+              </a:spcBef>
+              <a:buFont typeface="Arial" panose="020B0604020202020204" pitchFamily="34" charset="0"/>
+              <a:buChar char="•"/>
+            </a:pPr>
+            <a:r>
+              <a:rPr lang="en-US" sz="1800" dirty="0">
+                <a:solidFill>
+                  <a:srgbClr val="000000"/>
+                </a:solidFill>
+                <a:effectLst/>
+                <a:latin typeface="Segoe UI" panose="020B0502040204020203" pitchFamily="34" charset="0"/>
+              </a:rPr>
+              <a:t>Manages team workflows with permissions and access controls</a:t>
+            </a:r>
+            <a:endParaRPr lang="en-US" sz="1800" i="0" dirty="0">
+              <a:effectLst/>
+              <a:latin typeface="Segoe UI" panose="020B0502040204020203" pitchFamily="34" charset="0"/>
+              <a:cs typeface="Segoe UI" panose="020B0502040204020203" pitchFamily="34" charset="0"/>
+            </a:endParaRPr>
           </a:p>
         </p:txBody>
       </p:sp>
@@ -5620,6 +5843,42 @@
           </a:p>
         </p:txBody>
       </p:sp>
+      <p:pic>
+        <p:nvPicPr>
+          <p:cNvPr id="8" name="Graphic 7">
+            <a:extLst>
+              <a:ext uri="{FF2B5EF4-FFF2-40B4-BE49-F238E27FC236}">
+                <a16:creationId xmlns:a16="http://schemas.microsoft.com/office/drawing/2014/main" id="{D6EB0829-5269-4FF7-F9B0-E14EEE23708D}"/>
+              </a:ext>
+            </a:extLst>
+          </p:cNvPr>
+          <p:cNvPicPr>
+            <a:picLocks noChangeAspect="1"/>
+          </p:cNvPicPr>
+          <p:nvPr/>
+        </p:nvPicPr>
+        <p:blipFill>
+          <a:blip>
+            <a:extLst>
+              <a:ext uri="{96DAC541-7B7A-43D3-8B79-37D633B846F1}">
+                <asvg:svgBlip xmlns:asvg="http://schemas.microsoft.com/office/drawing/2016/SVG/main" r:embed="rId3"/>
+              </a:ext>
+            </a:extLst>
+          </a:blip>
+          <a:stretch>
+            <a:fillRect/>
+          </a:stretch>
+        </p:blipFill>
+        <p:spPr>
+          <a:xfrm>
+            <a:off x="750643" y="3648075"/>
+            <a:ext cx="1307592" cy="1307592"/>
+          </a:xfrm>
+          <a:prstGeom prst="rect">
+            <a:avLst/>
+          </a:prstGeom>
+        </p:spPr>
+      </p:pic>
     </p:spTree>
     <p:extLst>
       <p:ext uri="{BB962C8B-B14F-4D97-AF65-F5344CB8AC3E}">
@@ -6199,7 +6458,7 @@
         <p:spPr>
           <a:xfrm>
             <a:off x="630936" y="640823"/>
-            <a:ext cx="3419856" cy="5583148"/>
+            <a:ext cx="3419856" cy="2267915"/>
           </a:xfrm>
         </p:spPr>
         <p:txBody>
@@ -6209,7 +6468,7 @@
           <a:lstStyle/>
           <a:p>
             <a:r>
-              <a:rPr lang="en-US" sz="5400"/>
+              <a:rPr lang="en-US" sz="5400" dirty="0"/>
               <a:t>Git’s Three States</a:t>
             </a:r>
           </a:p>
@@ -6246,108 +6505,108 @@
           <a:custGeom>
             <a:avLst/>
             <a:gdLst>
-              <a:gd name="connsiteX0" fmla="*/ 0 w 18288"/>
-              <a:gd name="connsiteY0" fmla="*/ 0 h 5590381"/>
-              <a:gd name="connsiteX1" fmla="*/ 18288 w 18288"/>
-              <a:gd name="connsiteY1" fmla="*/ 0 h 5590381"/>
-              <a:gd name="connsiteX2" fmla="*/ 18288 w 18288"/>
-              <a:gd name="connsiteY2" fmla="*/ 754701 h 5590381"/>
-              <a:gd name="connsiteX3" fmla="*/ 18288 w 18288"/>
-              <a:gd name="connsiteY3" fmla="*/ 1565307 h 5590381"/>
-              <a:gd name="connsiteX4" fmla="*/ 18288 w 18288"/>
-              <a:gd name="connsiteY4" fmla="*/ 2152297 h 5590381"/>
-              <a:gd name="connsiteX5" fmla="*/ 18288 w 18288"/>
-              <a:gd name="connsiteY5" fmla="*/ 2906998 h 5590381"/>
-              <a:gd name="connsiteX6" fmla="*/ 18288 w 18288"/>
-              <a:gd name="connsiteY6" fmla="*/ 3549892 h 5590381"/>
-              <a:gd name="connsiteX7" fmla="*/ 18288 w 18288"/>
-              <a:gd name="connsiteY7" fmla="*/ 4080978 h 5590381"/>
-              <a:gd name="connsiteX8" fmla="*/ 18288 w 18288"/>
-              <a:gd name="connsiteY8" fmla="*/ 4835680 h 5590381"/>
-              <a:gd name="connsiteX9" fmla="*/ 18288 w 18288"/>
-              <a:gd name="connsiteY9" fmla="*/ 5590381 h 5590381"/>
-              <a:gd name="connsiteX10" fmla="*/ 0 w 18288"/>
-              <a:gd name="connsiteY10" fmla="*/ 5590381 h 5590381"/>
-              <a:gd name="connsiteX11" fmla="*/ 0 w 18288"/>
-              <a:gd name="connsiteY11" fmla="*/ 4835680 h 5590381"/>
-              <a:gd name="connsiteX12" fmla="*/ 0 w 18288"/>
-              <a:gd name="connsiteY12" fmla="*/ 4304593 h 5590381"/>
-              <a:gd name="connsiteX13" fmla="*/ 0 w 18288"/>
-              <a:gd name="connsiteY13" fmla="*/ 3773507 h 5590381"/>
-              <a:gd name="connsiteX14" fmla="*/ 0 w 18288"/>
-              <a:gd name="connsiteY14" fmla="*/ 3186517 h 5590381"/>
-              <a:gd name="connsiteX15" fmla="*/ 0 w 18288"/>
-              <a:gd name="connsiteY15" fmla="*/ 2487720 h 5590381"/>
-              <a:gd name="connsiteX16" fmla="*/ 0 w 18288"/>
-              <a:gd name="connsiteY16" fmla="*/ 1956633 h 5590381"/>
-              <a:gd name="connsiteX17" fmla="*/ 0 w 18288"/>
-              <a:gd name="connsiteY17" fmla="*/ 1425547 h 5590381"/>
-              <a:gd name="connsiteX18" fmla="*/ 0 w 18288"/>
-              <a:gd name="connsiteY18" fmla="*/ 614942 h 5590381"/>
-              <a:gd name="connsiteX19" fmla="*/ 0 w 18288"/>
-              <a:gd name="connsiteY19" fmla="*/ 0 h 5590381"/>
+              <a:gd name="csX0" fmla="*/ 0 w 18288"/>
+              <a:gd name="csY0" fmla="*/ 0 h 5590381"/>
+              <a:gd name="csX1" fmla="*/ 18288 w 18288"/>
+              <a:gd name="csY1" fmla="*/ 0 h 5590381"/>
+              <a:gd name="csX2" fmla="*/ 18288 w 18288"/>
+              <a:gd name="csY2" fmla="*/ 754701 h 5590381"/>
+              <a:gd name="csX3" fmla="*/ 18288 w 18288"/>
+              <a:gd name="csY3" fmla="*/ 1565307 h 5590381"/>
+              <a:gd name="csX4" fmla="*/ 18288 w 18288"/>
+              <a:gd name="csY4" fmla="*/ 2152297 h 5590381"/>
+              <a:gd name="csX5" fmla="*/ 18288 w 18288"/>
+              <a:gd name="csY5" fmla="*/ 2906998 h 5590381"/>
+              <a:gd name="csX6" fmla="*/ 18288 w 18288"/>
+              <a:gd name="csY6" fmla="*/ 3549892 h 5590381"/>
+              <a:gd name="csX7" fmla="*/ 18288 w 18288"/>
+              <a:gd name="csY7" fmla="*/ 4080978 h 5590381"/>
+              <a:gd name="csX8" fmla="*/ 18288 w 18288"/>
+              <a:gd name="csY8" fmla="*/ 4835680 h 5590381"/>
+              <a:gd name="csX9" fmla="*/ 18288 w 18288"/>
+              <a:gd name="csY9" fmla="*/ 5590381 h 5590381"/>
+              <a:gd name="csX10" fmla="*/ 0 w 18288"/>
+              <a:gd name="csY10" fmla="*/ 5590381 h 5590381"/>
+              <a:gd name="csX11" fmla="*/ 0 w 18288"/>
+              <a:gd name="csY11" fmla="*/ 4835680 h 5590381"/>
+              <a:gd name="csX12" fmla="*/ 0 w 18288"/>
+              <a:gd name="csY12" fmla="*/ 4304593 h 5590381"/>
+              <a:gd name="csX13" fmla="*/ 0 w 18288"/>
+              <a:gd name="csY13" fmla="*/ 3773507 h 5590381"/>
+              <a:gd name="csX14" fmla="*/ 0 w 18288"/>
+              <a:gd name="csY14" fmla="*/ 3186517 h 5590381"/>
+              <a:gd name="csX15" fmla="*/ 0 w 18288"/>
+              <a:gd name="csY15" fmla="*/ 2487720 h 5590381"/>
+              <a:gd name="csX16" fmla="*/ 0 w 18288"/>
+              <a:gd name="csY16" fmla="*/ 1956633 h 5590381"/>
+              <a:gd name="csX17" fmla="*/ 0 w 18288"/>
+              <a:gd name="csY17" fmla="*/ 1425547 h 5590381"/>
+              <a:gd name="csX18" fmla="*/ 0 w 18288"/>
+              <a:gd name="csY18" fmla="*/ 614942 h 5590381"/>
+              <a:gd name="csX19" fmla="*/ 0 w 18288"/>
+              <a:gd name="csY19" fmla="*/ 0 h 5590381"/>
             </a:gdLst>
             <a:ahLst/>
             <a:cxnLst>
               <a:cxn ang="0">
-                <a:pos x="connsiteX0" y="connsiteY0"/>
+                <a:pos x="csX0" y="csY0"/>
               </a:cxn>
               <a:cxn ang="0">
-                <a:pos x="connsiteX1" y="connsiteY1"/>
+                <a:pos x="csX1" y="csY1"/>
               </a:cxn>
               <a:cxn ang="0">
-                <a:pos x="connsiteX2" y="connsiteY2"/>
+                <a:pos x="csX2" y="csY2"/>
               </a:cxn>
               <a:cxn ang="0">
-                <a:pos x="connsiteX3" y="connsiteY3"/>
+                <a:pos x="csX3" y="csY3"/>
               </a:cxn>
               <a:cxn ang="0">
-                <a:pos x="connsiteX4" y="connsiteY4"/>
+                <a:pos x="csX4" y="csY4"/>
               </a:cxn>
               <a:cxn ang="0">
-                <a:pos x="connsiteX5" y="connsiteY5"/>
+                <a:pos x="csX5" y="csY5"/>
               </a:cxn>
               <a:cxn ang="0">
-                <a:pos x="connsiteX6" y="connsiteY6"/>
+                <a:pos x="csX6" y="csY6"/>
               </a:cxn>
               <a:cxn ang="0">
-                <a:pos x="connsiteX7" y="connsiteY7"/>
+                <a:pos x="csX7" y="csY7"/>
               </a:cxn>
               <a:cxn ang="0">
-                <a:pos x="connsiteX8" y="connsiteY8"/>
+                <a:pos x="csX8" y="csY8"/>
               </a:cxn>
               <a:cxn ang="0">
-                <a:pos x="connsiteX9" y="connsiteY9"/>
+                <a:pos x="csX9" y="csY9"/>
               </a:cxn>
               <a:cxn ang="0">
-                <a:pos x="connsiteX10" y="connsiteY10"/>
+                <a:pos x="csX10" y="csY10"/>
               </a:cxn>
               <a:cxn ang="0">
-                <a:pos x="connsiteX11" y="connsiteY11"/>
+                <a:pos x="csX11" y="csY11"/>
               </a:cxn>
               <a:cxn ang="0">
-                <a:pos x="connsiteX12" y="connsiteY12"/>
+                <a:pos x="csX12" y="csY12"/>
               </a:cxn>
               <a:cxn ang="0">
-                <a:pos x="connsiteX13" y="connsiteY13"/>
+                <a:pos x="csX13" y="csY13"/>
               </a:cxn>
               <a:cxn ang="0">
-                <a:pos x="connsiteX14" y="connsiteY14"/>
+                <a:pos x="csX14" y="csY14"/>
               </a:cxn>
               <a:cxn ang="0">
-                <a:pos x="connsiteX15" y="connsiteY15"/>
+                <a:pos x="csX15" y="csY15"/>
               </a:cxn>
               <a:cxn ang="0">
-                <a:pos x="connsiteX16" y="connsiteY16"/>
+                <a:pos x="csX16" y="csY16"/>
               </a:cxn>
               <a:cxn ang="0">
-                <a:pos x="connsiteX17" y="connsiteY17"/>
+                <a:pos x="csX17" y="csY17"/>
               </a:cxn>
               <a:cxn ang="0">
-                <a:pos x="connsiteX18" y="connsiteY18"/>
+                <a:pos x="csX18" y="csY18"/>
               </a:cxn>
               <a:cxn ang="0">
-                <a:pos x="connsiteX19" y="connsiteY19"/>
+                <a:pos x="csX19" y="csY19"/>
               </a:cxn>
             </a:cxnLst>
             <a:rect l="l" t="t" r="r" b="b"/>
@@ -6593,96 +6852,950 @@
           </a:p>
         </p:txBody>
       </p:sp>
-      <p:pic>
-        <p:nvPicPr>
-          <p:cNvPr id="1026" name="Picture 2" descr="Working tree, staging area, and Git directory">
-            <a:extLst>
-              <a:ext uri="{FF2B5EF4-FFF2-40B4-BE49-F238E27FC236}">
-                <a16:creationId xmlns:a16="http://schemas.microsoft.com/office/drawing/2014/main" id="{C9C3EF32-D632-47BE-E70F-2FE956200684}"/>
-              </a:ext>
-            </a:extLst>
-          </p:cNvPr>
-          <p:cNvPicPr>
-            <a:picLocks noChangeAspect="1" noChangeArrowheads="1"/>
-          </p:cNvPicPr>
+      <p:sp>
+        <p:nvSpPr>
+          <p:cNvPr id="6" name="lane_1">
+            <a:extLst>
+              <a:ext uri="{FF2B5EF4-FFF2-40B4-BE49-F238E27FC236}">
+                <a16:creationId xmlns:a16="http://schemas.microsoft.com/office/drawing/2014/main" id="{DF4A77A2-6834-4279-BA74-DC68E3CC4EBA}"/>
+              </a:ext>
+            </a:extLst>
+          </p:cNvPr>
+          <p:cNvSpPr/>
           <p:nvPr/>
-        </p:nvPicPr>
-        <p:blipFill>
-          <a:blip r:embed="rId3">
-            <a:extLst>
-              <a:ext uri="{28A0092B-C50C-407E-A947-70E740481C1C}">
-                <a14:useLocalDpi xmlns:a14="http://schemas.microsoft.com/office/drawing/2010/main" val="0"/>
-              </a:ext>
-            </a:extLst>
-          </a:blip>
-          <a:stretch>
-            <a:fillRect/>
-          </a:stretch>
-        </p:blipFill>
-        <p:spPr bwMode="auto">
+        </p:nvSpPr>
+        <p:spPr>
           <a:xfrm>
-            <a:off x="4654296" y="691744"/>
-            <a:ext cx="6894576" cy="3792015"/>
+            <a:off x="5841492" y="2303357"/>
+            <a:ext cx="25400" cy="2674365"/>
+          </a:xfrm>
+          <a:prstGeom prst="rect">
+            <a:avLst/>
+          </a:prstGeom>
+          <a:solidFill>
+            <a:srgbClr val="BDBDBD"/>
+          </a:solidFill>
+          <a:ln w="0" cap="flat" cmpd="sng" algn="ctr">
+            <a:solidFill>
+              <a:srgbClr val="156082">
+                <a:shade val="15000"/>
+              </a:srgbClr>
+            </a:solidFill>
+            <a:prstDash val="solid"/>
+            <a:miter lim="800000"/>
+          </a:ln>
+        </p:spPr>
+        <p:style>
+          <a:lnRef idx="2">
+            <a:schemeClr val="accent1">
+              <a:shade val="15000"/>
+            </a:schemeClr>
+          </a:lnRef>
+          <a:fillRef idx="1">
+            <a:schemeClr val="accent1"/>
+          </a:fillRef>
+          <a:effectRef idx="0">
+            <a:schemeClr val="accent1"/>
+          </a:effectRef>
+          <a:fontRef idx="minor">
+            <a:schemeClr val="lt1"/>
+          </a:fontRef>
+        </p:style>
+        <p:txBody>
+          <a:bodyPr vertOverflow="clip" horzOverflow="clip" rtlCol="0" anchor="t"/>
+          <a:lstStyle/>
+          <a:p>
+            <a:pPr algn="l"/>
+            <a:endParaRPr lang="en-US"/>
+          </a:p>
+        </p:txBody>
+      </p:sp>
+      <p:sp>
+        <p:nvSpPr>
+          <p:cNvPr id="7" name="lane_2">
+            <a:extLst>
+              <a:ext uri="{FF2B5EF4-FFF2-40B4-BE49-F238E27FC236}">
+                <a16:creationId xmlns:a16="http://schemas.microsoft.com/office/drawing/2014/main" id="{8E6EF5BD-F257-49D9-B92B-C146994F5EC9}"/>
+              </a:ext>
+            </a:extLst>
+          </p:cNvPr>
+          <p:cNvSpPr/>
+          <p:nvPr/>
+        </p:nvSpPr>
+        <p:spPr>
+          <a:xfrm>
+            <a:off x="8088884" y="2303357"/>
+            <a:ext cx="25400" cy="2674365"/>
+          </a:xfrm>
+          <a:prstGeom prst="rect">
+            <a:avLst/>
+          </a:prstGeom>
+          <a:solidFill>
+            <a:srgbClr val="BDBDBD"/>
+          </a:solidFill>
+          <a:ln w="0" cap="flat" cmpd="sng" algn="ctr">
+            <a:solidFill>
+              <a:srgbClr val="156082">
+                <a:shade val="15000"/>
+              </a:srgbClr>
+            </a:solidFill>
+            <a:prstDash val="solid"/>
+            <a:miter lim="800000"/>
+          </a:ln>
+        </p:spPr>
+        <p:style>
+          <a:lnRef idx="2">
+            <a:schemeClr val="accent1">
+              <a:shade val="15000"/>
+            </a:schemeClr>
+          </a:lnRef>
+          <a:fillRef idx="1">
+            <a:schemeClr val="accent1"/>
+          </a:fillRef>
+          <a:effectRef idx="0">
+            <a:schemeClr val="accent1"/>
+          </a:effectRef>
+          <a:fontRef idx="minor">
+            <a:schemeClr val="lt1"/>
+          </a:fontRef>
+        </p:style>
+        <p:txBody>
+          <a:bodyPr vertOverflow="clip" horzOverflow="clip" rtlCol="0" anchor="t"/>
+          <a:lstStyle/>
+          <a:p>
+            <a:pPr algn="l"/>
+            <a:endParaRPr lang="en-US"/>
+          </a:p>
+        </p:txBody>
+      </p:sp>
+      <p:sp>
+        <p:nvSpPr>
+          <p:cNvPr id="8" name="lane_3">
+            <a:extLst>
+              <a:ext uri="{FF2B5EF4-FFF2-40B4-BE49-F238E27FC236}">
+                <a16:creationId xmlns:a16="http://schemas.microsoft.com/office/drawing/2014/main" id="{31BCFF78-46C4-48EA-8E2B-6FEB865CADD8}"/>
+              </a:ext>
+            </a:extLst>
+          </p:cNvPr>
+          <p:cNvSpPr/>
+          <p:nvPr/>
+        </p:nvSpPr>
+        <p:spPr>
+          <a:xfrm>
+            <a:off x="10336276" y="2303357"/>
+            <a:ext cx="25400" cy="2674365"/>
+          </a:xfrm>
+          <a:prstGeom prst="rect">
+            <a:avLst/>
+          </a:prstGeom>
+          <a:solidFill>
+            <a:srgbClr val="BDBDBD"/>
+          </a:solidFill>
+          <a:ln w="0" cap="flat" cmpd="sng" algn="ctr">
+            <a:solidFill>
+              <a:srgbClr val="156082">
+                <a:shade val="15000"/>
+              </a:srgbClr>
+            </a:solidFill>
+            <a:prstDash val="solid"/>
+            <a:miter lim="800000"/>
+          </a:ln>
+        </p:spPr>
+        <p:style>
+          <a:lnRef idx="2">
+            <a:schemeClr val="accent1">
+              <a:shade val="15000"/>
+            </a:schemeClr>
+          </a:lnRef>
+          <a:fillRef idx="1">
+            <a:schemeClr val="accent1"/>
+          </a:fillRef>
+          <a:effectRef idx="0">
+            <a:schemeClr val="accent1"/>
+          </a:effectRef>
+          <a:fontRef idx="minor">
+            <a:schemeClr val="lt1"/>
+          </a:fontRef>
+        </p:style>
+        <p:txBody>
+          <a:bodyPr vertOverflow="clip" horzOverflow="clip" rtlCol="0" anchor="t"/>
+          <a:lstStyle/>
+          <a:p>
+            <a:pPr algn="l"/>
+            <a:endParaRPr lang="en-US"/>
+          </a:p>
+        </p:txBody>
+      </p:sp>
+      <p:sp>
+        <p:nvSpPr>
+          <p:cNvPr id="9" name="arrow_checkout">
+            <a:extLst>
+              <a:ext uri="{FF2B5EF4-FFF2-40B4-BE49-F238E27FC236}">
+                <a16:creationId xmlns:a16="http://schemas.microsoft.com/office/drawing/2014/main" id="{5A4C302C-47AF-4BF5-B685-B328D4756641}"/>
+              </a:ext>
+            </a:extLst>
+          </p:cNvPr>
+          <p:cNvSpPr/>
+          <p:nvPr/>
+        </p:nvSpPr>
+        <p:spPr>
+          <a:xfrm>
+            <a:off x="5841492" y="2430357"/>
+            <a:ext cx="4494784" cy="558800"/>
+          </a:xfrm>
+          <a:prstGeom prst="leftArrow">
+            <a:avLst/>
+          </a:prstGeom>
+          <a:solidFill>
+            <a:srgbClr val="8A8A8A"/>
+          </a:solidFill>
+          <a:ln w="0" cap="flat" cmpd="sng" algn="ctr">
+            <a:solidFill>
+              <a:srgbClr val="156082">
+                <a:shade val="15000"/>
+              </a:srgbClr>
+            </a:solidFill>
+            <a:prstDash val="solid"/>
+            <a:miter lim="800000"/>
+          </a:ln>
+        </p:spPr>
+        <p:style>
+          <a:lnRef idx="2">
+            <a:schemeClr val="accent1">
+              <a:shade val="15000"/>
+            </a:schemeClr>
+          </a:lnRef>
+          <a:fillRef idx="1">
+            <a:schemeClr val="accent1"/>
+          </a:fillRef>
+          <a:effectRef idx="0">
+            <a:schemeClr val="accent1"/>
+          </a:effectRef>
+          <a:fontRef idx="minor">
+            <a:schemeClr val="lt1"/>
+          </a:fontRef>
+        </p:style>
+        <p:txBody>
+          <a:bodyPr vertOverflow="clip" horzOverflow="clip" rtlCol="0" anchor="ctr" anchorCtr="0"/>
+          <a:lstStyle/>
+          <a:p>
+            <a:pPr algn="ctr"/>
+            <a:r>
+              <a:rPr lang="en-US" sz="1300" b="1">
+                <a:solidFill>
+                  <a:srgbClr val="FFFFFF"/>
+                </a:solidFill>
+              </a:rPr>
+              <a:t>Checkout the project</a:t>
+            </a:r>
+          </a:p>
+        </p:txBody>
+      </p:sp>
+      <p:sp>
+        <p:nvSpPr>
+          <p:cNvPr id="10" name="arrow_stage_fixes">
+            <a:extLst>
+              <a:ext uri="{FF2B5EF4-FFF2-40B4-BE49-F238E27FC236}">
+                <a16:creationId xmlns:a16="http://schemas.microsoft.com/office/drawing/2014/main" id="{B6697D44-14F7-4EAE-B2D8-05987AC06EF8}"/>
+              </a:ext>
+            </a:extLst>
+          </p:cNvPr>
+          <p:cNvSpPr/>
+          <p:nvPr/>
+        </p:nvSpPr>
+        <p:spPr>
+          <a:xfrm>
+            <a:off x="5841492" y="3420957"/>
+            <a:ext cx="2247900" cy="558800"/>
+          </a:xfrm>
+          <a:prstGeom prst="rightArrow">
+            <a:avLst/>
+          </a:prstGeom>
+          <a:solidFill>
+            <a:srgbClr val="8A8A8A"/>
+          </a:solidFill>
+          <a:ln w="0" cap="flat" cmpd="sng" algn="ctr">
+            <a:solidFill>
+              <a:srgbClr val="156082">
+                <a:shade val="15000"/>
+              </a:srgbClr>
+            </a:solidFill>
+            <a:prstDash val="solid"/>
+            <a:miter lim="800000"/>
+          </a:ln>
+        </p:spPr>
+        <p:style>
+          <a:lnRef idx="2">
+            <a:schemeClr val="accent1">
+              <a:shade val="15000"/>
+            </a:schemeClr>
+          </a:lnRef>
+          <a:fillRef idx="1">
+            <a:schemeClr val="accent1"/>
+          </a:fillRef>
+          <a:effectRef idx="0">
+            <a:schemeClr val="accent1"/>
+          </a:effectRef>
+          <a:fontRef idx="minor">
+            <a:schemeClr val="lt1"/>
+          </a:fontRef>
+        </p:style>
+        <p:txBody>
+          <a:bodyPr vertOverflow="clip" horzOverflow="clip" rtlCol="0" anchor="ctr" anchorCtr="0"/>
+          <a:lstStyle/>
+          <a:p>
+            <a:pPr algn="ctr"/>
+            <a:r>
+              <a:rPr lang="en-US" sz="1300" b="1">
+                <a:solidFill>
+                  <a:srgbClr val="FFFFFF"/>
+                </a:solidFill>
+              </a:rPr>
+              <a:t>Stage Fixes</a:t>
+            </a:r>
+          </a:p>
+        </p:txBody>
+      </p:sp>
+      <p:sp>
+        <p:nvSpPr>
+          <p:cNvPr id="11" name="arrow_commit">
+            <a:extLst>
+              <a:ext uri="{FF2B5EF4-FFF2-40B4-BE49-F238E27FC236}">
+                <a16:creationId xmlns:a16="http://schemas.microsoft.com/office/drawing/2014/main" id="{8444A4DA-5372-497F-8032-FB0C121B097A}"/>
+              </a:ext>
+            </a:extLst>
+          </p:cNvPr>
+          <p:cNvSpPr/>
+          <p:nvPr/>
+        </p:nvSpPr>
+        <p:spPr>
+          <a:xfrm>
+            <a:off x="8088883" y="4411557"/>
+            <a:ext cx="2247900" cy="558800"/>
+          </a:xfrm>
+          <a:prstGeom prst="rightArrow">
+            <a:avLst/>
+          </a:prstGeom>
+          <a:solidFill>
+            <a:srgbClr val="8A8A8A"/>
+          </a:solidFill>
+          <a:ln w="0" cap="flat" cmpd="sng" algn="ctr">
+            <a:solidFill>
+              <a:srgbClr val="156082">
+                <a:shade val="15000"/>
+              </a:srgbClr>
+            </a:solidFill>
+            <a:prstDash val="solid"/>
+            <a:miter lim="800000"/>
+          </a:ln>
+        </p:spPr>
+        <p:style>
+          <a:lnRef idx="2">
+            <a:schemeClr val="accent1">
+              <a:shade val="15000"/>
+            </a:schemeClr>
+          </a:lnRef>
+          <a:fillRef idx="1">
+            <a:schemeClr val="accent1"/>
+          </a:fillRef>
+          <a:effectRef idx="0">
+            <a:schemeClr val="accent1"/>
+          </a:effectRef>
+          <a:fontRef idx="minor">
+            <a:schemeClr val="lt1"/>
+          </a:fontRef>
+        </p:style>
+        <p:txBody>
+          <a:bodyPr vertOverflow="clip" horzOverflow="clip" rtlCol="0" anchor="ctr" anchorCtr="0"/>
+          <a:lstStyle/>
+          <a:p>
+            <a:pPr algn="ctr"/>
+            <a:r>
+              <a:rPr lang="en-US" sz="1300" b="1">
+                <a:solidFill>
+                  <a:srgbClr val="FFFFFF"/>
+                </a:solidFill>
+              </a:rPr>
+              <a:t>Commit</a:t>
+            </a:r>
+          </a:p>
+        </p:txBody>
+      </p:sp>
+      <p:sp>
+        <p:nvSpPr>
+          <p:cNvPr id="3" name="hdr_working_directory">
+            <a:extLst>
+              <a:ext uri="{FF2B5EF4-FFF2-40B4-BE49-F238E27FC236}">
+                <a16:creationId xmlns:a16="http://schemas.microsoft.com/office/drawing/2014/main" id="{79FE6068-A3B4-469C-8325-062090273F60}"/>
+              </a:ext>
+            </a:extLst>
+          </p:cNvPr>
+          <p:cNvSpPr/>
+          <p:nvPr/>
+        </p:nvSpPr>
+        <p:spPr>
+          <a:xfrm>
+            <a:off x="4814579" y="1490557"/>
+            <a:ext cx="2094992" cy="685800"/>
+          </a:xfrm>
+          <a:prstGeom prst="rect">
+            <a:avLst/>
+          </a:prstGeom>
+          <a:solidFill>
+            <a:srgbClr val="4E95D9"/>
+          </a:solidFill>
+          <a:ln w="0" cap="flat" cmpd="sng" algn="ctr">
+            <a:solidFill>
+              <a:srgbClr val="156082">
+                <a:shade val="15000"/>
+              </a:srgbClr>
+            </a:solidFill>
+            <a:prstDash val="solid"/>
+            <a:miter lim="800000"/>
+          </a:ln>
+        </p:spPr>
+        <p:style>
+          <a:lnRef idx="2">
+            <a:schemeClr val="accent1">
+              <a:shade val="15000"/>
+            </a:schemeClr>
+          </a:lnRef>
+          <a:fillRef idx="1">
+            <a:schemeClr val="accent1"/>
+          </a:fillRef>
+          <a:effectRef idx="0">
+            <a:schemeClr val="accent1"/>
+          </a:effectRef>
+          <a:fontRef idx="minor">
+            <a:schemeClr val="lt1"/>
+          </a:fontRef>
+        </p:style>
+        <p:txBody>
+          <a:bodyPr vertOverflow="clip" horzOverflow="clip" rtlCol="0" anchor="ctr" anchorCtr="0"/>
+          <a:lstStyle/>
+          <a:p>
+            <a:pPr algn="ctr"/>
+            <a:r>
+              <a:rPr lang="en-US" sz="1400" b="1" dirty="0">
+                <a:solidFill>
+                  <a:srgbClr val="FFFFFF"/>
+                </a:solidFill>
+              </a:rPr>
+              <a:t>Working</a:t>
+            </a:r>
+          </a:p>
+          <a:p>
+            <a:pPr algn="ctr"/>
+            <a:r>
+              <a:rPr lang="en-US" sz="1400" b="1" dirty="0">
+                <a:solidFill>
+                  <a:srgbClr val="FFFFFF"/>
+                </a:solidFill>
+              </a:rPr>
+              <a:t>Directory</a:t>
+            </a:r>
+          </a:p>
+        </p:txBody>
+      </p:sp>
+      <p:sp>
+        <p:nvSpPr>
+          <p:cNvPr id="4" name="hdr_staging_area">
+            <a:extLst>
+              <a:ext uri="{FF2B5EF4-FFF2-40B4-BE49-F238E27FC236}">
+                <a16:creationId xmlns:a16="http://schemas.microsoft.com/office/drawing/2014/main" id="{9FE1E0A1-252A-433F-BCC7-9E60FFE1C72B}"/>
+              </a:ext>
+            </a:extLst>
+          </p:cNvPr>
+          <p:cNvSpPr/>
+          <p:nvPr/>
+        </p:nvSpPr>
+        <p:spPr>
+          <a:xfrm>
+            <a:off x="7054088" y="1490557"/>
+            <a:ext cx="2094992" cy="685800"/>
+          </a:xfrm>
+          <a:prstGeom prst="rect">
+            <a:avLst/>
+          </a:prstGeom>
+          <a:solidFill>
+            <a:srgbClr val="E96F2B"/>
+          </a:solidFill>
+          <a:ln w="0" cap="flat" cmpd="sng" algn="ctr">
+            <a:solidFill>
+              <a:srgbClr val="156082">
+                <a:shade val="15000"/>
+              </a:srgbClr>
+            </a:solidFill>
+            <a:prstDash val="solid"/>
+            <a:miter lim="800000"/>
+          </a:ln>
+        </p:spPr>
+        <p:style>
+          <a:lnRef idx="2">
+            <a:schemeClr val="accent1">
+              <a:shade val="15000"/>
+            </a:schemeClr>
+          </a:lnRef>
+          <a:fillRef idx="1">
+            <a:schemeClr val="accent1"/>
+          </a:fillRef>
+          <a:effectRef idx="0">
+            <a:schemeClr val="accent1"/>
+          </a:effectRef>
+          <a:fontRef idx="minor">
+            <a:schemeClr val="lt1"/>
+          </a:fontRef>
+        </p:style>
+        <p:txBody>
+          <a:bodyPr vertOverflow="clip" horzOverflow="clip" rtlCol="0" anchor="ctr" anchorCtr="0"/>
+          <a:lstStyle/>
+          <a:p>
+            <a:pPr algn="ctr"/>
+            <a:r>
+              <a:rPr lang="en-US" sz="1400" b="1" dirty="0">
+                <a:solidFill>
+                  <a:srgbClr val="FFFFFF"/>
+                </a:solidFill>
+              </a:rPr>
+              <a:t>Staging</a:t>
+            </a:r>
+          </a:p>
+          <a:p>
+            <a:pPr algn="ctr"/>
+            <a:r>
+              <a:rPr lang="en-US" sz="1400" b="1" dirty="0">
+                <a:solidFill>
+                  <a:srgbClr val="FFFFFF"/>
+                </a:solidFill>
+              </a:rPr>
+              <a:t>Area (index)</a:t>
+            </a:r>
+          </a:p>
+        </p:txBody>
+      </p:sp>
+      <p:sp>
+        <p:nvSpPr>
+          <p:cNvPr id="5" name="hdr_repo">
+            <a:extLst>
+              <a:ext uri="{FF2B5EF4-FFF2-40B4-BE49-F238E27FC236}">
+                <a16:creationId xmlns:a16="http://schemas.microsoft.com/office/drawing/2014/main" id="{8CFC8AA7-0682-42D4-9CC1-E56EC00A4045}"/>
+              </a:ext>
+            </a:extLst>
+          </p:cNvPr>
+          <p:cNvSpPr/>
+          <p:nvPr/>
+        </p:nvSpPr>
+        <p:spPr>
+          <a:xfrm>
+            <a:off x="9301480" y="1490557"/>
+            <a:ext cx="2094992" cy="685800"/>
+          </a:xfrm>
+          <a:prstGeom prst="rect">
+            <a:avLst/>
+          </a:prstGeom>
+          <a:solidFill>
+            <a:srgbClr val="92D050"/>
+          </a:solidFill>
+          <a:ln w="15875" cap="flat" cmpd="sng" algn="ctr">
+            <a:solidFill>
+              <a:srgbClr val="9A9A9A"/>
+            </a:solidFill>
+            <a:prstDash val="solid"/>
+            <a:miter lim="800000"/>
+          </a:ln>
+        </p:spPr>
+        <p:style>
+          <a:lnRef idx="2">
+            <a:schemeClr val="accent1">
+              <a:shade val="15000"/>
+            </a:schemeClr>
+          </a:lnRef>
+          <a:fillRef idx="1">
+            <a:schemeClr val="accent1"/>
+          </a:fillRef>
+          <a:effectRef idx="0">
+            <a:schemeClr val="accent1"/>
+          </a:effectRef>
+          <a:fontRef idx="minor">
+            <a:schemeClr val="lt1"/>
+          </a:fontRef>
+        </p:style>
+        <p:txBody>
+          <a:bodyPr vertOverflow="clip" horzOverflow="clip" rtlCol="0" anchor="ctr" anchorCtr="0"/>
+          <a:lstStyle/>
+          <a:p>
+            <a:pPr algn="ctr"/>
+            <a:r>
+              <a:rPr lang="en-US" sz="1400" b="1" dirty="0">
+                <a:solidFill>
+                  <a:srgbClr val="333333"/>
+                </a:solidFill>
+              </a:rPr>
+              <a:t>Object</a:t>
+            </a:r>
+          </a:p>
+          <a:p>
+            <a:pPr algn="ctr"/>
+            <a:r>
+              <a:rPr lang="en-US" sz="1400" b="1" dirty="0">
+                <a:solidFill>
+                  <a:srgbClr val="333333"/>
+                </a:solidFill>
+              </a:rPr>
+              <a:t>database</a:t>
+            </a:r>
+          </a:p>
+        </p:txBody>
+      </p:sp>
+      <p:sp>
+        <p:nvSpPr>
+          <p:cNvPr id="14" name="hdr_repo">
+            <a:extLst>
+              <a:ext uri="{FF2B5EF4-FFF2-40B4-BE49-F238E27FC236}">
+                <a16:creationId xmlns:a16="http://schemas.microsoft.com/office/drawing/2014/main" id="{815A0292-FAB4-D514-8E52-2578F44A6B57}"/>
+              </a:ext>
+            </a:extLst>
+          </p:cNvPr>
+          <p:cNvSpPr/>
+          <p:nvPr/>
+        </p:nvSpPr>
+        <p:spPr>
+          <a:xfrm>
+            <a:off x="7054088" y="880956"/>
+            <a:ext cx="4321361" cy="525511"/>
+          </a:xfrm>
+          <a:prstGeom prst="rect">
+            <a:avLst/>
+          </a:prstGeom>
+          <a:solidFill>
+            <a:srgbClr val="EDEDED"/>
+          </a:solidFill>
+          <a:ln w="15875" cap="flat" cmpd="sng" algn="ctr">
+            <a:solidFill>
+              <a:srgbClr val="9A9A9A"/>
+            </a:solidFill>
+            <a:prstDash val="solid"/>
+            <a:miter lim="800000"/>
+          </a:ln>
+        </p:spPr>
+        <p:style>
+          <a:lnRef idx="2">
+            <a:schemeClr val="accent1">
+              <a:shade val="15000"/>
+            </a:schemeClr>
+          </a:lnRef>
+          <a:fillRef idx="1">
+            <a:schemeClr val="accent1"/>
+          </a:fillRef>
+          <a:effectRef idx="0">
+            <a:schemeClr val="accent1"/>
+          </a:effectRef>
+          <a:fontRef idx="minor">
+            <a:schemeClr val="lt1"/>
+          </a:fontRef>
+        </p:style>
+        <p:txBody>
+          <a:bodyPr vertOverflow="clip" horzOverflow="clip" rtlCol="0" anchor="ctr" anchorCtr="0"/>
+          <a:lstStyle/>
+          <a:p>
+            <a:pPr algn="ctr"/>
+            <a:r>
+              <a:rPr lang="en-US" sz="1400" b="1" dirty="0">
+                <a:solidFill>
+                  <a:srgbClr val="333333"/>
+                </a:solidFill>
+              </a:rPr>
+              <a:t>.git directory</a:t>
+            </a:r>
+          </a:p>
+          <a:p>
+            <a:pPr algn="ctr"/>
+            <a:r>
+              <a:rPr lang="en-US" sz="1400" b="1" dirty="0">
+                <a:solidFill>
+                  <a:srgbClr val="333333"/>
+                </a:solidFill>
+              </a:rPr>
+              <a:t>(Repository)</a:t>
+            </a:r>
+          </a:p>
+        </p:txBody>
+      </p:sp>
+      <p:sp>
+        <p:nvSpPr>
+          <p:cNvPr id="15" name="hdr_working_directory">
+            <a:extLst>
+              <a:ext uri="{FF2B5EF4-FFF2-40B4-BE49-F238E27FC236}">
+                <a16:creationId xmlns:a16="http://schemas.microsoft.com/office/drawing/2014/main" id="{433FF574-45B9-4AB9-5798-DB4D711DD382}"/>
+              </a:ext>
+            </a:extLst>
+          </p:cNvPr>
+          <p:cNvSpPr/>
+          <p:nvPr/>
+        </p:nvSpPr>
+        <p:spPr>
+          <a:xfrm>
+            <a:off x="4814579" y="5133804"/>
+            <a:ext cx="2094992" cy="685800"/>
+          </a:xfrm>
+          <a:prstGeom prst="rect">
+            <a:avLst/>
+          </a:prstGeom>
+          <a:solidFill>
+            <a:schemeClr val="tx2">
+              <a:lumMod val="50000"/>
+              <a:lumOff val="50000"/>
+            </a:schemeClr>
+          </a:solidFill>
+          <a:ln w="0" cap="flat" cmpd="sng" algn="ctr">
+            <a:solidFill>
+              <a:srgbClr val="156082">
+                <a:shade val="15000"/>
+              </a:srgbClr>
+            </a:solidFill>
+            <a:prstDash val="solid"/>
+            <a:miter lim="800000"/>
+          </a:ln>
+        </p:spPr>
+        <p:style>
+          <a:lnRef idx="2">
+            <a:schemeClr val="accent1">
+              <a:shade val="15000"/>
+            </a:schemeClr>
+          </a:lnRef>
+          <a:fillRef idx="1">
+            <a:schemeClr val="accent1"/>
+          </a:fillRef>
+          <a:effectRef idx="0">
+            <a:schemeClr val="accent1"/>
+          </a:effectRef>
+          <a:fontRef idx="minor">
+            <a:schemeClr val="lt1"/>
+          </a:fontRef>
+        </p:style>
+        <p:txBody>
+          <a:bodyPr vertOverflow="clip" horzOverflow="clip" rtlCol="0" anchor="ctr" anchorCtr="0"/>
+          <a:lstStyle/>
+          <a:p>
+            <a:pPr algn="ctr"/>
+            <a:r>
+              <a:rPr lang="en-US" sz="1400" b="1" dirty="0">
+                <a:solidFill>
+                  <a:srgbClr val="FFFFFF"/>
+                </a:solidFill>
+              </a:rPr>
+              <a:t>New, changed, and unchanged files</a:t>
+            </a:r>
+          </a:p>
+        </p:txBody>
+      </p:sp>
+      <p:sp>
+        <p:nvSpPr>
+          <p:cNvPr id="16" name="hdr_staging_area">
+            <a:extLst>
+              <a:ext uri="{FF2B5EF4-FFF2-40B4-BE49-F238E27FC236}">
+                <a16:creationId xmlns:a16="http://schemas.microsoft.com/office/drawing/2014/main" id="{3CC7E45B-A64D-6031-0AB0-E5C1AA0F0C10}"/>
+              </a:ext>
+            </a:extLst>
+          </p:cNvPr>
+          <p:cNvSpPr/>
+          <p:nvPr/>
+        </p:nvSpPr>
+        <p:spPr>
+          <a:xfrm>
+            <a:off x="7054088" y="5133804"/>
+            <a:ext cx="2094992" cy="685800"/>
+          </a:xfrm>
+          <a:prstGeom prst="rect">
+            <a:avLst/>
+          </a:prstGeom>
+          <a:solidFill>
+            <a:srgbClr val="E96F2B"/>
+          </a:solidFill>
+          <a:ln w="0" cap="flat" cmpd="sng" algn="ctr">
+            <a:solidFill>
+              <a:srgbClr val="156082">
+                <a:shade val="15000"/>
+              </a:srgbClr>
+            </a:solidFill>
+            <a:prstDash val="solid"/>
+            <a:miter lim="800000"/>
+          </a:ln>
+        </p:spPr>
+        <p:style>
+          <a:lnRef idx="2">
+            <a:schemeClr val="accent1">
+              <a:shade val="15000"/>
+            </a:schemeClr>
+          </a:lnRef>
+          <a:fillRef idx="1">
+            <a:schemeClr val="accent1"/>
+          </a:fillRef>
+          <a:effectRef idx="0">
+            <a:schemeClr val="accent1"/>
+          </a:effectRef>
+          <a:fontRef idx="minor">
+            <a:schemeClr val="lt1"/>
+          </a:fontRef>
+        </p:style>
+        <p:txBody>
+          <a:bodyPr vertOverflow="clip" horzOverflow="clip" rtlCol="0" anchor="ctr" anchorCtr="0"/>
+          <a:lstStyle/>
+          <a:p>
+            <a:pPr algn="ctr"/>
+            <a:r>
+              <a:rPr lang="en-US" sz="1400" b="1" dirty="0">
+                <a:solidFill>
+                  <a:srgbClr val="FFFFFF"/>
+                </a:solidFill>
+              </a:rPr>
+              <a:t>Tracked</a:t>
+            </a:r>
+          </a:p>
+          <a:p>
+            <a:pPr algn="ctr"/>
+            <a:r>
+              <a:rPr lang="en-US" sz="1400" b="1" dirty="0">
+                <a:solidFill>
+                  <a:srgbClr val="FFFFFF"/>
+                </a:solidFill>
+              </a:rPr>
+              <a:t>changes</a:t>
+            </a:r>
+          </a:p>
+        </p:txBody>
+      </p:sp>
+      <p:sp>
+        <p:nvSpPr>
+          <p:cNvPr id="17" name="hdr_repo">
+            <a:extLst>
+              <a:ext uri="{FF2B5EF4-FFF2-40B4-BE49-F238E27FC236}">
+                <a16:creationId xmlns:a16="http://schemas.microsoft.com/office/drawing/2014/main" id="{B06070A7-9151-C625-74B2-6BD1F68B87F9}"/>
+              </a:ext>
+            </a:extLst>
+          </p:cNvPr>
+          <p:cNvSpPr/>
+          <p:nvPr/>
+        </p:nvSpPr>
+        <p:spPr>
+          <a:xfrm>
+            <a:off x="9301480" y="5133804"/>
+            <a:ext cx="2094992" cy="685800"/>
+          </a:xfrm>
+          <a:prstGeom prst="rect">
+            <a:avLst/>
+          </a:prstGeom>
+          <a:solidFill>
+            <a:srgbClr val="92D050"/>
+          </a:solidFill>
+          <a:ln w="15875" cap="flat" cmpd="sng" algn="ctr">
+            <a:solidFill>
+              <a:srgbClr val="9A9A9A"/>
+            </a:solidFill>
+            <a:prstDash val="solid"/>
+            <a:miter lim="800000"/>
+          </a:ln>
+        </p:spPr>
+        <p:style>
+          <a:lnRef idx="2">
+            <a:schemeClr val="accent1">
+              <a:shade val="15000"/>
+            </a:schemeClr>
+          </a:lnRef>
+          <a:fillRef idx="1">
+            <a:schemeClr val="accent1"/>
+          </a:fillRef>
+          <a:effectRef idx="0">
+            <a:schemeClr val="accent1"/>
+          </a:effectRef>
+          <a:fontRef idx="minor">
+            <a:schemeClr val="lt1"/>
+          </a:fontRef>
+        </p:style>
+        <p:txBody>
+          <a:bodyPr vertOverflow="clip" horzOverflow="clip" rtlCol="0" anchor="ctr" anchorCtr="0"/>
+          <a:lstStyle/>
+          <a:p>
+            <a:pPr algn="ctr"/>
+            <a:r>
+              <a:rPr lang="en-US" sz="1400" b="1" dirty="0">
+                <a:solidFill>
+                  <a:srgbClr val="333333"/>
+                </a:solidFill>
+              </a:rPr>
+              <a:t>Committed</a:t>
+            </a:r>
+          </a:p>
+          <a:p>
+            <a:pPr algn="ctr"/>
+            <a:r>
+              <a:rPr lang="en-US" sz="1400" b="1" dirty="0">
+                <a:solidFill>
+                  <a:srgbClr val="333333"/>
+                </a:solidFill>
+              </a:rPr>
+              <a:t>objects</a:t>
+            </a:r>
+          </a:p>
+        </p:txBody>
+      </p:sp>
+      <p:sp>
+        <p:nvSpPr>
+          <p:cNvPr id="18" name="TextBox 17">
+            <a:extLst>
+              <a:ext uri="{FF2B5EF4-FFF2-40B4-BE49-F238E27FC236}">
+                <a16:creationId xmlns:a16="http://schemas.microsoft.com/office/drawing/2014/main" id="{A5750475-0DF2-61ED-39BE-E5BD0F89940C}"/>
+              </a:ext>
+            </a:extLst>
+          </p:cNvPr>
+          <p:cNvSpPr txBox="1"/>
+          <p:nvPr/>
+        </p:nvSpPr>
+        <p:spPr>
+          <a:xfrm>
+            <a:off x="630936" y="3420957"/>
+            <a:ext cx="3419856" cy="1200329"/>
           </a:xfrm>
           <a:prstGeom prst="rect">
             <a:avLst/>
           </a:prstGeom>
           <a:noFill/>
-          <a:extLst>
-            <a:ext uri="{909E8E84-426E-40DD-AFC4-6F175D3DCCD1}">
-              <a14:hiddenFill xmlns:a14="http://schemas.microsoft.com/office/drawing/2010/main">
-                <a:solidFill>
-                  <a:srgbClr val="FFFFFF"/>
-                </a:solidFill>
-              </a14:hiddenFill>
-            </a:ext>
-          </a:extLst>
         </p:spPr>
-      </p:pic>
-      <p:sp>
-        <p:nvSpPr>
-          <p:cNvPr id="1030" name="Content Placeholder 1029">
-            <a:extLst>
-              <a:ext uri="{FF2B5EF4-FFF2-40B4-BE49-F238E27FC236}">
-                <a16:creationId xmlns:a16="http://schemas.microsoft.com/office/drawing/2014/main" id="{713F870B-111C-315B-2E2A-596C505EF7F2}"/>
-              </a:ext>
-            </a:extLst>
-          </p:cNvPr>
-          <p:cNvSpPr>
-            <a:spLocks noGrp="1"/>
-          </p:cNvSpPr>
-          <p:nvPr>
-            <p:ph idx="1"/>
-          </p:nvPr>
-        </p:nvSpPr>
-        <p:spPr>
-          <a:xfrm>
-            <a:off x="4654296" y="4798577"/>
-            <a:ext cx="6894576" cy="1428487"/>
-          </a:xfrm>
-        </p:spPr>
-        <p:txBody>
-          <a:bodyPr anchor="t">
-            <a:normAutofit fontScale="92500"/>
+        <p:txBody>
+          <a:bodyPr wrap="square" rtlCol="0">
+            <a:spAutoFit/>
           </a:bodyPr>
           <a:lstStyle/>
           <a:p>
-            <a:r>
-              <a:rPr lang="en-US" sz="2200" dirty="0"/>
-              <a:t>Working directory – repo directory on the local file system</a:t>
-            </a:r>
-          </a:p>
-          <a:p>
-            <a:r>
-              <a:rPr lang="en-US" sz="2200" dirty="0"/>
-              <a:t>.git directory – hidden directory in root of the repo</a:t>
-            </a:r>
-          </a:p>
-          <a:p>
-            <a:r>
-              <a:rPr lang="en-US" sz="2200" dirty="0"/>
-              <a:t>Staging Area – index file in .git directory</a:t>
-            </a:r>
+            <a:pPr marL="285750" indent="-285750">
+              <a:buFont typeface="Arial" panose="020B0604020202020204" pitchFamily="34" charset="0"/>
+              <a:buChar char="•"/>
+            </a:pPr>
+            <a:r>
+              <a:rPr lang="en-US" sz="2400" dirty="0"/>
+              <a:t>Modified</a:t>
+            </a:r>
+          </a:p>
+          <a:p>
+            <a:pPr marL="285750" indent="-285750">
+              <a:buFont typeface="Arial" panose="020B0604020202020204" pitchFamily="34" charset="0"/>
+              <a:buChar char="•"/>
+            </a:pPr>
+            <a:r>
+              <a:rPr lang="en-US" sz="2400" dirty="0"/>
+              <a:t>Staged</a:t>
+            </a:r>
+          </a:p>
+          <a:p>
+            <a:pPr marL="285750" indent="-285750">
+              <a:buFont typeface="Arial" panose="020B0604020202020204" pitchFamily="34" charset="0"/>
+              <a:buChar char="•"/>
+            </a:pPr>
+            <a:r>
+              <a:rPr lang="en-US" sz="2400" dirty="0" err="1"/>
+              <a:t>Commited</a:t>
+            </a:r>
+            <a:endParaRPr lang="en-US" sz="2400" dirty="0"/>
           </a:p>
         </p:txBody>
       </p:sp>
@@ -6744,61 +7857,146 @@
           </a:p>
         </p:txBody>
       </p:sp>
-      <p:pic>
-        <p:nvPicPr>
-          <p:cNvPr id="2052" name="Picture 4" descr="The lifecycle of the status of your files">
-            <a:extLst>
-              <a:ext uri="{FF2B5EF4-FFF2-40B4-BE49-F238E27FC236}">
-                <a16:creationId xmlns:a16="http://schemas.microsoft.com/office/drawing/2014/main" id="{01673D6B-F791-2712-8B5C-52B444A486A9}"/>
-              </a:ext>
-            </a:extLst>
-          </p:cNvPr>
-          <p:cNvPicPr>
-            <a:picLocks noGrp="1" noChangeAspect="1" noChangeArrowheads="1"/>
-          </p:cNvPicPr>
-          <p:nvPr>
-            <p:ph idx="1"/>
-          </p:nvPr>
-        </p:nvPicPr>
-        <p:blipFill>
-          <a:blip r:embed="rId3">
-            <a:extLst>
-              <a:ext uri="{28A0092B-C50C-407E-A947-70E740481C1C}">
-                <a14:useLocalDpi xmlns:a14="http://schemas.microsoft.com/office/drawing/2010/main" val="0"/>
-              </a:ext>
-            </a:extLst>
-          </a:blip>
-          <a:srcRect/>
-          <a:stretch>
-            <a:fillRect/>
-          </a:stretch>
-        </p:blipFill>
-        <p:spPr bwMode="auto">
+      <p:sp>
+        <p:nvSpPr>
+          <p:cNvPr id="5" name="state_header_untracked">
+            <a:extLst>
+              <a:ext uri="{FF2B5EF4-FFF2-40B4-BE49-F238E27FC236}">
+                <a16:creationId xmlns:a16="http://schemas.microsoft.com/office/drawing/2014/main" id="{75225711-5E81-4E02-9D3B-28FDED9C9E34}"/>
+              </a:ext>
+            </a:extLst>
+          </p:cNvPr>
+          <p:cNvSpPr/>
+          <p:nvPr/>
+        </p:nvSpPr>
+        <p:spPr>
           <a:xfrm>
-            <a:off x="1150426" y="1825625"/>
-            <a:ext cx="9891147" cy="4351338"/>
+            <a:off x="1150424" y="1825625"/>
+            <a:ext cx="2358486" cy="533400"/>
           </a:xfrm>
           <a:prstGeom prst="rect">
             <a:avLst/>
           </a:prstGeom>
-          <a:noFill/>
-          <a:extLst>
-            <a:ext uri="{909E8E84-426E-40DD-AFC4-6F175D3DCCD1}">
-              <a14:hiddenFill xmlns:a14="http://schemas.microsoft.com/office/drawing/2010/main">
+          <a:solidFill>
+            <a:srgbClr val="E8E2D6"/>
+          </a:solidFill>
+          <a:ln w="19050" cap="flat" cmpd="sng" algn="ctr">
+            <a:solidFill>
+              <a:srgbClr val="156082">
+                <a:shade val="15000"/>
+                <a:alpha val="0"/>
+              </a:srgbClr>
+            </a:solidFill>
+            <a:prstDash val="solid"/>
+            <a:miter lim="800000"/>
+          </a:ln>
+        </p:spPr>
+        <p:style>
+          <a:lnRef idx="2">
+            <a:schemeClr val="accent1">
+              <a:shade val="15000"/>
+            </a:schemeClr>
+          </a:lnRef>
+          <a:fillRef idx="1">
+            <a:schemeClr val="accent1"/>
+          </a:fillRef>
+          <a:effectRef idx="0">
+            <a:schemeClr val="accent1"/>
+          </a:effectRef>
+          <a:fontRef idx="minor">
+            <a:schemeClr val="lt1"/>
+          </a:fontRef>
+        </p:style>
+        <p:txBody>
+          <a:bodyPr vertOverflow="clip" horzOverflow="clip" rtlCol="0" anchor="ctr" anchorCtr="0"/>
+          <a:lstStyle/>
+          <a:p>
+            <a:pPr algn="ctr"/>
+            <a:r>
+              <a:rPr lang="en-US" sz="1600" b="1">
+                <a:solidFill>
+                  <a:srgbClr val="3A3A3A"/>
+                </a:solidFill>
+                <a:latin typeface="Aptos"/>
+              </a:rPr>
+              <a:t>Untracked</a:t>
+            </a:r>
+          </a:p>
+        </p:txBody>
+      </p:sp>
+      <p:sp>
+        <p:nvSpPr>
+          <p:cNvPr id="6" name="state_header_unmodified">
+            <a:extLst>
+              <a:ext uri="{FF2B5EF4-FFF2-40B4-BE49-F238E27FC236}">
+                <a16:creationId xmlns:a16="http://schemas.microsoft.com/office/drawing/2014/main" id="{8F90BFF9-BBF7-466E-848C-EF2174E9856E}"/>
+              </a:ext>
+            </a:extLst>
+          </p:cNvPr>
+          <p:cNvSpPr/>
+          <p:nvPr/>
+        </p:nvSpPr>
+        <p:spPr>
+          <a:xfrm>
+            <a:off x="3661311" y="1825625"/>
+            <a:ext cx="2358486" cy="533400"/>
+          </a:xfrm>
+          <a:prstGeom prst="rect">
+            <a:avLst/>
+          </a:prstGeom>
+          <a:solidFill>
+            <a:srgbClr val="4E95D9"/>
+          </a:solidFill>
+          <a:ln w="19050" cap="flat" cmpd="sng" algn="ctr">
+            <a:solidFill>
+              <a:srgbClr val="156082">
+                <a:shade val="15000"/>
+                <a:alpha val="0"/>
+              </a:srgbClr>
+            </a:solidFill>
+            <a:prstDash val="solid"/>
+            <a:miter lim="800000"/>
+          </a:ln>
+        </p:spPr>
+        <p:style>
+          <a:lnRef idx="2">
+            <a:schemeClr val="accent1">
+              <a:shade val="15000"/>
+            </a:schemeClr>
+          </a:lnRef>
+          <a:fillRef idx="1">
+            <a:schemeClr val="accent1"/>
+          </a:fillRef>
+          <a:effectRef idx="0">
+            <a:schemeClr val="accent1"/>
+          </a:effectRef>
+          <a:fontRef idx="minor">
+            <a:schemeClr val="lt1"/>
+          </a:fontRef>
+        </p:style>
+        <p:txBody>
+          <a:bodyPr vertOverflow="clip" horzOverflow="clip" rtlCol="0" anchor="ctr" anchorCtr="0"/>
+          <a:lstStyle/>
+          <a:p>
+            <a:pPr algn="ctr"/>
+            <a:r>
+              <a:rPr lang="en-US" sz="1600" b="1">
                 <a:solidFill>
                   <a:srgbClr val="FFFFFF"/>
                 </a:solidFill>
-              </a14:hiddenFill>
-            </a:ext>
-          </a:extLst>
-        </p:spPr>
-      </p:pic>
-      <p:sp>
-        <p:nvSpPr>
-          <p:cNvPr id="3" name="Right Brace 2">
-            <a:extLst>
-              <a:ext uri="{FF2B5EF4-FFF2-40B4-BE49-F238E27FC236}">
-                <a16:creationId xmlns:a16="http://schemas.microsoft.com/office/drawing/2014/main" id="{34461D0D-4D41-C197-C665-2D644FE02E9C}"/>
+                <a:latin typeface="Aptos"/>
+              </a:rPr>
+              <a:t>Unmodified</a:t>
+            </a:r>
+          </a:p>
+        </p:txBody>
+      </p:sp>
+      <p:sp>
+        <p:nvSpPr>
+          <p:cNvPr id="7" name="state_header_modified">
+            <a:extLst>
+              <a:ext uri="{FF2B5EF4-FFF2-40B4-BE49-F238E27FC236}">
+                <a16:creationId xmlns:a16="http://schemas.microsoft.com/office/drawing/2014/main" id="{EE55EDAD-9E48-4648-99D0-D96278BA02B8}"/>
               </a:ext>
             </a:extLst>
           </p:cNvPr>
@@ -6806,14 +8004,662 @@
           <p:nvPr/>
         </p:nvSpPr>
         <p:spPr>
+          <a:xfrm>
+            <a:off x="6172198" y="1825625"/>
+            <a:ext cx="2358486" cy="533400"/>
+          </a:xfrm>
+          <a:prstGeom prst="rect">
+            <a:avLst/>
+          </a:prstGeom>
+          <a:solidFill>
+            <a:srgbClr val="E2B437"/>
+          </a:solidFill>
+          <a:ln w="19050" cap="flat" cmpd="sng" algn="ctr">
+            <a:solidFill>
+              <a:srgbClr val="156082">
+                <a:shade val="15000"/>
+                <a:alpha val="0"/>
+              </a:srgbClr>
+            </a:solidFill>
+            <a:prstDash val="solid"/>
+            <a:miter lim="800000"/>
+          </a:ln>
+        </p:spPr>
+        <p:style>
+          <a:lnRef idx="2">
+            <a:schemeClr val="accent1">
+              <a:shade val="15000"/>
+            </a:schemeClr>
+          </a:lnRef>
+          <a:fillRef idx="1">
+            <a:schemeClr val="accent1"/>
+          </a:fillRef>
+          <a:effectRef idx="0">
+            <a:schemeClr val="accent1"/>
+          </a:effectRef>
+          <a:fontRef idx="minor">
+            <a:schemeClr val="lt1"/>
+          </a:fontRef>
+        </p:style>
+        <p:txBody>
+          <a:bodyPr vertOverflow="clip" horzOverflow="clip" rtlCol="0" anchor="ctr" anchorCtr="0"/>
+          <a:lstStyle/>
+          <a:p>
+            <a:pPr algn="ctr"/>
+            <a:r>
+              <a:rPr lang="en-US" sz="1600" b="1" dirty="0">
+                <a:solidFill>
+                  <a:schemeClr val="bg2">
+                    <a:lumMod val="25000"/>
+                  </a:schemeClr>
+                </a:solidFill>
+                <a:latin typeface="Aptos"/>
+              </a:rPr>
+              <a:t>Modified</a:t>
+            </a:r>
+          </a:p>
+        </p:txBody>
+      </p:sp>
+      <p:sp>
+        <p:nvSpPr>
+          <p:cNvPr id="8" name="state_header_staged">
+            <a:extLst>
+              <a:ext uri="{FF2B5EF4-FFF2-40B4-BE49-F238E27FC236}">
+                <a16:creationId xmlns:a16="http://schemas.microsoft.com/office/drawing/2014/main" id="{AB9E43C7-5C91-43CD-81C3-06BA9144F525}"/>
+              </a:ext>
+            </a:extLst>
+          </p:cNvPr>
+          <p:cNvSpPr/>
+          <p:nvPr/>
+        </p:nvSpPr>
+        <p:spPr>
+          <a:xfrm>
+            <a:off x="8683085" y="1825625"/>
+            <a:ext cx="2358486" cy="533400"/>
+          </a:xfrm>
+          <a:prstGeom prst="rect">
+            <a:avLst/>
+          </a:prstGeom>
+          <a:solidFill>
+            <a:srgbClr val="D65A2E"/>
+          </a:solidFill>
+          <a:ln w="19050" cap="flat" cmpd="sng" algn="ctr">
+            <a:solidFill>
+              <a:srgbClr val="156082">
+                <a:shade val="15000"/>
+                <a:alpha val="0"/>
+              </a:srgbClr>
+            </a:solidFill>
+            <a:prstDash val="solid"/>
+            <a:miter lim="800000"/>
+          </a:ln>
+        </p:spPr>
+        <p:style>
+          <a:lnRef idx="2">
+            <a:schemeClr val="accent1">
+              <a:shade val="15000"/>
+            </a:schemeClr>
+          </a:lnRef>
+          <a:fillRef idx="1">
+            <a:schemeClr val="accent1"/>
+          </a:fillRef>
+          <a:effectRef idx="0">
+            <a:schemeClr val="accent1"/>
+          </a:effectRef>
+          <a:fontRef idx="minor">
+            <a:schemeClr val="lt1"/>
+          </a:fontRef>
+        </p:style>
+        <p:txBody>
+          <a:bodyPr vertOverflow="clip" horzOverflow="clip" rtlCol="0" anchor="ctr" anchorCtr="0"/>
+          <a:lstStyle/>
+          <a:p>
+            <a:pPr algn="ctr"/>
+            <a:r>
+              <a:rPr lang="en-US" sz="1600" b="1">
+                <a:solidFill>
+                  <a:srgbClr val="FFFFFF"/>
+                </a:solidFill>
+                <a:latin typeface="Aptos"/>
+              </a:rPr>
+              <a:t>Staged</a:t>
+            </a:r>
+          </a:p>
+        </p:txBody>
+      </p:sp>
+      <p:sp>
+        <p:nvSpPr>
+          <p:cNvPr id="9" name="state_divider_1">
+            <a:extLst>
+              <a:ext uri="{FF2B5EF4-FFF2-40B4-BE49-F238E27FC236}">
+                <a16:creationId xmlns:a16="http://schemas.microsoft.com/office/drawing/2014/main" id="{24F7C51F-7950-432D-B466-E369F58DFB56}"/>
+              </a:ext>
+            </a:extLst>
+          </p:cNvPr>
+          <p:cNvSpPr/>
+          <p:nvPr/>
+        </p:nvSpPr>
+        <p:spPr>
+          <a:xfrm>
+            <a:off x="4853255" y="2486025"/>
+            <a:ext cx="12700" cy="3462338"/>
+          </a:xfrm>
+          <a:prstGeom prst="rect">
+            <a:avLst/>
+          </a:prstGeom>
+          <a:solidFill>
+            <a:srgbClr val="D9D9D9"/>
+          </a:solidFill>
+          <a:ln w="19050" cap="flat" cmpd="sng" algn="ctr">
+            <a:solidFill>
+              <a:srgbClr val="156082">
+                <a:shade val="15000"/>
+                <a:alpha val="0"/>
+              </a:srgbClr>
+            </a:solidFill>
+            <a:prstDash val="solid"/>
+            <a:miter lim="800000"/>
+          </a:ln>
+        </p:spPr>
+        <p:style>
+          <a:lnRef idx="2">
+            <a:schemeClr val="accent1">
+              <a:shade val="15000"/>
+            </a:schemeClr>
+          </a:lnRef>
+          <a:fillRef idx="1">
+            <a:schemeClr val="accent1"/>
+          </a:fillRef>
+          <a:effectRef idx="0">
+            <a:schemeClr val="accent1"/>
+          </a:effectRef>
+          <a:fontRef idx="minor">
+            <a:schemeClr val="lt1"/>
+          </a:fontRef>
+        </p:style>
+        <p:txBody>
+          <a:bodyPr vertOverflow="clip" horzOverflow="clip" rtlCol="0" anchor="t"/>
+          <a:lstStyle/>
+          <a:p>
+            <a:pPr algn="l"/>
+            <a:endParaRPr lang="en-US"/>
+          </a:p>
+        </p:txBody>
+      </p:sp>
+      <p:sp>
+        <p:nvSpPr>
+          <p:cNvPr id="10" name="state_divider_2">
+            <a:extLst>
+              <a:ext uri="{FF2B5EF4-FFF2-40B4-BE49-F238E27FC236}">
+                <a16:creationId xmlns:a16="http://schemas.microsoft.com/office/drawing/2014/main" id="{4F2EFC66-9D8E-4798-98C4-E7AEB4C607D2}"/>
+              </a:ext>
+            </a:extLst>
+          </p:cNvPr>
+          <p:cNvSpPr/>
+          <p:nvPr/>
+        </p:nvSpPr>
+        <p:spPr>
+          <a:xfrm>
+            <a:off x="7326041" y="2486025"/>
+            <a:ext cx="12700" cy="3462338"/>
+          </a:xfrm>
+          <a:prstGeom prst="rect">
+            <a:avLst/>
+          </a:prstGeom>
+          <a:solidFill>
+            <a:srgbClr val="D9D9D9"/>
+          </a:solidFill>
+          <a:ln w="19050" cap="flat" cmpd="sng" algn="ctr">
+            <a:solidFill>
+              <a:srgbClr val="156082">
+                <a:shade val="15000"/>
+                <a:alpha val="0"/>
+              </a:srgbClr>
+            </a:solidFill>
+            <a:prstDash val="solid"/>
+            <a:miter lim="800000"/>
+          </a:ln>
+        </p:spPr>
+        <p:style>
+          <a:lnRef idx="2">
+            <a:schemeClr val="accent1">
+              <a:shade val="15000"/>
+            </a:schemeClr>
+          </a:lnRef>
+          <a:fillRef idx="1">
+            <a:schemeClr val="accent1"/>
+          </a:fillRef>
+          <a:effectRef idx="0">
+            <a:schemeClr val="accent1"/>
+          </a:effectRef>
+          <a:fontRef idx="minor">
+            <a:schemeClr val="lt1"/>
+          </a:fontRef>
+        </p:style>
+        <p:txBody>
+          <a:bodyPr vertOverflow="clip" horzOverflow="clip" rtlCol="0" anchor="t"/>
+          <a:lstStyle/>
+          <a:p>
+            <a:pPr algn="l"/>
+            <a:endParaRPr lang="en-US"/>
+          </a:p>
+        </p:txBody>
+      </p:sp>
+      <p:sp>
+        <p:nvSpPr>
+          <p:cNvPr id="11" name="state_divider_3">
+            <a:extLst>
+              <a:ext uri="{FF2B5EF4-FFF2-40B4-BE49-F238E27FC236}">
+                <a16:creationId xmlns:a16="http://schemas.microsoft.com/office/drawing/2014/main" id="{683CD8B0-C5A3-407D-9456-AFDD175D0F32}"/>
+              </a:ext>
+            </a:extLst>
+          </p:cNvPr>
+          <p:cNvSpPr/>
+          <p:nvPr/>
+        </p:nvSpPr>
+        <p:spPr>
+          <a:xfrm>
+            <a:off x="9798828" y="2486025"/>
+            <a:ext cx="12700" cy="3462338"/>
+          </a:xfrm>
+          <a:prstGeom prst="rect">
+            <a:avLst/>
+          </a:prstGeom>
+          <a:solidFill>
+            <a:srgbClr val="D9D9D9"/>
+          </a:solidFill>
+          <a:ln w="19050" cap="flat" cmpd="sng" algn="ctr">
+            <a:solidFill>
+              <a:srgbClr val="156082">
+                <a:shade val="15000"/>
+                <a:alpha val="0"/>
+              </a:srgbClr>
+            </a:solidFill>
+            <a:prstDash val="solid"/>
+            <a:miter lim="800000"/>
+          </a:ln>
+        </p:spPr>
+        <p:style>
+          <a:lnRef idx="2">
+            <a:schemeClr val="accent1">
+              <a:shade val="15000"/>
+            </a:schemeClr>
+          </a:lnRef>
+          <a:fillRef idx="1">
+            <a:schemeClr val="accent1"/>
+          </a:fillRef>
+          <a:effectRef idx="0">
+            <a:schemeClr val="accent1"/>
+          </a:effectRef>
+          <a:fontRef idx="minor">
+            <a:schemeClr val="lt1"/>
+          </a:fontRef>
+        </p:style>
+        <p:txBody>
+          <a:bodyPr vertOverflow="clip" horzOverflow="clip" rtlCol="0" anchor="t"/>
+          <a:lstStyle/>
+          <a:p>
+            <a:pPr algn="l"/>
+            <a:endParaRPr lang="en-US"/>
+          </a:p>
+        </p:txBody>
+      </p:sp>
+      <p:sp>
+        <p:nvSpPr>
+          <p:cNvPr id="12" name="arrow_add">
+            <a:extLst>
+              <a:ext uri="{FF2B5EF4-FFF2-40B4-BE49-F238E27FC236}">
+                <a16:creationId xmlns:a16="http://schemas.microsoft.com/office/drawing/2014/main" id="{67D69D4A-0748-49E0-A95C-CF06E5E2589B}"/>
+              </a:ext>
+            </a:extLst>
+          </p:cNvPr>
+          <p:cNvSpPr/>
+          <p:nvPr/>
+        </p:nvSpPr>
+        <p:spPr>
+          <a:xfrm>
+            <a:off x="2615418" y="2678849"/>
+            <a:ext cx="6961160" cy="431800"/>
+          </a:xfrm>
+          <a:prstGeom prst="rightArrow">
+            <a:avLst/>
+          </a:prstGeom>
+          <a:solidFill>
+            <a:srgbClr val="7A7A7A"/>
+          </a:solidFill>
+          <a:ln w="19050" cap="flat" cmpd="sng" algn="ctr">
+            <a:solidFill>
+              <a:srgbClr val="156082">
+                <a:shade val="15000"/>
+                <a:alpha val="0"/>
+              </a:srgbClr>
+            </a:solidFill>
+            <a:prstDash val="solid"/>
+            <a:miter lim="800000"/>
+          </a:ln>
+        </p:spPr>
+        <p:style>
+          <a:lnRef idx="2">
+            <a:schemeClr val="accent1">
+              <a:shade val="15000"/>
+            </a:schemeClr>
+          </a:lnRef>
+          <a:fillRef idx="1">
+            <a:schemeClr val="accent1"/>
+          </a:fillRef>
+          <a:effectRef idx="0">
+            <a:schemeClr val="accent1"/>
+          </a:effectRef>
+          <a:fontRef idx="minor">
+            <a:schemeClr val="lt1"/>
+          </a:fontRef>
+        </p:style>
+        <p:txBody>
+          <a:bodyPr vertOverflow="clip" horzOverflow="clip" rtlCol="0" anchor="ctr" anchorCtr="0"/>
+          <a:lstStyle/>
+          <a:p>
+            <a:pPr algn="ctr"/>
+            <a:r>
+              <a:rPr lang="en-US" sz="1600" b="1" dirty="0">
+                <a:solidFill>
+                  <a:srgbClr val="FFFFFF"/>
+                </a:solidFill>
+                <a:latin typeface="Aptos"/>
+              </a:rPr>
+              <a:t>Add the file</a:t>
+            </a:r>
+          </a:p>
+        </p:txBody>
+      </p:sp>
+      <p:sp>
+        <p:nvSpPr>
+          <p:cNvPr id="13" name="arrow_edit">
+            <a:extLst>
+              <a:ext uri="{FF2B5EF4-FFF2-40B4-BE49-F238E27FC236}">
+                <a16:creationId xmlns:a16="http://schemas.microsoft.com/office/drawing/2014/main" id="{C6677DC0-CCAF-4C4F-9064-FE38759C880E}"/>
+              </a:ext>
+            </a:extLst>
+          </p:cNvPr>
+          <p:cNvSpPr/>
+          <p:nvPr/>
+        </p:nvSpPr>
+        <p:spPr>
+          <a:xfrm>
+            <a:off x="5088205" y="3397340"/>
+            <a:ext cx="2015586" cy="431800"/>
+          </a:xfrm>
+          <a:prstGeom prst="rightArrow">
+            <a:avLst/>
+          </a:prstGeom>
+          <a:solidFill>
+            <a:srgbClr val="7A7A7A"/>
+          </a:solidFill>
+          <a:ln w="19050" cap="flat" cmpd="sng" algn="ctr">
+            <a:solidFill>
+              <a:srgbClr val="156082">
+                <a:shade val="15000"/>
+                <a:alpha val="0"/>
+              </a:srgbClr>
+            </a:solidFill>
+            <a:prstDash val="solid"/>
+            <a:miter lim="800000"/>
+          </a:ln>
+        </p:spPr>
+        <p:style>
+          <a:lnRef idx="2">
+            <a:schemeClr val="accent1">
+              <a:shade val="15000"/>
+            </a:schemeClr>
+          </a:lnRef>
+          <a:fillRef idx="1">
+            <a:schemeClr val="accent1"/>
+          </a:fillRef>
+          <a:effectRef idx="0">
+            <a:schemeClr val="accent1"/>
+          </a:effectRef>
+          <a:fontRef idx="minor">
+            <a:schemeClr val="lt1"/>
+          </a:fontRef>
+        </p:style>
+        <p:txBody>
+          <a:bodyPr vertOverflow="clip" horzOverflow="clip" rtlCol="0" anchor="ctr" anchorCtr="0"/>
+          <a:lstStyle/>
+          <a:p>
+            <a:pPr algn="ctr"/>
+            <a:r>
+              <a:rPr lang="en-US" sz="1600" b="1" dirty="0">
+                <a:solidFill>
+                  <a:srgbClr val="FFFFFF"/>
+                </a:solidFill>
+                <a:latin typeface="Aptos"/>
+              </a:rPr>
+              <a:t>Edit the file</a:t>
+            </a:r>
+          </a:p>
+        </p:txBody>
+      </p:sp>
+      <p:sp>
+        <p:nvSpPr>
+          <p:cNvPr id="14" name="arrow_stage">
+            <a:extLst>
+              <a:ext uri="{FF2B5EF4-FFF2-40B4-BE49-F238E27FC236}">
+                <a16:creationId xmlns:a16="http://schemas.microsoft.com/office/drawing/2014/main" id="{3F8EAB3A-EC31-4F0B-9806-F2C33B2A48DA}"/>
+              </a:ext>
+            </a:extLst>
+          </p:cNvPr>
+          <p:cNvSpPr/>
+          <p:nvPr/>
+        </p:nvSpPr>
+        <p:spPr>
+          <a:xfrm>
+            <a:off x="7560993" y="3400516"/>
+            <a:ext cx="2015586" cy="431800"/>
+          </a:xfrm>
+          <a:prstGeom prst="rightArrow">
+            <a:avLst/>
+          </a:prstGeom>
+          <a:solidFill>
+            <a:srgbClr val="7A7A7A"/>
+          </a:solidFill>
+          <a:ln w="19050" cap="flat" cmpd="sng" algn="ctr">
+            <a:solidFill>
+              <a:srgbClr val="156082">
+                <a:shade val="15000"/>
+                <a:alpha val="0"/>
+              </a:srgbClr>
+            </a:solidFill>
+            <a:prstDash val="solid"/>
+            <a:miter lim="800000"/>
+          </a:ln>
+        </p:spPr>
+        <p:style>
+          <a:lnRef idx="2">
+            <a:schemeClr val="accent1">
+              <a:shade val="15000"/>
+            </a:schemeClr>
+          </a:lnRef>
+          <a:fillRef idx="1">
+            <a:schemeClr val="accent1"/>
+          </a:fillRef>
+          <a:effectRef idx="0">
+            <a:schemeClr val="accent1"/>
+          </a:effectRef>
+          <a:fontRef idx="minor">
+            <a:schemeClr val="lt1"/>
+          </a:fontRef>
+        </p:style>
+        <p:txBody>
+          <a:bodyPr vertOverflow="clip" horzOverflow="clip" rtlCol="0" anchor="ctr" anchorCtr="0"/>
+          <a:lstStyle/>
+          <a:p>
+            <a:pPr algn="ctr"/>
+            <a:r>
+              <a:rPr lang="en-US" sz="1600" b="1" dirty="0">
+                <a:solidFill>
+                  <a:srgbClr val="FFFFFF"/>
+                </a:solidFill>
+                <a:latin typeface="Aptos"/>
+              </a:rPr>
+              <a:t>Stage the file</a:t>
+            </a:r>
+          </a:p>
+        </p:txBody>
+      </p:sp>
+      <p:sp>
+        <p:nvSpPr>
+          <p:cNvPr id="15" name="arrow_remove">
+            <a:extLst>
+              <a:ext uri="{FF2B5EF4-FFF2-40B4-BE49-F238E27FC236}">
+                <a16:creationId xmlns:a16="http://schemas.microsoft.com/office/drawing/2014/main" id="{D1374DF3-DFB5-4F37-9468-2EF39DDFE506}"/>
+              </a:ext>
+            </a:extLst>
+          </p:cNvPr>
+          <p:cNvSpPr/>
+          <p:nvPr/>
+        </p:nvSpPr>
+        <p:spPr>
+          <a:xfrm>
+            <a:off x="2615420" y="4001294"/>
+            <a:ext cx="2015586" cy="431800"/>
+          </a:xfrm>
+          <a:prstGeom prst="leftArrow">
+            <a:avLst/>
+          </a:prstGeom>
+          <a:solidFill>
+            <a:srgbClr val="7A7A7A"/>
+          </a:solidFill>
+          <a:ln w="19050" cap="flat" cmpd="sng" algn="ctr">
+            <a:solidFill>
+              <a:srgbClr val="156082">
+                <a:shade val="15000"/>
+                <a:alpha val="0"/>
+              </a:srgbClr>
+            </a:solidFill>
+            <a:prstDash val="solid"/>
+            <a:miter lim="800000"/>
+          </a:ln>
+        </p:spPr>
+        <p:style>
+          <a:lnRef idx="2">
+            <a:schemeClr val="accent1">
+              <a:shade val="15000"/>
+            </a:schemeClr>
+          </a:lnRef>
+          <a:fillRef idx="1">
+            <a:schemeClr val="accent1"/>
+          </a:fillRef>
+          <a:effectRef idx="0">
+            <a:schemeClr val="accent1"/>
+          </a:effectRef>
+          <a:fontRef idx="minor">
+            <a:schemeClr val="lt1"/>
+          </a:fontRef>
+        </p:style>
+        <p:txBody>
+          <a:bodyPr vertOverflow="clip" horzOverflow="clip" rtlCol="0" anchor="ctr" anchorCtr="0"/>
+          <a:lstStyle/>
+          <a:p>
+            <a:pPr algn="ctr"/>
+            <a:r>
+              <a:rPr lang="en-US" sz="1600" b="1" dirty="0">
+                <a:solidFill>
+                  <a:srgbClr val="FFFFFF"/>
+                </a:solidFill>
+                <a:latin typeface="Aptos"/>
+              </a:rPr>
+              <a:t>Remove the file</a:t>
+            </a:r>
+          </a:p>
+        </p:txBody>
+      </p:sp>
+      <p:sp>
+        <p:nvSpPr>
+          <p:cNvPr id="16" name="arrow_commit">
+            <a:extLst>
+              <a:ext uri="{FF2B5EF4-FFF2-40B4-BE49-F238E27FC236}">
+                <a16:creationId xmlns:a16="http://schemas.microsoft.com/office/drawing/2014/main" id="{55746C7C-2DAB-435B-842C-877B0EE77C56}"/>
+              </a:ext>
+            </a:extLst>
+          </p:cNvPr>
+          <p:cNvSpPr/>
+          <p:nvPr/>
+        </p:nvSpPr>
+        <p:spPr>
+          <a:xfrm>
+            <a:off x="5113603" y="4773058"/>
+            <a:ext cx="4462974" cy="431800"/>
+          </a:xfrm>
+          <a:prstGeom prst="leftArrow">
+            <a:avLst/>
+          </a:prstGeom>
+          <a:solidFill>
+            <a:srgbClr val="7A7A7A"/>
+          </a:solidFill>
+          <a:ln w="19050" cap="flat" cmpd="sng" algn="ctr">
+            <a:solidFill>
+              <a:srgbClr val="156082">
+                <a:shade val="15000"/>
+                <a:alpha val="0"/>
+              </a:srgbClr>
+            </a:solidFill>
+            <a:prstDash val="solid"/>
+            <a:miter lim="800000"/>
+          </a:ln>
+        </p:spPr>
+        <p:style>
+          <a:lnRef idx="2">
+            <a:schemeClr val="accent1">
+              <a:shade val="15000"/>
+            </a:schemeClr>
+          </a:lnRef>
+          <a:fillRef idx="1">
+            <a:schemeClr val="accent1"/>
+          </a:fillRef>
+          <a:effectRef idx="0">
+            <a:schemeClr val="accent1"/>
+          </a:effectRef>
+          <a:fontRef idx="minor">
+            <a:schemeClr val="lt1"/>
+          </a:fontRef>
+        </p:style>
+        <p:txBody>
+          <a:bodyPr vertOverflow="clip" horzOverflow="clip" rtlCol="0" anchor="ctr" anchorCtr="0"/>
+          <a:lstStyle/>
+          <a:p>
+            <a:pPr algn="ctr"/>
+            <a:r>
+              <a:rPr lang="en-US" sz="1600" b="1" dirty="0">
+                <a:solidFill>
+                  <a:srgbClr val="FFFFFF"/>
+                </a:solidFill>
+                <a:latin typeface="Aptos"/>
+              </a:rPr>
+              <a:t>Commit</a:t>
+            </a:r>
+          </a:p>
+        </p:txBody>
+      </p:sp>
+      <p:sp>
+        <p:nvSpPr>
+          <p:cNvPr id="3" name="Right Brace 2">
+            <a:extLst>
+              <a:ext uri="{FF2B5EF4-FFF2-40B4-BE49-F238E27FC236}">
+                <a16:creationId xmlns:a16="http://schemas.microsoft.com/office/drawing/2014/main" id="{34461D0D-4D41-C197-C665-2D644FE02E9C}"/>
+              </a:ext>
+            </a:extLst>
+          </p:cNvPr>
+          <p:cNvSpPr/>
+          <p:nvPr/>
+        </p:nvSpPr>
+        <p:spPr>
           <a:xfrm rot="5400000">
-            <a:off x="7079104" y="3328324"/>
-            <a:ext cx="517161" cy="5697278"/>
+            <a:off x="7080160" y="3526379"/>
+            <a:ext cx="517161" cy="4945574"/>
           </a:xfrm>
           <a:prstGeom prst="rightBrace">
             <a:avLst>
               <a:gd name="adj1" fmla="val 8333"/>
-              <a:gd name="adj2" fmla="val 47369"/>
+              <a:gd name="adj2" fmla="val 50337"/>
             </a:avLst>
           </a:prstGeom>
           <a:ln w="50800"/>
@@ -6855,7 +8701,7 @@
         </p:nvSpPr>
         <p:spPr>
           <a:xfrm>
-            <a:off x="6895476" y="6396335"/>
+            <a:off x="6719112" y="6234849"/>
             <a:ext cx="1213858" cy="461665"/>
           </a:xfrm>
           <a:prstGeom prst="rect">
@@ -6873,6 +8719,62 @@
               <a:rPr lang="en-US" sz="2400" dirty="0"/>
               <a:t>Tracked</a:t>
             </a:r>
+          </a:p>
+        </p:txBody>
+      </p:sp>
+      <p:sp>
+        <p:nvSpPr>
+          <p:cNvPr id="17" name="state_divider_0">
+            <a:extLst>
+              <a:ext uri="{FF2B5EF4-FFF2-40B4-BE49-F238E27FC236}">
+                <a16:creationId xmlns:a16="http://schemas.microsoft.com/office/drawing/2014/main" id="{49C6E2D4-F6CD-4600-A318-AD2B5BDA4A2C}"/>
+              </a:ext>
+            </a:extLst>
+          </p:cNvPr>
+          <p:cNvSpPr/>
+          <p:nvPr/>
+        </p:nvSpPr>
+        <p:spPr>
+          <a:xfrm>
+            <a:off x="2380467" y="2486025"/>
+            <a:ext cx="12700" cy="3462338"/>
+          </a:xfrm>
+          <a:prstGeom prst="rect">
+            <a:avLst/>
+          </a:prstGeom>
+          <a:solidFill>
+            <a:srgbClr val="D9D9D9"/>
+          </a:solidFill>
+          <a:ln w="0" cap="flat" cmpd="sng" algn="ctr">
+            <a:solidFill>
+              <a:srgbClr val="D9D9D9"/>
+            </a:solidFill>
+            <a:prstDash val="solid"/>
+            <a:miter lim="800000"/>
+          </a:ln>
+        </p:spPr>
+        <p:style>
+          <a:lnRef idx="2">
+            <a:schemeClr val="accent1">
+              <a:shade val="15000"/>
+            </a:schemeClr>
+          </a:lnRef>
+          <a:fillRef idx="1">
+            <a:schemeClr val="accent1"/>
+          </a:fillRef>
+          <a:effectRef idx="0">
+            <a:schemeClr val="accent1"/>
+          </a:effectRef>
+          <a:fontRef idx="minor">
+            <a:schemeClr val="lt1"/>
+          </a:fontRef>
+        </p:style>
+        <p:txBody>
+          <a:bodyPr vertOverflow="clip" horzOverflow="clip" rtlCol="0" anchor="t"/>
+          <a:lstStyle/>
+          <a:p>
+            <a:pPr algn="l"/>
+            <a:endParaRPr lang="en-US"/>
           </a:p>
         </p:txBody>
       </p:sp>

</xml_diff>

<commit_message>
Initial merge using Copilot (#25)
</commit_message>
<xml_diff>
--- a/pptfiles/Git Fun(damentals).pptx
+++ b/pptfiles/Git Fun(damentals).pptx
@@ -206,7 +206,7 @@
           <a:p>
             <a:fld id="{0DEEF836-1B92-4BB9-A026-840A0CC45D27}" type="datetimeFigureOut">
               <a:rPr lang="en-US" smtClean="0"/>
-              <a:t>3/12/2025</a:t>
+              <a:t>4/4/2026</a:t>
             </a:fld>
             <a:endParaRPr lang="en-US"/>
           </a:p>
@@ -932,10 +932,9 @@
           <a:lstStyle/>
           <a:p>
             <a:r>
-              <a:rPr lang="en-US"/>
+              <a:rPr lang="en-US" dirty="0"/>
               <a:t>git status</a:t>
             </a:r>
-            <a:endParaRPr lang="en-US" dirty="0"/>
           </a:p>
         </p:txBody>
       </p:sp>
@@ -1122,7 +1121,7 @@
           <a:p>
             <a:fld id="{21313E3A-D863-467D-A8AF-65230468DBE3}" type="datetimeFigureOut">
               <a:rPr lang="en-US" smtClean="0"/>
-              <a:t>3/12/2025</a:t>
+              <a:t>4/4/2026</a:t>
             </a:fld>
             <a:endParaRPr lang="en-US"/>
           </a:p>
@@ -1320,7 +1319,7 @@
           <a:p>
             <a:fld id="{21313E3A-D863-467D-A8AF-65230468DBE3}" type="datetimeFigureOut">
               <a:rPr lang="en-US" smtClean="0"/>
-              <a:t>3/12/2025</a:t>
+              <a:t>4/4/2026</a:t>
             </a:fld>
             <a:endParaRPr lang="en-US"/>
           </a:p>
@@ -1528,7 +1527,7 @@
           <a:p>
             <a:fld id="{21313E3A-D863-467D-A8AF-65230468DBE3}" type="datetimeFigureOut">
               <a:rPr lang="en-US" smtClean="0"/>
-              <a:t>3/12/2025</a:t>
+              <a:t>4/4/2026</a:t>
             </a:fld>
             <a:endParaRPr lang="en-US"/>
           </a:p>
@@ -1726,7 +1725,7 @@
           <a:p>
             <a:fld id="{21313E3A-D863-467D-A8AF-65230468DBE3}" type="datetimeFigureOut">
               <a:rPr lang="en-US" smtClean="0"/>
-              <a:t>3/12/2025</a:t>
+              <a:t>4/4/2026</a:t>
             </a:fld>
             <a:endParaRPr lang="en-US"/>
           </a:p>
@@ -2001,7 +2000,7 @@
           <a:p>
             <a:fld id="{21313E3A-D863-467D-A8AF-65230468DBE3}" type="datetimeFigureOut">
               <a:rPr lang="en-US" smtClean="0"/>
-              <a:t>3/12/2025</a:t>
+              <a:t>4/4/2026</a:t>
             </a:fld>
             <a:endParaRPr lang="en-US"/>
           </a:p>
@@ -2266,7 +2265,7 @@
           <a:p>
             <a:fld id="{21313E3A-D863-467D-A8AF-65230468DBE3}" type="datetimeFigureOut">
               <a:rPr lang="en-US" smtClean="0"/>
-              <a:t>3/12/2025</a:t>
+              <a:t>4/4/2026</a:t>
             </a:fld>
             <a:endParaRPr lang="en-US"/>
           </a:p>
@@ -2678,7 +2677,7 @@
           <a:p>
             <a:fld id="{21313E3A-D863-467D-A8AF-65230468DBE3}" type="datetimeFigureOut">
               <a:rPr lang="en-US" smtClean="0"/>
-              <a:t>3/12/2025</a:t>
+              <a:t>4/4/2026</a:t>
             </a:fld>
             <a:endParaRPr lang="en-US"/>
           </a:p>
@@ -2819,7 +2818,7 @@
           <a:p>
             <a:fld id="{21313E3A-D863-467D-A8AF-65230468DBE3}" type="datetimeFigureOut">
               <a:rPr lang="en-US" smtClean="0"/>
-              <a:t>3/12/2025</a:t>
+              <a:t>4/4/2026</a:t>
             </a:fld>
             <a:endParaRPr lang="en-US"/>
           </a:p>
@@ -2932,7 +2931,7 @@
           <a:p>
             <a:fld id="{21313E3A-D863-467D-A8AF-65230468DBE3}" type="datetimeFigureOut">
               <a:rPr lang="en-US" smtClean="0"/>
-              <a:t>3/12/2025</a:t>
+              <a:t>4/4/2026</a:t>
             </a:fld>
             <a:endParaRPr lang="en-US"/>
           </a:p>
@@ -3243,7 +3242,7 @@
           <a:p>
             <a:fld id="{21313E3A-D863-467D-A8AF-65230468DBE3}" type="datetimeFigureOut">
               <a:rPr lang="en-US" smtClean="0"/>
-              <a:t>3/12/2025</a:t>
+              <a:t>4/4/2026</a:t>
             </a:fld>
             <a:endParaRPr lang="en-US"/>
           </a:p>
@@ -3531,7 +3530,7 @@
           <a:p>
             <a:fld id="{21313E3A-D863-467D-A8AF-65230468DBE3}" type="datetimeFigureOut">
               <a:rPr lang="en-US" smtClean="0"/>
-              <a:t>3/12/2025</a:t>
+              <a:t>4/4/2026</a:t>
             </a:fld>
             <a:endParaRPr lang="en-US"/>
           </a:p>
@@ -3772,7 +3771,7 @@
           <a:p>
             <a:fld id="{21313E3A-D863-467D-A8AF-65230468DBE3}" type="datetimeFigureOut">
               <a:rPr lang="en-US" smtClean="0"/>
-              <a:t>3/12/2025</a:t>
+              <a:t>4/4/2026</a:t>
             </a:fld>
             <a:endParaRPr lang="en-US"/>
           </a:p>
@@ -4287,8 +4286,16 @@
           <a:p>
             <a:pPr algn="l"/>
             <a:r>
-              <a:rPr lang="en-US" sz="6600"/>
-              <a:t>Git Fun(damentals)</a:t>
+              <a:rPr lang="en-US" sz="6600" dirty="0"/>
+              <a:t>Source Control Fun(</a:t>
+            </a:r>
+            <a:r>
+              <a:rPr lang="en-US" sz="6600" dirty="0" err="1"/>
+              <a:t>damentals</a:t>
+            </a:r>
+            <a:r>
+              <a:rPr lang="en-US" sz="6600" dirty="0"/>
+              <a:t>)</a:t>
             </a:r>
           </a:p>
         </p:txBody>
@@ -4324,7 +4331,7 @@
             <a:pPr algn="l"/>
             <a:r>
               <a:rPr lang="en-US" dirty="0"/>
-              <a:t>Have fun with Git without going mental!</a:t>
+              <a:t>Have fun with Git and GitHub without going mental!</a:t>
             </a:r>
           </a:p>
         </p:txBody>
@@ -4360,93 +4367,93 @@
           <a:custGeom>
             <a:avLst/>
             <a:gdLst>
-              <a:gd name="connsiteX0" fmla="*/ 0 w 4243589"/>
-              <a:gd name="connsiteY0" fmla="*/ 0 h 18288"/>
-              <a:gd name="connsiteX1" fmla="*/ 563791 w 4243589"/>
-              <a:gd name="connsiteY1" fmla="*/ 0 h 18288"/>
-              <a:gd name="connsiteX2" fmla="*/ 1042710 w 4243589"/>
-              <a:gd name="connsiteY2" fmla="*/ 0 h 18288"/>
-              <a:gd name="connsiteX3" fmla="*/ 1564066 w 4243589"/>
-              <a:gd name="connsiteY3" fmla="*/ 0 h 18288"/>
-              <a:gd name="connsiteX4" fmla="*/ 2212729 w 4243589"/>
-              <a:gd name="connsiteY4" fmla="*/ 0 h 18288"/>
-              <a:gd name="connsiteX5" fmla="*/ 2776520 w 4243589"/>
-              <a:gd name="connsiteY5" fmla="*/ 0 h 18288"/>
-              <a:gd name="connsiteX6" fmla="*/ 3297875 w 4243589"/>
-              <a:gd name="connsiteY6" fmla="*/ 0 h 18288"/>
-              <a:gd name="connsiteX7" fmla="*/ 4243589 w 4243589"/>
-              <a:gd name="connsiteY7" fmla="*/ 0 h 18288"/>
-              <a:gd name="connsiteX8" fmla="*/ 4243589 w 4243589"/>
-              <a:gd name="connsiteY8" fmla="*/ 18288 h 18288"/>
-              <a:gd name="connsiteX9" fmla="*/ 3637362 w 4243589"/>
-              <a:gd name="connsiteY9" fmla="*/ 18288 h 18288"/>
-              <a:gd name="connsiteX10" fmla="*/ 3116007 w 4243589"/>
-              <a:gd name="connsiteY10" fmla="*/ 18288 h 18288"/>
-              <a:gd name="connsiteX11" fmla="*/ 2424908 w 4243589"/>
-              <a:gd name="connsiteY11" fmla="*/ 18288 h 18288"/>
-              <a:gd name="connsiteX12" fmla="*/ 1861117 w 4243589"/>
-              <a:gd name="connsiteY12" fmla="*/ 18288 h 18288"/>
-              <a:gd name="connsiteX13" fmla="*/ 1382198 w 4243589"/>
-              <a:gd name="connsiteY13" fmla="*/ 18288 h 18288"/>
-              <a:gd name="connsiteX14" fmla="*/ 733535 w 4243589"/>
-              <a:gd name="connsiteY14" fmla="*/ 18288 h 18288"/>
-              <a:gd name="connsiteX15" fmla="*/ 0 w 4243589"/>
-              <a:gd name="connsiteY15" fmla="*/ 18288 h 18288"/>
-              <a:gd name="connsiteX16" fmla="*/ 0 w 4243589"/>
-              <a:gd name="connsiteY16" fmla="*/ 0 h 18288"/>
+              <a:gd name="csX0" fmla="*/ 0 w 4243589"/>
+              <a:gd name="csY0" fmla="*/ 0 h 18288"/>
+              <a:gd name="csX1" fmla="*/ 563791 w 4243589"/>
+              <a:gd name="csY1" fmla="*/ 0 h 18288"/>
+              <a:gd name="csX2" fmla="*/ 1042710 w 4243589"/>
+              <a:gd name="csY2" fmla="*/ 0 h 18288"/>
+              <a:gd name="csX3" fmla="*/ 1564066 w 4243589"/>
+              <a:gd name="csY3" fmla="*/ 0 h 18288"/>
+              <a:gd name="csX4" fmla="*/ 2212729 w 4243589"/>
+              <a:gd name="csY4" fmla="*/ 0 h 18288"/>
+              <a:gd name="csX5" fmla="*/ 2776520 w 4243589"/>
+              <a:gd name="csY5" fmla="*/ 0 h 18288"/>
+              <a:gd name="csX6" fmla="*/ 3297875 w 4243589"/>
+              <a:gd name="csY6" fmla="*/ 0 h 18288"/>
+              <a:gd name="csX7" fmla="*/ 4243589 w 4243589"/>
+              <a:gd name="csY7" fmla="*/ 0 h 18288"/>
+              <a:gd name="csX8" fmla="*/ 4243589 w 4243589"/>
+              <a:gd name="csY8" fmla="*/ 18288 h 18288"/>
+              <a:gd name="csX9" fmla="*/ 3637362 w 4243589"/>
+              <a:gd name="csY9" fmla="*/ 18288 h 18288"/>
+              <a:gd name="csX10" fmla="*/ 3116007 w 4243589"/>
+              <a:gd name="csY10" fmla="*/ 18288 h 18288"/>
+              <a:gd name="csX11" fmla="*/ 2424908 w 4243589"/>
+              <a:gd name="csY11" fmla="*/ 18288 h 18288"/>
+              <a:gd name="csX12" fmla="*/ 1861117 w 4243589"/>
+              <a:gd name="csY12" fmla="*/ 18288 h 18288"/>
+              <a:gd name="csX13" fmla="*/ 1382198 w 4243589"/>
+              <a:gd name="csY13" fmla="*/ 18288 h 18288"/>
+              <a:gd name="csX14" fmla="*/ 733535 w 4243589"/>
+              <a:gd name="csY14" fmla="*/ 18288 h 18288"/>
+              <a:gd name="csX15" fmla="*/ 0 w 4243589"/>
+              <a:gd name="csY15" fmla="*/ 18288 h 18288"/>
+              <a:gd name="csX16" fmla="*/ 0 w 4243589"/>
+              <a:gd name="csY16" fmla="*/ 0 h 18288"/>
             </a:gdLst>
             <a:ahLst/>
             <a:cxnLst>
               <a:cxn ang="0">
-                <a:pos x="connsiteX0" y="connsiteY0"/>
+                <a:pos x="csX0" y="csY0"/>
               </a:cxn>
               <a:cxn ang="0">
-                <a:pos x="connsiteX1" y="connsiteY1"/>
+                <a:pos x="csX1" y="csY1"/>
               </a:cxn>
               <a:cxn ang="0">
-                <a:pos x="connsiteX2" y="connsiteY2"/>
+                <a:pos x="csX2" y="csY2"/>
               </a:cxn>
               <a:cxn ang="0">
-                <a:pos x="connsiteX3" y="connsiteY3"/>
+                <a:pos x="csX3" y="csY3"/>
               </a:cxn>
               <a:cxn ang="0">
-                <a:pos x="connsiteX4" y="connsiteY4"/>
+                <a:pos x="csX4" y="csY4"/>
               </a:cxn>
               <a:cxn ang="0">
-                <a:pos x="connsiteX5" y="connsiteY5"/>
+                <a:pos x="csX5" y="csY5"/>
               </a:cxn>
               <a:cxn ang="0">
-                <a:pos x="connsiteX6" y="connsiteY6"/>
+                <a:pos x="csX6" y="csY6"/>
               </a:cxn>
               <a:cxn ang="0">
-                <a:pos x="connsiteX7" y="connsiteY7"/>
+                <a:pos x="csX7" y="csY7"/>
               </a:cxn>
               <a:cxn ang="0">
-                <a:pos x="connsiteX8" y="connsiteY8"/>
+                <a:pos x="csX8" y="csY8"/>
               </a:cxn>
               <a:cxn ang="0">
-                <a:pos x="connsiteX9" y="connsiteY9"/>
+                <a:pos x="csX9" y="csY9"/>
               </a:cxn>
               <a:cxn ang="0">
-                <a:pos x="connsiteX10" y="connsiteY10"/>
+                <a:pos x="csX10" y="csY10"/>
               </a:cxn>
               <a:cxn ang="0">
-                <a:pos x="connsiteX11" y="connsiteY11"/>
+                <a:pos x="csX11" y="csY11"/>
               </a:cxn>
               <a:cxn ang="0">
-                <a:pos x="connsiteX12" y="connsiteY12"/>
+                <a:pos x="csX12" y="csY12"/>
               </a:cxn>
               <a:cxn ang="0">
-                <a:pos x="connsiteX13" y="connsiteY13"/>
+                <a:pos x="csX13" y="csY13"/>
               </a:cxn>
               <a:cxn ang="0">
-                <a:pos x="connsiteX14" y="connsiteY14"/>
+                <a:pos x="csX14" y="csY14"/>
               </a:cxn>
               <a:cxn ang="0">
-                <a:pos x="connsiteX15" y="connsiteY15"/>
+                <a:pos x="csX15" y="csY15"/>
               </a:cxn>
               <a:cxn ang="0">
-                <a:pos x="connsiteX16" y="connsiteY16"/>
+                <a:pos x="csX16" y="csY16"/>
               </a:cxn>
             </a:cxnLst>
             <a:rect l="l" t="t" r="r" b="b"/>
@@ -4687,10 +4694,10 @@
           <p:nvPr/>
         </p:nvPicPr>
         <p:blipFill>
-          <a:blip r:embed="rId2">
+          <a:blip>
             <a:extLst>
               <a:ext uri="{96DAC541-7B7A-43D3-8B79-37D633B846F1}">
-                <asvg:svgBlip xmlns:asvg="http://schemas.microsoft.com/office/drawing/2016/SVG/main" r:embed="rId3"/>
+                <asvg:svgBlip xmlns:asvg="http://schemas.microsoft.com/office/drawing/2016/SVG/main" r:embed="rId2"/>
               </a:ext>
             </a:extLst>
           </a:blip>
@@ -5356,8 +5363,8 @@
         </p:nvSpPr>
         <p:spPr>
           <a:xfrm>
-            <a:off x="4290217" y="489509"/>
-            <a:ext cx="5754896" cy="833784"/>
+            <a:off x="750643" y="489509"/>
+            <a:ext cx="10690713" cy="833784"/>
           </a:xfrm>
         </p:spPr>
         <p:txBody>
@@ -5368,7 +5375,7 @@
           <a:p>
             <a:r>
               <a:rPr lang="en-US" sz="4000" dirty="0"/>
-              <a:t>What is Git?</a:t>
+              <a:t>What are Git and GitHub?</a:t>
             </a:r>
           </a:p>
         </p:txBody>
@@ -5388,10 +5395,10 @@
           <p:nvPr/>
         </p:nvPicPr>
         <p:blipFill>
-          <a:blip r:embed="rId2">
+          <a:blip>
             <a:extLst>
               <a:ext uri="{96DAC541-7B7A-43D3-8B79-37D633B846F1}">
-                <asvg:svgBlip xmlns:asvg="http://schemas.microsoft.com/office/drawing/2016/SVG/main" r:embed="rId3"/>
+                <asvg:svgBlip xmlns:asvg="http://schemas.microsoft.com/office/drawing/2016/SVG/main" r:embed="rId2"/>
               </a:ext>
             </a:extLst>
           </a:blip>
@@ -5401,8 +5408,8 @@
         </p:blipFill>
         <p:spPr>
           <a:xfrm>
-            <a:off x="750643" y="1323292"/>
-            <a:ext cx="2788930" cy="2788930"/>
+            <a:off x="750643" y="1681432"/>
+            <a:ext cx="1305608" cy="1305608"/>
           </a:xfrm>
           <a:prstGeom prst="rect">
             <a:avLst/>
@@ -5427,8 +5434,8 @@
         </p:nvSpPr>
         <p:spPr>
           <a:xfrm>
-            <a:off x="4290216" y="1412981"/>
-            <a:ext cx="5754896" cy="4955510"/>
+            <a:off x="2545081" y="1412981"/>
+            <a:ext cx="8896276" cy="4081039"/>
           </a:xfrm>
         </p:spPr>
         <p:txBody>
@@ -5437,40 +5444,256 @@
           </a:bodyPr>
           <a:lstStyle/>
           <a:p>
-            <a:r>
-              <a:rPr lang="en-US" dirty="0"/>
-              <a:t>A distributed version control system</a:t>
-            </a:r>
-          </a:p>
-          <a:p>
-            <a:r>
-              <a:rPr lang="en-US" dirty="0"/>
-              <a:t>Tracks the history of changes from multiple contributors</a:t>
-            </a:r>
-          </a:p>
-          <a:p>
-            <a:r>
-              <a:rPr lang="en-US" dirty="0"/>
-              <a:t>Any earlier version of the project can be recovered at any time</a:t>
-            </a:r>
-          </a:p>
-          <a:p>
-            <a:r>
-              <a:rPr lang="en-US" dirty="0"/>
-              <a:t>Each contributor has a full copy of the project and history</a:t>
-            </a:r>
-          </a:p>
-          <a:p>
-            <a:r>
-              <a:rPr lang="en-US" dirty="0"/>
-              <a:t>DVCSs don’t need a constant connection with a central repository</a:t>
-            </a:r>
-          </a:p>
-          <a:p>
-            <a:pPr marL="0" indent="0">
+            <a:pPr marL="0" indent="0" algn="l" rtl="0" eaLnBrk="1" latinLnBrk="0" hangingPunct="1">
+              <a:lnSpc>
+                <a:spcPct val="90000"/>
+              </a:lnSpc>
+              <a:spcBef>
+                <a:spcPts val="1000"/>
+              </a:spcBef>
               <a:buNone/>
             </a:pPr>
-            <a:endParaRPr lang="en-US" dirty="0"/>
+            <a:r>
+              <a:rPr lang="en-US" sz="1800" b="1" dirty="0">
+                <a:solidFill>
+                  <a:srgbClr val="000000"/>
+                </a:solidFill>
+                <a:effectLst/>
+                <a:latin typeface="Segoe UI" panose="020B0502040204020203" pitchFamily="34" charset="0"/>
+              </a:rPr>
+              <a:t>What is Git?</a:t>
+            </a:r>
+          </a:p>
+          <a:p>
+            <a:pPr marL="228600" indent="-228600" algn="l" rtl="0" eaLnBrk="1" latinLnBrk="0" hangingPunct="1">
+              <a:lnSpc>
+                <a:spcPct val="90000"/>
+              </a:lnSpc>
+              <a:spcBef>
+                <a:spcPts val="1000"/>
+              </a:spcBef>
+              <a:buFont typeface="Arial" panose="020B0604020202020204" pitchFamily="34" charset="0"/>
+              <a:buChar char="•"/>
+            </a:pPr>
+            <a:r>
+              <a:rPr lang="en-US" sz="1800" dirty="0">
+                <a:solidFill>
+                  <a:srgbClr val="000000"/>
+                </a:solidFill>
+                <a:effectLst/>
+                <a:latin typeface="Segoe UI" panose="020B0502040204020203" pitchFamily="34" charset="0"/>
+              </a:rPr>
+              <a:t>A distributed version control system tracking changes from multiple contributors</a:t>
+            </a:r>
+          </a:p>
+          <a:p>
+            <a:pPr marL="228600" indent="-228600" algn="l" rtl="0" eaLnBrk="1" latinLnBrk="0" hangingPunct="1">
+              <a:lnSpc>
+                <a:spcPct val="90000"/>
+              </a:lnSpc>
+              <a:spcBef>
+                <a:spcPts val="1000"/>
+              </a:spcBef>
+              <a:buFont typeface="Arial" panose="020B0604020202020204" pitchFamily="34" charset="0"/>
+              <a:buChar char="•"/>
+            </a:pPr>
+            <a:r>
+              <a:rPr lang="en-US" sz="1800" dirty="0">
+                <a:solidFill>
+                  <a:srgbClr val="000000"/>
+                </a:solidFill>
+                <a:effectLst/>
+                <a:latin typeface="Segoe UI" panose="020B0502040204020203" pitchFamily="34" charset="0"/>
+              </a:rPr>
+              <a:t>Allows recovery of any previous version</a:t>
+            </a:r>
+          </a:p>
+          <a:p>
+            <a:pPr marL="228600" indent="-228600" algn="l" rtl="0" eaLnBrk="1" latinLnBrk="0" hangingPunct="1">
+              <a:lnSpc>
+                <a:spcPct val="90000"/>
+              </a:lnSpc>
+              <a:spcBef>
+                <a:spcPts val="1000"/>
+              </a:spcBef>
+              <a:buFont typeface="Arial" panose="020B0604020202020204" pitchFamily="34" charset="0"/>
+              <a:buChar char="•"/>
+            </a:pPr>
+            <a:r>
+              <a:rPr lang="en-US" sz="1800" dirty="0">
+                <a:solidFill>
+                  <a:srgbClr val="000000"/>
+                </a:solidFill>
+                <a:effectLst/>
+                <a:latin typeface="Segoe UI" panose="020B0502040204020203" pitchFamily="34" charset="0"/>
+              </a:rPr>
+              <a:t>Each contributor has a full project copy and history</a:t>
+            </a:r>
+          </a:p>
+          <a:p>
+            <a:pPr marL="228600" indent="-228600" algn="l" rtl="0" eaLnBrk="1" latinLnBrk="0" hangingPunct="1">
+              <a:lnSpc>
+                <a:spcPct val="90000"/>
+              </a:lnSpc>
+              <a:spcBef>
+                <a:spcPts val="1000"/>
+              </a:spcBef>
+              <a:buFont typeface="Arial" panose="020B0604020202020204" pitchFamily="34" charset="0"/>
+              <a:buChar char="•"/>
+            </a:pPr>
+            <a:r>
+              <a:rPr lang="en-US" sz="1800" dirty="0">
+                <a:solidFill>
+                  <a:srgbClr val="000000"/>
+                </a:solidFill>
+                <a:effectLst/>
+                <a:latin typeface="Segoe UI" panose="020B0502040204020203" pitchFamily="34" charset="0"/>
+              </a:rPr>
+              <a:t>Does not require constant connection to a central repository</a:t>
+            </a:r>
+            <a:endParaRPr lang="en-US" sz="1800" b="1" dirty="0">
+              <a:solidFill>
+                <a:srgbClr val="000000"/>
+              </a:solidFill>
+              <a:effectLst/>
+              <a:latin typeface="Segoe UI" panose="020B0502040204020203" pitchFamily="34" charset="0"/>
+            </a:endParaRPr>
+          </a:p>
+          <a:p>
+            <a:pPr marL="0" indent="0" algn="l" rtl="0" eaLnBrk="1" latinLnBrk="0" hangingPunct="1">
+              <a:lnSpc>
+                <a:spcPct val="90000"/>
+              </a:lnSpc>
+              <a:spcBef>
+                <a:spcPts val="1000"/>
+              </a:spcBef>
+              <a:buNone/>
+            </a:pPr>
+            <a:r>
+              <a:rPr lang="en-US" sz="1800" b="1" dirty="0">
+                <a:solidFill>
+                  <a:srgbClr val="000000"/>
+                </a:solidFill>
+                <a:effectLst/>
+                <a:latin typeface="Segoe UI" panose="020B0502040204020203" pitchFamily="34" charset="0"/>
+              </a:rPr>
+              <a:t>What is GitHub?</a:t>
+            </a:r>
+          </a:p>
+          <a:p>
+            <a:pPr marL="228600" indent="-228600" algn="l" rtl="0" eaLnBrk="1" latinLnBrk="0" hangingPunct="1">
+              <a:lnSpc>
+                <a:spcPct val="90000"/>
+              </a:lnSpc>
+              <a:spcBef>
+                <a:spcPts val="1000"/>
+              </a:spcBef>
+              <a:buFont typeface="Arial" panose="020B0604020202020204" pitchFamily="34" charset="0"/>
+              <a:buChar char="•"/>
+            </a:pPr>
+            <a:r>
+              <a:rPr lang="en-US" sz="1800" dirty="0">
+                <a:solidFill>
+                  <a:srgbClr val="000000"/>
+                </a:solidFill>
+                <a:effectLst/>
+                <a:latin typeface="Segoe UI" panose="020B0502040204020203" pitchFamily="34" charset="0"/>
+              </a:rPr>
+              <a:t>Cloud hosting for Git repositories</a:t>
+            </a:r>
+          </a:p>
+          <a:p>
+            <a:pPr marL="228600" indent="-228600" algn="l" rtl="0" eaLnBrk="1" latinLnBrk="0" hangingPunct="1">
+              <a:lnSpc>
+                <a:spcPct val="90000"/>
+              </a:lnSpc>
+              <a:spcBef>
+                <a:spcPts val="1000"/>
+              </a:spcBef>
+              <a:buFont typeface="Arial" panose="020B0604020202020204" pitchFamily="34" charset="0"/>
+              <a:buChar char="•"/>
+            </a:pPr>
+            <a:r>
+              <a:rPr lang="en-US" sz="1800" dirty="0">
+                <a:solidFill>
+                  <a:srgbClr val="000000"/>
+                </a:solidFill>
+                <a:effectLst/>
+                <a:latin typeface="Segoe UI" panose="020B0502040204020203" pitchFamily="34" charset="0"/>
+              </a:rPr>
+              <a:t>Web interface for browsing repositories</a:t>
+            </a:r>
+          </a:p>
+          <a:p>
+            <a:pPr marL="228600" indent="-228600" algn="l" rtl="0" eaLnBrk="1" latinLnBrk="0" hangingPunct="1">
+              <a:lnSpc>
+                <a:spcPct val="90000"/>
+              </a:lnSpc>
+              <a:spcBef>
+                <a:spcPts val="1000"/>
+              </a:spcBef>
+              <a:buFont typeface="Arial" panose="020B0604020202020204" pitchFamily="34" charset="0"/>
+              <a:buChar char="•"/>
+            </a:pPr>
+            <a:r>
+              <a:rPr lang="en-US" sz="1800" dirty="0">
+                <a:solidFill>
+                  <a:srgbClr val="000000"/>
+                </a:solidFill>
+                <a:effectLst/>
+                <a:latin typeface="Segoe UI" panose="020B0502040204020203" pitchFamily="34" charset="0"/>
+              </a:rPr>
+              <a:t>Supports collaboration via pull requests and code reviews</a:t>
+            </a:r>
+          </a:p>
+          <a:p>
+            <a:pPr marL="228600" indent="-228600" algn="l" rtl="0" eaLnBrk="1" latinLnBrk="0" hangingPunct="1">
+              <a:lnSpc>
+                <a:spcPct val="90000"/>
+              </a:lnSpc>
+              <a:spcBef>
+                <a:spcPts val="1000"/>
+              </a:spcBef>
+              <a:buFont typeface="Arial" panose="020B0604020202020204" pitchFamily="34" charset="0"/>
+              <a:buChar char="•"/>
+            </a:pPr>
+            <a:r>
+              <a:rPr lang="en-US" sz="1800" dirty="0">
+                <a:solidFill>
+                  <a:srgbClr val="000000"/>
+                </a:solidFill>
+                <a:effectLst/>
+                <a:latin typeface="Segoe UI" panose="020B0502040204020203" pitchFamily="34" charset="0"/>
+              </a:rPr>
+              <a:t>Includes issue tracking and project management</a:t>
+            </a:r>
+          </a:p>
+          <a:p>
+            <a:pPr marL="228600" indent="-228600" algn="l" rtl="0" eaLnBrk="1" latinLnBrk="0" hangingPunct="1">
+              <a:lnSpc>
+                <a:spcPct val="90000"/>
+              </a:lnSpc>
+              <a:spcBef>
+                <a:spcPts val="1000"/>
+              </a:spcBef>
+              <a:buFont typeface="Arial" panose="020B0604020202020204" pitchFamily="34" charset="0"/>
+              <a:buChar char="•"/>
+            </a:pPr>
+            <a:r>
+              <a:rPr lang="en-US" sz="1800" dirty="0">
+                <a:solidFill>
+                  <a:srgbClr val="000000"/>
+                </a:solidFill>
+                <a:effectLst/>
+                <a:latin typeface="Segoe UI" panose="020B0502040204020203" pitchFamily="34" charset="0"/>
+              </a:rPr>
+              <a:t>Manages team workflows with permissions and access controls</a:t>
+            </a:r>
+            <a:endParaRPr lang="en-US" sz="1800" i="0" dirty="0">
+              <a:effectLst/>
+              <a:latin typeface="Segoe UI" panose="020B0502040204020203" pitchFamily="34" charset="0"/>
+              <a:cs typeface="Segoe UI" panose="020B0502040204020203" pitchFamily="34" charset="0"/>
+            </a:endParaRPr>
           </a:p>
         </p:txBody>
       </p:sp>
@@ -5620,6 +5843,42 @@
           </a:p>
         </p:txBody>
       </p:sp>
+      <p:pic>
+        <p:nvPicPr>
+          <p:cNvPr id="8" name="Graphic 7">
+            <a:extLst>
+              <a:ext uri="{FF2B5EF4-FFF2-40B4-BE49-F238E27FC236}">
+                <a16:creationId xmlns:a16="http://schemas.microsoft.com/office/drawing/2014/main" id="{D6EB0829-5269-4FF7-F9B0-E14EEE23708D}"/>
+              </a:ext>
+            </a:extLst>
+          </p:cNvPr>
+          <p:cNvPicPr>
+            <a:picLocks noChangeAspect="1"/>
+          </p:cNvPicPr>
+          <p:nvPr/>
+        </p:nvPicPr>
+        <p:blipFill>
+          <a:blip>
+            <a:extLst>
+              <a:ext uri="{96DAC541-7B7A-43D3-8B79-37D633B846F1}">
+                <asvg:svgBlip xmlns:asvg="http://schemas.microsoft.com/office/drawing/2016/SVG/main" r:embed="rId3"/>
+              </a:ext>
+            </a:extLst>
+          </a:blip>
+          <a:stretch>
+            <a:fillRect/>
+          </a:stretch>
+        </p:blipFill>
+        <p:spPr>
+          <a:xfrm>
+            <a:off x="750643" y="3648075"/>
+            <a:ext cx="1307592" cy="1307592"/>
+          </a:xfrm>
+          <a:prstGeom prst="rect">
+            <a:avLst/>
+          </a:prstGeom>
+        </p:spPr>
+      </p:pic>
     </p:spTree>
     <p:extLst>
       <p:ext uri="{BB962C8B-B14F-4D97-AF65-F5344CB8AC3E}">
@@ -6199,7 +6458,7 @@
         <p:spPr>
           <a:xfrm>
             <a:off x="630936" y="640823"/>
-            <a:ext cx="3419856" cy="5583148"/>
+            <a:ext cx="3419856" cy="2267915"/>
           </a:xfrm>
         </p:spPr>
         <p:txBody>
@@ -6209,7 +6468,7 @@
           <a:lstStyle/>
           <a:p>
             <a:r>
-              <a:rPr lang="en-US" sz="5400"/>
+              <a:rPr lang="en-US" sz="5400" dirty="0"/>
               <a:t>Git’s Three States</a:t>
             </a:r>
           </a:p>
@@ -6246,108 +6505,108 @@
           <a:custGeom>
             <a:avLst/>
             <a:gdLst>
-              <a:gd name="connsiteX0" fmla="*/ 0 w 18288"/>
-              <a:gd name="connsiteY0" fmla="*/ 0 h 5590381"/>
-              <a:gd name="connsiteX1" fmla="*/ 18288 w 18288"/>
-              <a:gd name="connsiteY1" fmla="*/ 0 h 5590381"/>
-              <a:gd name="connsiteX2" fmla="*/ 18288 w 18288"/>
-              <a:gd name="connsiteY2" fmla="*/ 754701 h 5590381"/>
-              <a:gd name="connsiteX3" fmla="*/ 18288 w 18288"/>
-              <a:gd name="connsiteY3" fmla="*/ 1565307 h 5590381"/>
-              <a:gd name="connsiteX4" fmla="*/ 18288 w 18288"/>
-              <a:gd name="connsiteY4" fmla="*/ 2152297 h 5590381"/>
-              <a:gd name="connsiteX5" fmla="*/ 18288 w 18288"/>
-              <a:gd name="connsiteY5" fmla="*/ 2906998 h 5590381"/>
-              <a:gd name="connsiteX6" fmla="*/ 18288 w 18288"/>
-              <a:gd name="connsiteY6" fmla="*/ 3549892 h 5590381"/>
-              <a:gd name="connsiteX7" fmla="*/ 18288 w 18288"/>
-              <a:gd name="connsiteY7" fmla="*/ 4080978 h 5590381"/>
-              <a:gd name="connsiteX8" fmla="*/ 18288 w 18288"/>
-              <a:gd name="connsiteY8" fmla="*/ 4835680 h 5590381"/>
-              <a:gd name="connsiteX9" fmla="*/ 18288 w 18288"/>
-              <a:gd name="connsiteY9" fmla="*/ 5590381 h 5590381"/>
-              <a:gd name="connsiteX10" fmla="*/ 0 w 18288"/>
-              <a:gd name="connsiteY10" fmla="*/ 5590381 h 5590381"/>
-              <a:gd name="connsiteX11" fmla="*/ 0 w 18288"/>
-              <a:gd name="connsiteY11" fmla="*/ 4835680 h 5590381"/>
-              <a:gd name="connsiteX12" fmla="*/ 0 w 18288"/>
-              <a:gd name="connsiteY12" fmla="*/ 4304593 h 5590381"/>
-              <a:gd name="connsiteX13" fmla="*/ 0 w 18288"/>
-              <a:gd name="connsiteY13" fmla="*/ 3773507 h 5590381"/>
-              <a:gd name="connsiteX14" fmla="*/ 0 w 18288"/>
-              <a:gd name="connsiteY14" fmla="*/ 3186517 h 5590381"/>
-              <a:gd name="connsiteX15" fmla="*/ 0 w 18288"/>
-              <a:gd name="connsiteY15" fmla="*/ 2487720 h 5590381"/>
-              <a:gd name="connsiteX16" fmla="*/ 0 w 18288"/>
-              <a:gd name="connsiteY16" fmla="*/ 1956633 h 5590381"/>
-              <a:gd name="connsiteX17" fmla="*/ 0 w 18288"/>
-              <a:gd name="connsiteY17" fmla="*/ 1425547 h 5590381"/>
-              <a:gd name="connsiteX18" fmla="*/ 0 w 18288"/>
-              <a:gd name="connsiteY18" fmla="*/ 614942 h 5590381"/>
-              <a:gd name="connsiteX19" fmla="*/ 0 w 18288"/>
-              <a:gd name="connsiteY19" fmla="*/ 0 h 5590381"/>
+              <a:gd name="csX0" fmla="*/ 0 w 18288"/>
+              <a:gd name="csY0" fmla="*/ 0 h 5590381"/>
+              <a:gd name="csX1" fmla="*/ 18288 w 18288"/>
+              <a:gd name="csY1" fmla="*/ 0 h 5590381"/>
+              <a:gd name="csX2" fmla="*/ 18288 w 18288"/>
+              <a:gd name="csY2" fmla="*/ 754701 h 5590381"/>
+              <a:gd name="csX3" fmla="*/ 18288 w 18288"/>
+              <a:gd name="csY3" fmla="*/ 1565307 h 5590381"/>
+              <a:gd name="csX4" fmla="*/ 18288 w 18288"/>
+              <a:gd name="csY4" fmla="*/ 2152297 h 5590381"/>
+              <a:gd name="csX5" fmla="*/ 18288 w 18288"/>
+              <a:gd name="csY5" fmla="*/ 2906998 h 5590381"/>
+              <a:gd name="csX6" fmla="*/ 18288 w 18288"/>
+              <a:gd name="csY6" fmla="*/ 3549892 h 5590381"/>
+              <a:gd name="csX7" fmla="*/ 18288 w 18288"/>
+              <a:gd name="csY7" fmla="*/ 4080978 h 5590381"/>
+              <a:gd name="csX8" fmla="*/ 18288 w 18288"/>
+              <a:gd name="csY8" fmla="*/ 4835680 h 5590381"/>
+              <a:gd name="csX9" fmla="*/ 18288 w 18288"/>
+              <a:gd name="csY9" fmla="*/ 5590381 h 5590381"/>
+              <a:gd name="csX10" fmla="*/ 0 w 18288"/>
+              <a:gd name="csY10" fmla="*/ 5590381 h 5590381"/>
+              <a:gd name="csX11" fmla="*/ 0 w 18288"/>
+              <a:gd name="csY11" fmla="*/ 4835680 h 5590381"/>
+              <a:gd name="csX12" fmla="*/ 0 w 18288"/>
+              <a:gd name="csY12" fmla="*/ 4304593 h 5590381"/>
+              <a:gd name="csX13" fmla="*/ 0 w 18288"/>
+              <a:gd name="csY13" fmla="*/ 3773507 h 5590381"/>
+              <a:gd name="csX14" fmla="*/ 0 w 18288"/>
+              <a:gd name="csY14" fmla="*/ 3186517 h 5590381"/>
+              <a:gd name="csX15" fmla="*/ 0 w 18288"/>
+              <a:gd name="csY15" fmla="*/ 2487720 h 5590381"/>
+              <a:gd name="csX16" fmla="*/ 0 w 18288"/>
+              <a:gd name="csY16" fmla="*/ 1956633 h 5590381"/>
+              <a:gd name="csX17" fmla="*/ 0 w 18288"/>
+              <a:gd name="csY17" fmla="*/ 1425547 h 5590381"/>
+              <a:gd name="csX18" fmla="*/ 0 w 18288"/>
+              <a:gd name="csY18" fmla="*/ 614942 h 5590381"/>
+              <a:gd name="csX19" fmla="*/ 0 w 18288"/>
+              <a:gd name="csY19" fmla="*/ 0 h 5590381"/>
             </a:gdLst>
             <a:ahLst/>
             <a:cxnLst>
               <a:cxn ang="0">
-                <a:pos x="connsiteX0" y="connsiteY0"/>
+                <a:pos x="csX0" y="csY0"/>
               </a:cxn>
               <a:cxn ang="0">
-                <a:pos x="connsiteX1" y="connsiteY1"/>
+                <a:pos x="csX1" y="csY1"/>
               </a:cxn>
               <a:cxn ang="0">
-                <a:pos x="connsiteX2" y="connsiteY2"/>
+                <a:pos x="csX2" y="csY2"/>
               </a:cxn>
               <a:cxn ang="0">
-                <a:pos x="connsiteX3" y="connsiteY3"/>
+                <a:pos x="csX3" y="csY3"/>
               </a:cxn>
               <a:cxn ang="0">
-                <a:pos x="connsiteX4" y="connsiteY4"/>
+                <a:pos x="csX4" y="csY4"/>
               </a:cxn>
               <a:cxn ang="0">
-                <a:pos x="connsiteX5" y="connsiteY5"/>
+                <a:pos x="csX5" y="csY5"/>
               </a:cxn>
               <a:cxn ang="0">
-                <a:pos x="connsiteX6" y="connsiteY6"/>
+                <a:pos x="csX6" y="csY6"/>
               </a:cxn>
               <a:cxn ang="0">
-                <a:pos x="connsiteX7" y="connsiteY7"/>
+                <a:pos x="csX7" y="csY7"/>
               </a:cxn>
               <a:cxn ang="0">
-                <a:pos x="connsiteX8" y="connsiteY8"/>
+                <a:pos x="csX8" y="csY8"/>
               </a:cxn>
               <a:cxn ang="0">
-                <a:pos x="connsiteX9" y="connsiteY9"/>
+                <a:pos x="csX9" y="csY9"/>
               </a:cxn>
               <a:cxn ang="0">
-                <a:pos x="connsiteX10" y="connsiteY10"/>
+                <a:pos x="csX10" y="csY10"/>
               </a:cxn>
               <a:cxn ang="0">
-                <a:pos x="connsiteX11" y="connsiteY11"/>
+                <a:pos x="csX11" y="csY11"/>
               </a:cxn>
               <a:cxn ang="0">
-                <a:pos x="connsiteX12" y="connsiteY12"/>
+                <a:pos x="csX12" y="csY12"/>
               </a:cxn>
               <a:cxn ang="0">
-                <a:pos x="connsiteX13" y="connsiteY13"/>
+                <a:pos x="csX13" y="csY13"/>
               </a:cxn>
               <a:cxn ang="0">
-                <a:pos x="connsiteX14" y="connsiteY14"/>
+                <a:pos x="csX14" y="csY14"/>
               </a:cxn>
               <a:cxn ang="0">
-                <a:pos x="connsiteX15" y="connsiteY15"/>
+                <a:pos x="csX15" y="csY15"/>
               </a:cxn>
               <a:cxn ang="0">
-                <a:pos x="connsiteX16" y="connsiteY16"/>
+                <a:pos x="csX16" y="csY16"/>
               </a:cxn>
               <a:cxn ang="0">
-                <a:pos x="connsiteX17" y="connsiteY17"/>
+                <a:pos x="csX17" y="csY17"/>
               </a:cxn>
               <a:cxn ang="0">
-                <a:pos x="connsiteX18" y="connsiteY18"/>
+                <a:pos x="csX18" y="csY18"/>
               </a:cxn>
               <a:cxn ang="0">
-                <a:pos x="connsiteX19" y="connsiteY19"/>
+                <a:pos x="csX19" y="csY19"/>
               </a:cxn>
             </a:cxnLst>
             <a:rect l="l" t="t" r="r" b="b"/>
@@ -6593,96 +6852,950 @@
           </a:p>
         </p:txBody>
       </p:sp>
-      <p:pic>
-        <p:nvPicPr>
-          <p:cNvPr id="1026" name="Picture 2" descr="Working tree, staging area, and Git directory">
-            <a:extLst>
-              <a:ext uri="{FF2B5EF4-FFF2-40B4-BE49-F238E27FC236}">
-                <a16:creationId xmlns:a16="http://schemas.microsoft.com/office/drawing/2014/main" id="{C9C3EF32-D632-47BE-E70F-2FE956200684}"/>
-              </a:ext>
-            </a:extLst>
-          </p:cNvPr>
-          <p:cNvPicPr>
-            <a:picLocks noChangeAspect="1" noChangeArrowheads="1"/>
-          </p:cNvPicPr>
+      <p:sp>
+        <p:nvSpPr>
+          <p:cNvPr id="6" name="lane_1">
+            <a:extLst>
+              <a:ext uri="{FF2B5EF4-FFF2-40B4-BE49-F238E27FC236}">
+                <a16:creationId xmlns:a16="http://schemas.microsoft.com/office/drawing/2014/main" id="{DF4A77A2-6834-4279-BA74-DC68E3CC4EBA}"/>
+              </a:ext>
+            </a:extLst>
+          </p:cNvPr>
+          <p:cNvSpPr/>
           <p:nvPr/>
-        </p:nvPicPr>
-        <p:blipFill>
-          <a:blip r:embed="rId3">
-            <a:extLst>
-              <a:ext uri="{28A0092B-C50C-407E-A947-70E740481C1C}">
-                <a14:useLocalDpi xmlns:a14="http://schemas.microsoft.com/office/drawing/2010/main" val="0"/>
-              </a:ext>
-            </a:extLst>
-          </a:blip>
-          <a:stretch>
-            <a:fillRect/>
-          </a:stretch>
-        </p:blipFill>
-        <p:spPr bwMode="auto">
+        </p:nvSpPr>
+        <p:spPr>
           <a:xfrm>
-            <a:off x="4654296" y="691744"/>
-            <a:ext cx="6894576" cy="3792015"/>
+            <a:off x="5841492" y="2303357"/>
+            <a:ext cx="25400" cy="2674365"/>
+          </a:xfrm>
+          <a:prstGeom prst="rect">
+            <a:avLst/>
+          </a:prstGeom>
+          <a:solidFill>
+            <a:srgbClr val="BDBDBD"/>
+          </a:solidFill>
+          <a:ln w="0" cap="flat" cmpd="sng" algn="ctr">
+            <a:solidFill>
+              <a:srgbClr val="156082">
+                <a:shade val="15000"/>
+              </a:srgbClr>
+            </a:solidFill>
+            <a:prstDash val="solid"/>
+            <a:miter lim="800000"/>
+          </a:ln>
+        </p:spPr>
+        <p:style>
+          <a:lnRef idx="2">
+            <a:schemeClr val="accent1">
+              <a:shade val="15000"/>
+            </a:schemeClr>
+          </a:lnRef>
+          <a:fillRef idx="1">
+            <a:schemeClr val="accent1"/>
+          </a:fillRef>
+          <a:effectRef idx="0">
+            <a:schemeClr val="accent1"/>
+          </a:effectRef>
+          <a:fontRef idx="minor">
+            <a:schemeClr val="lt1"/>
+          </a:fontRef>
+        </p:style>
+        <p:txBody>
+          <a:bodyPr vertOverflow="clip" horzOverflow="clip" rtlCol="0" anchor="t"/>
+          <a:lstStyle/>
+          <a:p>
+            <a:pPr algn="l"/>
+            <a:endParaRPr lang="en-US"/>
+          </a:p>
+        </p:txBody>
+      </p:sp>
+      <p:sp>
+        <p:nvSpPr>
+          <p:cNvPr id="7" name="lane_2">
+            <a:extLst>
+              <a:ext uri="{FF2B5EF4-FFF2-40B4-BE49-F238E27FC236}">
+                <a16:creationId xmlns:a16="http://schemas.microsoft.com/office/drawing/2014/main" id="{8E6EF5BD-F257-49D9-B92B-C146994F5EC9}"/>
+              </a:ext>
+            </a:extLst>
+          </p:cNvPr>
+          <p:cNvSpPr/>
+          <p:nvPr/>
+        </p:nvSpPr>
+        <p:spPr>
+          <a:xfrm>
+            <a:off x="8088884" y="2303357"/>
+            <a:ext cx="25400" cy="2674365"/>
+          </a:xfrm>
+          <a:prstGeom prst="rect">
+            <a:avLst/>
+          </a:prstGeom>
+          <a:solidFill>
+            <a:srgbClr val="BDBDBD"/>
+          </a:solidFill>
+          <a:ln w="0" cap="flat" cmpd="sng" algn="ctr">
+            <a:solidFill>
+              <a:srgbClr val="156082">
+                <a:shade val="15000"/>
+              </a:srgbClr>
+            </a:solidFill>
+            <a:prstDash val="solid"/>
+            <a:miter lim="800000"/>
+          </a:ln>
+        </p:spPr>
+        <p:style>
+          <a:lnRef idx="2">
+            <a:schemeClr val="accent1">
+              <a:shade val="15000"/>
+            </a:schemeClr>
+          </a:lnRef>
+          <a:fillRef idx="1">
+            <a:schemeClr val="accent1"/>
+          </a:fillRef>
+          <a:effectRef idx="0">
+            <a:schemeClr val="accent1"/>
+          </a:effectRef>
+          <a:fontRef idx="minor">
+            <a:schemeClr val="lt1"/>
+          </a:fontRef>
+        </p:style>
+        <p:txBody>
+          <a:bodyPr vertOverflow="clip" horzOverflow="clip" rtlCol="0" anchor="t"/>
+          <a:lstStyle/>
+          <a:p>
+            <a:pPr algn="l"/>
+            <a:endParaRPr lang="en-US"/>
+          </a:p>
+        </p:txBody>
+      </p:sp>
+      <p:sp>
+        <p:nvSpPr>
+          <p:cNvPr id="8" name="lane_3">
+            <a:extLst>
+              <a:ext uri="{FF2B5EF4-FFF2-40B4-BE49-F238E27FC236}">
+                <a16:creationId xmlns:a16="http://schemas.microsoft.com/office/drawing/2014/main" id="{31BCFF78-46C4-48EA-8E2B-6FEB865CADD8}"/>
+              </a:ext>
+            </a:extLst>
+          </p:cNvPr>
+          <p:cNvSpPr/>
+          <p:nvPr/>
+        </p:nvSpPr>
+        <p:spPr>
+          <a:xfrm>
+            <a:off x="10336276" y="2303357"/>
+            <a:ext cx="25400" cy="2674365"/>
+          </a:xfrm>
+          <a:prstGeom prst="rect">
+            <a:avLst/>
+          </a:prstGeom>
+          <a:solidFill>
+            <a:srgbClr val="BDBDBD"/>
+          </a:solidFill>
+          <a:ln w="0" cap="flat" cmpd="sng" algn="ctr">
+            <a:solidFill>
+              <a:srgbClr val="156082">
+                <a:shade val="15000"/>
+              </a:srgbClr>
+            </a:solidFill>
+            <a:prstDash val="solid"/>
+            <a:miter lim="800000"/>
+          </a:ln>
+        </p:spPr>
+        <p:style>
+          <a:lnRef idx="2">
+            <a:schemeClr val="accent1">
+              <a:shade val="15000"/>
+            </a:schemeClr>
+          </a:lnRef>
+          <a:fillRef idx="1">
+            <a:schemeClr val="accent1"/>
+          </a:fillRef>
+          <a:effectRef idx="0">
+            <a:schemeClr val="accent1"/>
+          </a:effectRef>
+          <a:fontRef idx="minor">
+            <a:schemeClr val="lt1"/>
+          </a:fontRef>
+        </p:style>
+        <p:txBody>
+          <a:bodyPr vertOverflow="clip" horzOverflow="clip" rtlCol="0" anchor="t"/>
+          <a:lstStyle/>
+          <a:p>
+            <a:pPr algn="l"/>
+            <a:endParaRPr lang="en-US"/>
+          </a:p>
+        </p:txBody>
+      </p:sp>
+      <p:sp>
+        <p:nvSpPr>
+          <p:cNvPr id="9" name="arrow_checkout">
+            <a:extLst>
+              <a:ext uri="{FF2B5EF4-FFF2-40B4-BE49-F238E27FC236}">
+                <a16:creationId xmlns:a16="http://schemas.microsoft.com/office/drawing/2014/main" id="{5A4C302C-47AF-4BF5-B685-B328D4756641}"/>
+              </a:ext>
+            </a:extLst>
+          </p:cNvPr>
+          <p:cNvSpPr/>
+          <p:nvPr/>
+        </p:nvSpPr>
+        <p:spPr>
+          <a:xfrm>
+            <a:off x="5841492" y="2430357"/>
+            <a:ext cx="4494784" cy="558800"/>
+          </a:xfrm>
+          <a:prstGeom prst="leftArrow">
+            <a:avLst/>
+          </a:prstGeom>
+          <a:solidFill>
+            <a:srgbClr val="8A8A8A"/>
+          </a:solidFill>
+          <a:ln w="0" cap="flat" cmpd="sng" algn="ctr">
+            <a:solidFill>
+              <a:srgbClr val="156082">
+                <a:shade val="15000"/>
+              </a:srgbClr>
+            </a:solidFill>
+            <a:prstDash val="solid"/>
+            <a:miter lim="800000"/>
+          </a:ln>
+        </p:spPr>
+        <p:style>
+          <a:lnRef idx="2">
+            <a:schemeClr val="accent1">
+              <a:shade val="15000"/>
+            </a:schemeClr>
+          </a:lnRef>
+          <a:fillRef idx="1">
+            <a:schemeClr val="accent1"/>
+          </a:fillRef>
+          <a:effectRef idx="0">
+            <a:schemeClr val="accent1"/>
+          </a:effectRef>
+          <a:fontRef idx="minor">
+            <a:schemeClr val="lt1"/>
+          </a:fontRef>
+        </p:style>
+        <p:txBody>
+          <a:bodyPr vertOverflow="clip" horzOverflow="clip" rtlCol="0" anchor="ctr" anchorCtr="0"/>
+          <a:lstStyle/>
+          <a:p>
+            <a:pPr algn="ctr"/>
+            <a:r>
+              <a:rPr lang="en-US" sz="1300" b="1">
+                <a:solidFill>
+                  <a:srgbClr val="FFFFFF"/>
+                </a:solidFill>
+              </a:rPr>
+              <a:t>Checkout the project</a:t>
+            </a:r>
+          </a:p>
+        </p:txBody>
+      </p:sp>
+      <p:sp>
+        <p:nvSpPr>
+          <p:cNvPr id="10" name="arrow_stage_fixes">
+            <a:extLst>
+              <a:ext uri="{FF2B5EF4-FFF2-40B4-BE49-F238E27FC236}">
+                <a16:creationId xmlns:a16="http://schemas.microsoft.com/office/drawing/2014/main" id="{B6697D44-14F7-4EAE-B2D8-05987AC06EF8}"/>
+              </a:ext>
+            </a:extLst>
+          </p:cNvPr>
+          <p:cNvSpPr/>
+          <p:nvPr/>
+        </p:nvSpPr>
+        <p:spPr>
+          <a:xfrm>
+            <a:off x="5841492" y="3420957"/>
+            <a:ext cx="2247900" cy="558800"/>
+          </a:xfrm>
+          <a:prstGeom prst="rightArrow">
+            <a:avLst/>
+          </a:prstGeom>
+          <a:solidFill>
+            <a:srgbClr val="8A8A8A"/>
+          </a:solidFill>
+          <a:ln w="0" cap="flat" cmpd="sng" algn="ctr">
+            <a:solidFill>
+              <a:srgbClr val="156082">
+                <a:shade val="15000"/>
+              </a:srgbClr>
+            </a:solidFill>
+            <a:prstDash val="solid"/>
+            <a:miter lim="800000"/>
+          </a:ln>
+        </p:spPr>
+        <p:style>
+          <a:lnRef idx="2">
+            <a:schemeClr val="accent1">
+              <a:shade val="15000"/>
+            </a:schemeClr>
+          </a:lnRef>
+          <a:fillRef idx="1">
+            <a:schemeClr val="accent1"/>
+          </a:fillRef>
+          <a:effectRef idx="0">
+            <a:schemeClr val="accent1"/>
+          </a:effectRef>
+          <a:fontRef idx="minor">
+            <a:schemeClr val="lt1"/>
+          </a:fontRef>
+        </p:style>
+        <p:txBody>
+          <a:bodyPr vertOverflow="clip" horzOverflow="clip" rtlCol="0" anchor="ctr" anchorCtr="0"/>
+          <a:lstStyle/>
+          <a:p>
+            <a:pPr algn="ctr"/>
+            <a:r>
+              <a:rPr lang="en-US" sz="1300" b="1">
+                <a:solidFill>
+                  <a:srgbClr val="FFFFFF"/>
+                </a:solidFill>
+              </a:rPr>
+              <a:t>Stage Fixes</a:t>
+            </a:r>
+          </a:p>
+        </p:txBody>
+      </p:sp>
+      <p:sp>
+        <p:nvSpPr>
+          <p:cNvPr id="11" name="arrow_commit">
+            <a:extLst>
+              <a:ext uri="{FF2B5EF4-FFF2-40B4-BE49-F238E27FC236}">
+                <a16:creationId xmlns:a16="http://schemas.microsoft.com/office/drawing/2014/main" id="{8444A4DA-5372-497F-8032-FB0C121B097A}"/>
+              </a:ext>
+            </a:extLst>
+          </p:cNvPr>
+          <p:cNvSpPr/>
+          <p:nvPr/>
+        </p:nvSpPr>
+        <p:spPr>
+          <a:xfrm>
+            <a:off x="8088883" y="4411557"/>
+            <a:ext cx="2247900" cy="558800"/>
+          </a:xfrm>
+          <a:prstGeom prst="rightArrow">
+            <a:avLst/>
+          </a:prstGeom>
+          <a:solidFill>
+            <a:srgbClr val="8A8A8A"/>
+          </a:solidFill>
+          <a:ln w="0" cap="flat" cmpd="sng" algn="ctr">
+            <a:solidFill>
+              <a:srgbClr val="156082">
+                <a:shade val="15000"/>
+              </a:srgbClr>
+            </a:solidFill>
+            <a:prstDash val="solid"/>
+            <a:miter lim="800000"/>
+          </a:ln>
+        </p:spPr>
+        <p:style>
+          <a:lnRef idx="2">
+            <a:schemeClr val="accent1">
+              <a:shade val="15000"/>
+            </a:schemeClr>
+          </a:lnRef>
+          <a:fillRef idx="1">
+            <a:schemeClr val="accent1"/>
+          </a:fillRef>
+          <a:effectRef idx="0">
+            <a:schemeClr val="accent1"/>
+          </a:effectRef>
+          <a:fontRef idx="minor">
+            <a:schemeClr val="lt1"/>
+          </a:fontRef>
+        </p:style>
+        <p:txBody>
+          <a:bodyPr vertOverflow="clip" horzOverflow="clip" rtlCol="0" anchor="ctr" anchorCtr="0"/>
+          <a:lstStyle/>
+          <a:p>
+            <a:pPr algn="ctr"/>
+            <a:r>
+              <a:rPr lang="en-US" sz="1300" b="1">
+                <a:solidFill>
+                  <a:srgbClr val="FFFFFF"/>
+                </a:solidFill>
+              </a:rPr>
+              <a:t>Commit</a:t>
+            </a:r>
+          </a:p>
+        </p:txBody>
+      </p:sp>
+      <p:sp>
+        <p:nvSpPr>
+          <p:cNvPr id="3" name="hdr_working_directory">
+            <a:extLst>
+              <a:ext uri="{FF2B5EF4-FFF2-40B4-BE49-F238E27FC236}">
+                <a16:creationId xmlns:a16="http://schemas.microsoft.com/office/drawing/2014/main" id="{79FE6068-A3B4-469C-8325-062090273F60}"/>
+              </a:ext>
+            </a:extLst>
+          </p:cNvPr>
+          <p:cNvSpPr/>
+          <p:nvPr/>
+        </p:nvSpPr>
+        <p:spPr>
+          <a:xfrm>
+            <a:off x="4814579" y="1490557"/>
+            <a:ext cx="2094992" cy="685800"/>
+          </a:xfrm>
+          <a:prstGeom prst="rect">
+            <a:avLst/>
+          </a:prstGeom>
+          <a:solidFill>
+            <a:srgbClr val="4E95D9"/>
+          </a:solidFill>
+          <a:ln w="0" cap="flat" cmpd="sng" algn="ctr">
+            <a:solidFill>
+              <a:srgbClr val="156082">
+                <a:shade val="15000"/>
+              </a:srgbClr>
+            </a:solidFill>
+            <a:prstDash val="solid"/>
+            <a:miter lim="800000"/>
+          </a:ln>
+        </p:spPr>
+        <p:style>
+          <a:lnRef idx="2">
+            <a:schemeClr val="accent1">
+              <a:shade val="15000"/>
+            </a:schemeClr>
+          </a:lnRef>
+          <a:fillRef idx="1">
+            <a:schemeClr val="accent1"/>
+          </a:fillRef>
+          <a:effectRef idx="0">
+            <a:schemeClr val="accent1"/>
+          </a:effectRef>
+          <a:fontRef idx="minor">
+            <a:schemeClr val="lt1"/>
+          </a:fontRef>
+        </p:style>
+        <p:txBody>
+          <a:bodyPr vertOverflow="clip" horzOverflow="clip" rtlCol="0" anchor="ctr" anchorCtr="0"/>
+          <a:lstStyle/>
+          <a:p>
+            <a:pPr algn="ctr"/>
+            <a:r>
+              <a:rPr lang="en-US" sz="1400" b="1" dirty="0">
+                <a:solidFill>
+                  <a:srgbClr val="FFFFFF"/>
+                </a:solidFill>
+              </a:rPr>
+              <a:t>Working</a:t>
+            </a:r>
+          </a:p>
+          <a:p>
+            <a:pPr algn="ctr"/>
+            <a:r>
+              <a:rPr lang="en-US" sz="1400" b="1" dirty="0">
+                <a:solidFill>
+                  <a:srgbClr val="FFFFFF"/>
+                </a:solidFill>
+              </a:rPr>
+              <a:t>Directory</a:t>
+            </a:r>
+          </a:p>
+        </p:txBody>
+      </p:sp>
+      <p:sp>
+        <p:nvSpPr>
+          <p:cNvPr id="4" name="hdr_staging_area">
+            <a:extLst>
+              <a:ext uri="{FF2B5EF4-FFF2-40B4-BE49-F238E27FC236}">
+                <a16:creationId xmlns:a16="http://schemas.microsoft.com/office/drawing/2014/main" id="{9FE1E0A1-252A-433F-BCC7-9E60FFE1C72B}"/>
+              </a:ext>
+            </a:extLst>
+          </p:cNvPr>
+          <p:cNvSpPr/>
+          <p:nvPr/>
+        </p:nvSpPr>
+        <p:spPr>
+          <a:xfrm>
+            <a:off x="7054088" y="1490557"/>
+            <a:ext cx="2094992" cy="685800"/>
+          </a:xfrm>
+          <a:prstGeom prst="rect">
+            <a:avLst/>
+          </a:prstGeom>
+          <a:solidFill>
+            <a:srgbClr val="E96F2B"/>
+          </a:solidFill>
+          <a:ln w="0" cap="flat" cmpd="sng" algn="ctr">
+            <a:solidFill>
+              <a:srgbClr val="156082">
+                <a:shade val="15000"/>
+              </a:srgbClr>
+            </a:solidFill>
+            <a:prstDash val="solid"/>
+            <a:miter lim="800000"/>
+          </a:ln>
+        </p:spPr>
+        <p:style>
+          <a:lnRef idx="2">
+            <a:schemeClr val="accent1">
+              <a:shade val="15000"/>
+            </a:schemeClr>
+          </a:lnRef>
+          <a:fillRef idx="1">
+            <a:schemeClr val="accent1"/>
+          </a:fillRef>
+          <a:effectRef idx="0">
+            <a:schemeClr val="accent1"/>
+          </a:effectRef>
+          <a:fontRef idx="minor">
+            <a:schemeClr val="lt1"/>
+          </a:fontRef>
+        </p:style>
+        <p:txBody>
+          <a:bodyPr vertOverflow="clip" horzOverflow="clip" rtlCol="0" anchor="ctr" anchorCtr="0"/>
+          <a:lstStyle/>
+          <a:p>
+            <a:pPr algn="ctr"/>
+            <a:r>
+              <a:rPr lang="en-US" sz="1400" b="1" dirty="0">
+                <a:solidFill>
+                  <a:srgbClr val="FFFFFF"/>
+                </a:solidFill>
+              </a:rPr>
+              <a:t>Staging</a:t>
+            </a:r>
+          </a:p>
+          <a:p>
+            <a:pPr algn="ctr"/>
+            <a:r>
+              <a:rPr lang="en-US" sz="1400" b="1" dirty="0">
+                <a:solidFill>
+                  <a:srgbClr val="FFFFFF"/>
+                </a:solidFill>
+              </a:rPr>
+              <a:t>Area (index)</a:t>
+            </a:r>
+          </a:p>
+        </p:txBody>
+      </p:sp>
+      <p:sp>
+        <p:nvSpPr>
+          <p:cNvPr id="5" name="hdr_repo">
+            <a:extLst>
+              <a:ext uri="{FF2B5EF4-FFF2-40B4-BE49-F238E27FC236}">
+                <a16:creationId xmlns:a16="http://schemas.microsoft.com/office/drawing/2014/main" id="{8CFC8AA7-0682-42D4-9CC1-E56EC00A4045}"/>
+              </a:ext>
+            </a:extLst>
+          </p:cNvPr>
+          <p:cNvSpPr/>
+          <p:nvPr/>
+        </p:nvSpPr>
+        <p:spPr>
+          <a:xfrm>
+            <a:off x="9301480" y="1490557"/>
+            <a:ext cx="2094992" cy="685800"/>
+          </a:xfrm>
+          <a:prstGeom prst="rect">
+            <a:avLst/>
+          </a:prstGeom>
+          <a:solidFill>
+            <a:srgbClr val="92D050"/>
+          </a:solidFill>
+          <a:ln w="15875" cap="flat" cmpd="sng" algn="ctr">
+            <a:solidFill>
+              <a:srgbClr val="9A9A9A"/>
+            </a:solidFill>
+            <a:prstDash val="solid"/>
+            <a:miter lim="800000"/>
+          </a:ln>
+        </p:spPr>
+        <p:style>
+          <a:lnRef idx="2">
+            <a:schemeClr val="accent1">
+              <a:shade val="15000"/>
+            </a:schemeClr>
+          </a:lnRef>
+          <a:fillRef idx="1">
+            <a:schemeClr val="accent1"/>
+          </a:fillRef>
+          <a:effectRef idx="0">
+            <a:schemeClr val="accent1"/>
+          </a:effectRef>
+          <a:fontRef idx="minor">
+            <a:schemeClr val="lt1"/>
+          </a:fontRef>
+        </p:style>
+        <p:txBody>
+          <a:bodyPr vertOverflow="clip" horzOverflow="clip" rtlCol="0" anchor="ctr" anchorCtr="0"/>
+          <a:lstStyle/>
+          <a:p>
+            <a:pPr algn="ctr"/>
+            <a:r>
+              <a:rPr lang="en-US" sz="1400" b="1" dirty="0">
+                <a:solidFill>
+                  <a:srgbClr val="333333"/>
+                </a:solidFill>
+              </a:rPr>
+              <a:t>Object</a:t>
+            </a:r>
+          </a:p>
+          <a:p>
+            <a:pPr algn="ctr"/>
+            <a:r>
+              <a:rPr lang="en-US" sz="1400" b="1" dirty="0">
+                <a:solidFill>
+                  <a:srgbClr val="333333"/>
+                </a:solidFill>
+              </a:rPr>
+              <a:t>database</a:t>
+            </a:r>
+          </a:p>
+        </p:txBody>
+      </p:sp>
+      <p:sp>
+        <p:nvSpPr>
+          <p:cNvPr id="14" name="hdr_repo">
+            <a:extLst>
+              <a:ext uri="{FF2B5EF4-FFF2-40B4-BE49-F238E27FC236}">
+                <a16:creationId xmlns:a16="http://schemas.microsoft.com/office/drawing/2014/main" id="{815A0292-FAB4-D514-8E52-2578F44A6B57}"/>
+              </a:ext>
+            </a:extLst>
+          </p:cNvPr>
+          <p:cNvSpPr/>
+          <p:nvPr/>
+        </p:nvSpPr>
+        <p:spPr>
+          <a:xfrm>
+            <a:off x="7054088" y="880956"/>
+            <a:ext cx="4321361" cy="525511"/>
+          </a:xfrm>
+          <a:prstGeom prst="rect">
+            <a:avLst/>
+          </a:prstGeom>
+          <a:solidFill>
+            <a:srgbClr val="EDEDED"/>
+          </a:solidFill>
+          <a:ln w="15875" cap="flat" cmpd="sng" algn="ctr">
+            <a:solidFill>
+              <a:srgbClr val="9A9A9A"/>
+            </a:solidFill>
+            <a:prstDash val="solid"/>
+            <a:miter lim="800000"/>
+          </a:ln>
+        </p:spPr>
+        <p:style>
+          <a:lnRef idx="2">
+            <a:schemeClr val="accent1">
+              <a:shade val="15000"/>
+            </a:schemeClr>
+          </a:lnRef>
+          <a:fillRef idx="1">
+            <a:schemeClr val="accent1"/>
+          </a:fillRef>
+          <a:effectRef idx="0">
+            <a:schemeClr val="accent1"/>
+          </a:effectRef>
+          <a:fontRef idx="minor">
+            <a:schemeClr val="lt1"/>
+          </a:fontRef>
+        </p:style>
+        <p:txBody>
+          <a:bodyPr vertOverflow="clip" horzOverflow="clip" rtlCol="0" anchor="ctr" anchorCtr="0"/>
+          <a:lstStyle/>
+          <a:p>
+            <a:pPr algn="ctr"/>
+            <a:r>
+              <a:rPr lang="en-US" sz="1400" b="1" dirty="0">
+                <a:solidFill>
+                  <a:srgbClr val="333333"/>
+                </a:solidFill>
+              </a:rPr>
+              <a:t>.git directory</a:t>
+            </a:r>
+          </a:p>
+          <a:p>
+            <a:pPr algn="ctr"/>
+            <a:r>
+              <a:rPr lang="en-US" sz="1400" b="1" dirty="0">
+                <a:solidFill>
+                  <a:srgbClr val="333333"/>
+                </a:solidFill>
+              </a:rPr>
+              <a:t>(Repository)</a:t>
+            </a:r>
+          </a:p>
+        </p:txBody>
+      </p:sp>
+      <p:sp>
+        <p:nvSpPr>
+          <p:cNvPr id="15" name="hdr_working_directory">
+            <a:extLst>
+              <a:ext uri="{FF2B5EF4-FFF2-40B4-BE49-F238E27FC236}">
+                <a16:creationId xmlns:a16="http://schemas.microsoft.com/office/drawing/2014/main" id="{433FF574-45B9-4AB9-5798-DB4D711DD382}"/>
+              </a:ext>
+            </a:extLst>
+          </p:cNvPr>
+          <p:cNvSpPr/>
+          <p:nvPr/>
+        </p:nvSpPr>
+        <p:spPr>
+          <a:xfrm>
+            <a:off x="4814579" y="5133804"/>
+            <a:ext cx="2094992" cy="685800"/>
+          </a:xfrm>
+          <a:prstGeom prst="rect">
+            <a:avLst/>
+          </a:prstGeom>
+          <a:solidFill>
+            <a:schemeClr val="tx2">
+              <a:lumMod val="50000"/>
+              <a:lumOff val="50000"/>
+            </a:schemeClr>
+          </a:solidFill>
+          <a:ln w="0" cap="flat" cmpd="sng" algn="ctr">
+            <a:solidFill>
+              <a:srgbClr val="156082">
+                <a:shade val="15000"/>
+              </a:srgbClr>
+            </a:solidFill>
+            <a:prstDash val="solid"/>
+            <a:miter lim="800000"/>
+          </a:ln>
+        </p:spPr>
+        <p:style>
+          <a:lnRef idx="2">
+            <a:schemeClr val="accent1">
+              <a:shade val="15000"/>
+            </a:schemeClr>
+          </a:lnRef>
+          <a:fillRef idx="1">
+            <a:schemeClr val="accent1"/>
+          </a:fillRef>
+          <a:effectRef idx="0">
+            <a:schemeClr val="accent1"/>
+          </a:effectRef>
+          <a:fontRef idx="minor">
+            <a:schemeClr val="lt1"/>
+          </a:fontRef>
+        </p:style>
+        <p:txBody>
+          <a:bodyPr vertOverflow="clip" horzOverflow="clip" rtlCol="0" anchor="ctr" anchorCtr="0"/>
+          <a:lstStyle/>
+          <a:p>
+            <a:pPr algn="ctr"/>
+            <a:r>
+              <a:rPr lang="en-US" sz="1400" b="1" dirty="0">
+                <a:solidFill>
+                  <a:srgbClr val="FFFFFF"/>
+                </a:solidFill>
+              </a:rPr>
+              <a:t>New, changed, and unchanged files</a:t>
+            </a:r>
+          </a:p>
+        </p:txBody>
+      </p:sp>
+      <p:sp>
+        <p:nvSpPr>
+          <p:cNvPr id="16" name="hdr_staging_area">
+            <a:extLst>
+              <a:ext uri="{FF2B5EF4-FFF2-40B4-BE49-F238E27FC236}">
+                <a16:creationId xmlns:a16="http://schemas.microsoft.com/office/drawing/2014/main" id="{3CC7E45B-A64D-6031-0AB0-E5C1AA0F0C10}"/>
+              </a:ext>
+            </a:extLst>
+          </p:cNvPr>
+          <p:cNvSpPr/>
+          <p:nvPr/>
+        </p:nvSpPr>
+        <p:spPr>
+          <a:xfrm>
+            <a:off x="7054088" y="5133804"/>
+            <a:ext cx="2094992" cy="685800"/>
+          </a:xfrm>
+          <a:prstGeom prst="rect">
+            <a:avLst/>
+          </a:prstGeom>
+          <a:solidFill>
+            <a:srgbClr val="E96F2B"/>
+          </a:solidFill>
+          <a:ln w="0" cap="flat" cmpd="sng" algn="ctr">
+            <a:solidFill>
+              <a:srgbClr val="156082">
+                <a:shade val="15000"/>
+              </a:srgbClr>
+            </a:solidFill>
+            <a:prstDash val="solid"/>
+            <a:miter lim="800000"/>
+          </a:ln>
+        </p:spPr>
+        <p:style>
+          <a:lnRef idx="2">
+            <a:schemeClr val="accent1">
+              <a:shade val="15000"/>
+            </a:schemeClr>
+          </a:lnRef>
+          <a:fillRef idx="1">
+            <a:schemeClr val="accent1"/>
+          </a:fillRef>
+          <a:effectRef idx="0">
+            <a:schemeClr val="accent1"/>
+          </a:effectRef>
+          <a:fontRef idx="minor">
+            <a:schemeClr val="lt1"/>
+          </a:fontRef>
+        </p:style>
+        <p:txBody>
+          <a:bodyPr vertOverflow="clip" horzOverflow="clip" rtlCol="0" anchor="ctr" anchorCtr="0"/>
+          <a:lstStyle/>
+          <a:p>
+            <a:pPr algn="ctr"/>
+            <a:r>
+              <a:rPr lang="en-US" sz="1400" b="1" dirty="0">
+                <a:solidFill>
+                  <a:srgbClr val="FFFFFF"/>
+                </a:solidFill>
+              </a:rPr>
+              <a:t>Tracked</a:t>
+            </a:r>
+          </a:p>
+          <a:p>
+            <a:pPr algn="ctr"/>
+            <a:r>
+              <a:rPr lang="en-US" sz="1400" b="1" dirty="0">
+                <a:solidFill>
+                  <a:srgbClr val="FFFFFF"/>
+                </a:solidFill>
+              </a:rPr>
+              <a:t>changes</a:t>
+            </a:r>
+          </a:p>
+        </p:txBody>
+      </p:sp>
+      <p:sp>
+        <p:nvSpPr>
+          <p:cNvPr id="17" name="hdr_repo">
+            <a:extLst>
+              <a:ext uri="{FF2B5EF4-FFF2-40B4-BE49-F238E27FC236}">
+                <a16:creationId xmlns:a16="http://schemas.microsoft.com/office/drawing/2014/main" id="{B06070A7-9151-C625-74B2-6BD1F68B87F9}"/>
+              </a:ext>
+            </a:extLst>
+          </p:cNvPr>
+          <p:cNvSpPr/>
+          <p:nvPr/>
+        </p:nvSpPr>
+        <p:spPr>
+          <a:xfrm>
+            <a:off x="9301480" y="5133804"/>
+            <a:ext cx="2094992" cy="685800"/>
+          </a:xfrm>
+          <a:prstGeom prst="rect">
+            <a:avLst/>
+          </a:prstGeom>
+          <a:solidFill>
+            <a:srgbClr val="92D050"/>
+          </a:solidFill>
+          <a:ln w="15875" cap="flat" cmpd="sng" algn="ctr">
+            <a:solidFill>
+              <a:srgbClr val="9A9A9A"/>
+            </a:solidFill>
+            <a:prstDash val="solid"/>
+            <a:miter lim="800000"/>
+          </a:ln>
+        </p:spPr>
+        <p:style>
+          <a:lnRef idx="2">
+            <a:schemeClr val="accent1">
+              <a:shade val="15000"/>
+            </a:schemeClr>
+          </a:lnRef>
+          <a:fillRef idx="1">
+            <a:schemeClr val="accent1"/>
+          </a:fillRef>
+          <a:effectRef idx="0">
+            <a:schemeClr val="accent1"/>
+          </a:effectRef>
+          <a:fontRef idx="minor">
+            <a:schemeClr val="lt1"/>
+          </a:fontRef>
+        </p:style>
+        <p:txBody>
+          <a:bodyPr vertOverflow="clip" horzOverflow="clip" rtlCol="0" anchor="ctr" anchorCtr="0"/>
+          <a:lstStyle/>
+          <a:p>
+            <a:pPr algn="ctr"/>
+            <a:r>
+              <a:rPr lang="en-US" sz="1400" b="1" dirty="0">
+                <a:solidFill>
+                  <a:srgbClr val="333333"/>
+                </a:solidFill>
+              </a:rPr>
+              <a:t>Committed</a:t>
+            </a:r>
+          </a:p>
+          <a:p>
+            <a:pPr algn="ctr"/>
+            <a:r>
+              <a:rPr lang="en-US" sz="1400" b="1" dirty="0">
+                <a:solidFill>
+                  <a:srgbClr val="333333"/>
+                </a:solidFill>
+              </a:rPr>
+              <a:t>objects</a:t>
+            </a:r>
+          </a:p>
+        </p:txBody>
+      </p:sp>
+      <p:sp>
+        <p:nvSpPr>
+          <p:cNvPr id="18" name="TextBox 17">
+            <a:extLst>
+              <a:ext uri="{FF2B5EF4-FFF2-40B4-BE49-F238E27FC236}">
+                <a16:creationId xmlns:a16="http://schemas.microsoft.com/office/drawing/2014/main" id="{A5750475-0DF2-61ED-39BE-E5BD0F89940C}"/>
+              </a:ext>
+            </a:extLst>
+          </p:cNvPr>
+          <p:cNvSpPr txBox="1"/>
+          <p:nvPr/>
+        </p:nvSpPr>
+        <p:spPr>
+          <a:xfrm>
+            <a:off x="630936" y="3420957"/>
+            <a:ext cx="3419856" cy="1200329"/>
           </a:xfrm>
           <a:prstGeom prst="rect">
             <a:avLst/>
           </a:prstGeom>
           <a:noFill/>
-          <a:extLst>
-            <a:ext uri="{909E8E84-426E-40DD-AFC4-6F175D3DCCD1}">
-              <a14:hiddenFill xmlns:a14="http://schemas.microsoft.com/office/drawing/2010/main">
-                <a:solidFill>
-                  <a:srgbClr val="FFFFFF"/>
-                </a:solidFill>
-              </a14:hiddenFill>
-            </a:ext>
-          </a:extLst>
         </p:spPr>
-      </p:pic>
-      <p:sp>
-        <p:nvSpPr>
-          <p:cNvPr id="1030" name="Content Placeholder 1029">
-            <a:extLst>
-              <a:ext uri="{FF2B5EF4-FFF2-40B4-BE49-F238E27FC236}">
-                <a16:creationId xmlns:a16="http://schemas.microsoft.com/office/drawing/2014/main" id="{713F870B-111C-315B-2E2A-596C505EF7F2}"/>
-              </a:ext>
-            </a:extLst>
-          </p:cNvPr>
-          <p:cNvSpPr>
-            <a:spLocks noGrp="1"/>
-          </p:cNvSpPr>
-          <p:nvPr>
-            <p:ph idx="1"/>
-          </p:nvPr>
-        </p:nvSpPr>
-        <p:spPr>
-          <a:xfrm>
-            <a:off x="4654296" y="4798577"/>
-            <a:ext cx="6894576" cy="1428487"/>
-          </a:xfrm>
-        </p:spPr>
-        <p:txBody>
-          <a:bodyPr anchor="t">
-            <a:normAutofit fontScale="92500"/>
+        <p:txBody>
+          <a:bodyPr wrap="square" rtlCol="0">
+            <a:spAutoFit/>
           </a:bodyPr>
           <a:lstStyle/>
           <a:p>
-            <a:r>
-              <a:rPr lang="en-US" sz="2200" dirty="0"/>
-              <a:t>Working directory – repo directory on the local file system</a:t>
-            </a:r>
-          </a:p>
-          <a:p>
-            <a:r>
-              <a:rPr lang="en-US" sz="2200" dirty="0"/>
-              <a:t>.git directory – hidden directory in root of the repo</a:t>
-            </a:r>
-          </a:p>
-          <a:p>
-            <a:r>
-              <a:rPr lang="en-US" sz="2200" dirty="0"/>
-              <a:t>Staging Area – index file in .git directory</a:t>
-            </a:r>
+            <a:pPr marL="285750" indent="-285750">
+              <a:buFont typeface="Arial" panose="020B0604020202020204" pitchFamily="34" charset="0"/>
+              <a:buChar char="•"/>
+            </a:pPr>
+            <a:r>
+              <a:rPr lang="en-US" sz="2400" dirty="0"/>
+              <a:t>Modified</a:t>
+            </a:r>
+          </a:p>
+          <a:p>
+            <a:pPr marL="285750" indent="-285750">
+              <a:buFont typeface="Arial" panose="020B0604020202020204" pitchFamily="34" charset="0"/>
+              <a:buChar char="•"/>
+            </a:pPr>
+            <a:r>
+              <a:rPr lang="en-US" sz="2400" dirty="0"/>
+              <a:t>Staged</a:t>
+            </a:r>
+          </a:p>
+          <a:p>
+            <a:pPr marL="285750" indent="-285750">
+              <a:buFont typeface="Arial" panose="020B0604020202020204" pitchFamily="34" charset="0"/>
+              <a:buChar char="•"/>
+            </a:pPr>
+            <a:r>
+              <a:rPr lang="en-US" sz="2400" dirty="0" err="1"/>
+              <a:t>Commited</a:t>
+            </a:r>
+            <a:endParaRPr lang="en-US" sz="2400" dirty="0"/>
           </a:p>
         </p:txBody>
       </p:sp>
@@ -6744,61 +7857,146 @@
           </a:p>
         </p:txBody>
       </p:sp>
-      <p:pic>
-        <p:nvPicPr>
-          <p:cNvPr id="2052" name="Picture 4" descr="The lifecycle of the status of your files">
-            <a:extLst>
-              <a:ext uri="{FF2B5EF4-FFF2-40B4-BE49-F238E27FC236}">
-                <a16:creationId xmlns:a16="http://schemas.microsoft.com/office/drawing/2014/main" id="{01673D6B-F791-2712-8B5C-52B444A486A9}"/>
-              </a:ext>
-            </a:extLst>
-          </p:cNvPr>
-          <p:cNvPicPr>
-            <a:picLocks noGrp="1" noChangeAspect="1" noChangeArrowheads="1"/>
-          </p:cNvPicPr>
-          <p:nvPr>
-            <p:ph idx="1"/>
-          </p:nvPr>
-        </p:nvPicPr>
-        <p:blipFill>
-          <a:blip r:embed="rId3">
-            <a:extLst>
-              <a:ext uri="{28A0092B-C50C-407E-A947-70E740481C1C}">
-                <a14:useLocalDpi xmlns:a14="http://schemas.microsoft.com/office/drawing/2010/main" val="0"/>
-              </a:ext>
-            </a:extLst>
-          </a:blip>
-          <a:srcRect/>
-          <a:stretch>
-            <a:fillRect/>
-          </a:stretch>
-        </p:blipFill>
-        <p:spPr bwMode="auto">
+      <p:sp>
+        <p:nvSpPr>
+          <p:cNvPr id="5" name="state_header_untracked">
+            <a:extLst>
+              <a:ext uri="{FF2B5EF4-FFF2-40B4-BE49-F238E27FC236}">
+                <a16:creationId xmlns:a16="http://schemas.microsoft.com/office/drawing/2014/main" id="{75225711-5E81-4E02-9D3B-28FDED9C9E34}"/>
+              </a:ext>
+            </a:extLst>
+          </p:cNvPr>
+          <p:cNvSpPr/>
+          <p:nvPr/>
+        </p:nvSpPr>
+        <p:spPr>
           <a:xfrm>
-            <a:off x="1150426" y="1825625"/>
-            <a:ext cx="9891147" cy="4351338"/>
+            <a:off x="1150424" y="1825625"/>
+            <a:ext cx="2358486" cy="533400"/>
           </a:xfrm>
           <a:prstGeom prst="rect">
             <a:avLst/>
           </a:prstGeom>
-          <a:noFill/>
-          <a:extLst>
-            <a:ext uri="{909E8E84-426E-40DD-AFC4-6F175D3DCCD1}">
-              <a14:hiddenFill xmlns:a14="http://schemas.microsoft.com/office/drawing/2010/main">
+          <a:solidFill>
+            <a:srgbClr val="E8E2D6"/>
+          </a:solidFill>
+          <a:ln w="19050" cap="flat" cmpd="sng" algn="ctr">
+            <a:solidFill>
+              <a:srgbClr val="156082">
+                <a:shade val="15000"/>
+                <a:alpha val="0"/>
+              </a:srgbClr>
+            </a:solidFill>
+            <a:prstDash val="solid"/>
+            <a:miter lim="800000"/>
+          </a:ln>
+        </p:spPr>
+        <p:style>
+          <a:lnRef idx="2">
+            <a:schemeClr val="accent1">
+              <a:shade val="15000"/>
+            </a:schemeClr>
+          </a:lnRef>
+          <a:fillRef idx="1">
+            <a:schemeClr val="accent1"/>
+          </a:fillRef>
+          <a:effectRef idx="0">
+            <a:schemeClr val="accent1"/>
+          </a:effectRef>
+          <a:fontRef idx="minor">
+            <a:schemeClr val="lt1"/>
+          </a:fontRef>
+        </p:style>
+        <p:txBody>
+          <a:bodyPr vertOverflow="clip" horzOverflow="clip" rtlCol="0" anchor="ctr" anchorCtr="0"/>
+          <a:lstStyle/>
+          <a:p>
+            <a:pPr algn="ctr"/>
+            <a:r>
+              <a:rPr lang="en-US" sz="1600" b="1">
+                <a:solidFill>
+                  <a:srgbClr val="3A3A3A"/>
+                </a:solidFill>
+                <a:latin typeface="Aptos"/>
+              </a:rPr>
+              <a:t>Untracked</a:t>
+            </a:r>
+          </a:p>
+        </p:txBody>
+      </p:sp>
+      <p:sp>
+        <p:nvSpPr>
+          <p:cNvPr id="6" name="state_header_unmodified">
+            <a:extLst>
+              <a:ext uri="{FF2B5EF4-FFF2-40B4-BE49-F238E27FC236}">
+                <a16:creationId xmlns:a16="http://schemas.microsoft.com/office/drawing/2014/main" id="{8F90BFF9-BBF7-466E-848C-EF2174E9856E}"/>
+              </a:ext>
+            </a:extLst>
+          </p:cNvPr>
+          <p:cNvSpPr/>
+          <p:nvPr/>
+        </p:nvSpPr>
+        <p:spPr>
+          <a:xfrm>
+            <a:off x="3661311" y="1825625"/>
+            <a:ext cx="2358486" cy="533400"/>
+          </a:xfrm>
+          <a:prstGeom prst="rect">
+            <a:avLst/>
+          </a:prstGeom>
+          <a:solidFill>
+            <a:srgbClr val="4E95D9"/>
+          </a:solidFill>
+          <a:ln w="19050" cap="flat" cmpd="sng" algn="ctr">
+            <a:solidFill>
+              <a:srgbClr val="156082">
+                <a:shade val="15000"/>
+                <a:alpha val="0"/>
+              </a:srgbClr>
+            </a:solidFill>
+            <a:prstDash val="solid"/>
+            <a:miter lim="800000"/>
+          </a:ln>
+        </p:spPr>
+        <p:style>
+          <a:lnRef idx="2">
+            <a:schemeClr val="accent1">
+              <a:shade val="15000"/>
+            </a:schemeClr>
+          </a:lnRef>
+          <a:fillRef idx="1">
+            <a:schemeClr val="accent1"/>
+          </a:fillRef>
+          <a:effectRef idx="0">
+            <a:schemeClr val="accent1"/>
+          </a:effectRef>
+          <a:fontRef idx="minor">
+            <a:schemeClr val="lt1"/>
+          </a:fontRef>
+        </p:style>
+        <p:txBody>
+          <a:bodyPr vertOverflow="clip" horzOverflow="clip" rtlCol="0" anchor="ctr" anchorCtr="0"/>
+          <a:lstStyle/>
+          <a:p>
+            <a:pPr algn="ctr"/>
+            <a:r>
+              <a:rPr lang="en-US" sz="1600" b="1">
                 <a:solidFill>
                   <a:srgbClr val="FFFFFF"/>
                 </a:solidFill>
-              </a14:hiddenFill>
-            </a:ext>
-          </a:extLst>
-        </p:spPr>
-      </p:pic>
-      <p:sp>
-        <p:nvSpPr>
-          <p:cNvPr id="3" name="Right Brace 2">
-            <a:extLst>
-              <a:ext uri="{FF2B5EF4-FFF2-40B4-BE49-F238E27FC236}">
-                <a16:creationId xmlns:a16="http://schemas.microsoft.com/office/drawing/2014/main" id="{34461D0D-4D41-C197-C665-2D644FE02E9C}"/>
+                <a:latin typeface="Aptos"/>
+              </a:rPr>
+              <a:t>Unmodified</a:t>
+            </a:r>
+          </a:p>
+        </p:txBody>
+      </p:sp>
+      <p:sp>
+        <p:nvSpPr>
+          <p:cNvPr id="7" name="state_header_modified">
+            <a:extLst>
+              <a:ext uri="{FF2B5EF4-FFF2-40B4-BE49-F238E27FC236}">
+                <a16:creationId xmlns:a16="http://schemas.microsoft.com/office/drawing/2014/main" id="{EE55EDAD-9E48-4648-99D0-D96278BA02B8}"/>
               </a:ext>
             </a:extLst>
           </p:cNvPr>
@@ -6806,14 +8004,662 @@
           <p:nvPr/>
         </p:nvSpPr>
         <p:spPr>
+          <a:xfrm>
+            <a:off x="6172198" y="1825625"/>
+            <a:ext cx="2358486" cy="533400"/>
+          </a:xfrm>
+          <a:prstGeom prst="rect">
+            <a:avLst/>
+          </a:prstGeom>
+          <a:solidFill>
+            <a:srgbClr val="E2B437"/>
+          </a:solidFill>
+          <a:ln w="19050" cap="flat" cmpd="sng" algn="ctr">
+            <a:solidFill>
+              <a:srgbClr val="156082">
+                <a:shade val="15000"/>
+                <a:alpha val="0"/>
+              </a:srgbClr>
+            </a:solidFill>
+            <a:prstDash val="solid"/>
+            <a:miter lim="800000"/>
+          </a:ln>
+        </p:spPr>
+        <p:style>
+          <a:lnRef idx="2">
+            <a:schemeClr val="accent1">
+              <a:shade val="15000"/>
+            </a:schemeClr>
+          </a:lnRef>
+          <a:fillRef idx="1">
+            <a:schemeClr val="accent1"/>
+          </a:fillRef>
+          <a:effectRef idx="0">
+            <a:schemeClr val="accent1"/>
+          </a:effectRef>
+          <a:fontRef idx="minor">
+            <a:schemeClr val="lt1"/>
+          </a:fontRef>
+        </p:style>
+        <p:txBody>
+          <a:bodyPr vertOverflow="clip" horzOverflow="clip" rtlCol="0" anchor="ctr" anchorCtr="0"/>
+          <a:lstStyle/>
+          <a:p>
+            <a:pPr algn="ctr"/>
+            <a:r>
+              <a:rPr lang="en-US" sz="1600" b="1" dirty="0">
+                <a:solidFill>
+                  <a:schemeClr val="bg2">
+                    <a:lumMod val="25000"/>
+                  </a:schemeClr>
+                </a:solidFill>
+                <a:latin typeface="Aptos"/>
+              </a:rPr>
+              <a:t>Modified</a:t>
+            </a:r>
+          </a:p>
+        </p:txBody>
+      </p:sp>
+      <p:sp>
+        <p:nvSpPr>
+          <p:cNvPr id="8" name="state_header_staged">
+            <a:extLst>
+              <a:ext uri="{FF2B5EF4-FFF2-40B4-BE49-F238E27FC236}">
+                <a16:creationId xmlns:a16="http://schemas.microsoft.com/office/drawing/2014/main" id="{AB9E43C7-5C91-43CD-81C3-06BA9144F525}"/>
+              </a:ext>
+            </a:extLst>
+          </p:cNvPr>
+          <p:cNvSpPr/>
+          <p:nvPr/>
+        </p:nvSpPr>
+        <p:spPr>
+          <a:xfrm>
+            <a:off x="8683085" y="1825625"/>
+            <a:ext cx="2358486" cy="533400"/>
+          </a:xfrm>
+          <a:prstGeom prst="rect">
+            <a:avLst/>
+          </a:prstGeom>
+          <a:solidFill>
+            <a:srgbClr val="D65A2E"/>
+          </a:solidFill>
+          <a:ln w="19050" cap="flat" cmpd="sng" algn="ctr">
+            <a:solidFill>
+              <a:srgbClr val="156082">
+                <a:shade val="15000"/>
+                <a:alpha val="0"/>
+              </a:srgbClr>
+            </a:solidFill>
+            <a:prstDash val="solid"/>
+            <a:miter lim="800000"/>
+          </a:ln>
+        </p:spPr>
+        <p:style>
+          <a:lnRef idx="2">
+            <a:schemeClr val="accent1">
+              <a:shade val="15000"/>
+            </a:schemeClr>
+          </a:lnRef>
+          <a:fillRef idx="1">
+            <a:schemeClr val="accent1"/>
+          </a:fillRef>
+          <a:effectRef idx="0">
+            <a:schemeClr val="accent1"/>
+          </a:effectRef>
+          <a:fontRef idx="minor">
+            <a:schemeClr val="lt1"/>
+          </a:fontRef>
+        </p:style>
+        <p:txBody>
+          <a:bodyPr vertOverflow="clip" horzOverflow="clip" rtlCol="0" anchor="ctr" anchorCtr="0"/>
+          <a:lstStyle/>
+          <a:p>
+            <a:pPr algn="ctr"/>
+            <a:r>
+              <a:rPr lang="en-US" sz="1600" b="1">
+                <a:solidFill>
+                  <a:srgbClr val="FFFFFF"/>
+                </a:solidFill>
+                <a:latin typeface="Aptos"/>
+              </a:rPr>
+              <a:t>Staged</a:t>
+            </a:r>
+          </a:p>
+        </p:txBody>
+      </p:sp>
+      <p:sp>
+        <p:nvSpPr>
+          <p:cNvPr id="9" name="state_divider_1">
+            <a:extLst>
+              <a:ext uri="{FF2B5EF4-FFF2-40B4-BE49-F238E27FC236}">
+                <a16:creationId xmlns:a16="http://schemas.microsoft.com/office/drawing/2014/main" id="{24F7C51F-7950-432D-B466-E369F58DFB56}"/>
+              </a:ext>
+            </a:extLst>
+          </p:cNvPr>
+          <p:cNvSpPr/>
+          <p:nvPr/>
+        </p:nvSpPr>
+        <p:spPr>
+          <a:xfrm>
+            <a:off x="4853255" y="2486025"/>
+            <a:ext cx="12700" cy="3462338"/>
+          </a:xfrm>
+          <a:prstGeom prst="rect">
+            <a:avLst/>
+          </a:prstGeom>
+          <a:solidFill>
+            <a:srgbClr val="D9D9D9"/>
+          </a:solidFill>
+          <a:ln w="19050" cap="flat" cmpd="sng" algn="ctr">
+            <a:solidFill>
+              <a:srgbClr val="156082">
+                <a:shade val="15000"/>
+                <a:alpha val="0"/>
+              </a:srgbClr>
+            </a:solidFill>
+            <a:prstDash val="solid"/>
+            <a:miter lim="800000"/>
+          </a:ln>
+        </p:spPr>
+        <p:style>
+          <a:lnRef idx="2">
+            <a:schemeClr val="accent1">
+              <a:shade val="15000"/>
+            </a:schemeClr>
+          </a:lnRef>
+          <a:fillRef idx="1">
+            <a:schemeClr val="accent1"/>
+          </a:fillRef>
+          <a:effectRef idx="0">
+            <a:schemeClr val="accent1"/>
+          </a:effectRef>
+          <a:fontRef idx="minor">
+            <a:schemeClr val="lt1"/>
+          </a:fontRef>
+        </p:style>
+        <p:txBody>
+          <a:bodyPr vertOverflow="clip" horzOverflow="clip" rtlCol="0" anchor="t"/>
+          <a:lstStyle/>
+          <a:p>
+            <a:pPr algn="l"/>
+            <a:endParaRPr lang="en-US"/>
+          </a:p>
+        </p:txBody>
+      </p:sp>
+      <p:sp>
+        <p:nvSpPr>
+          <p:cNvPr id="10" name="state_divider_2">
+            <a:extLst>
+              <a:ext uri="{FF2B5EF4-FFF2-40B4-BE49-F238E27FC236}">
+                <a16:creationId xmlns:a16="http://schemas.microsoft.com/office/drawing/2014/main" id="{4F2EFC66-9D8E-4798-98C4-E7AEB4C607D2}"/>
+              </a:ext>
+            </a:extLst>
+          </p:cNvPr>
+          <p:cNvSpPr/>
+          <p:nvPr/>
+        </p:nvSpPr>
+        <p:spPr>
+          <a:xfrm>
+            <a:off x="7326041" y="2486025"/>
+            <a:ext cx="12700" cy="3462338"/>
+          </a:xfrm>
+          <a:prstGeom prst="rect">
+            <a:avLst/>
+          </a:prstGeom>
+          <a:solidFill>
+            <a:srgbClr val="D9D9D9"/>
+          </a:solidFill>
+          <a:ln w="19050" cap="flat" cmpd="sng" algn="ctr">
+            <a:solidFill>
+              <a:srgbClr val="156082">
+                <a:shade val="15000"/>
+                <a:alpha val="0"/>
+              </a:srgbClr>
+            </a:solidFill>
+            <a:prstDash val="solid"/>
+            <a:miter lim="800000"/>
+          </a:ln>
+        </p:spPr>
+        <p:style>
+          <a:lnRef idx="2">
+            <a:schemeClr val="accent1">
+              <a:shade val="15000"/>
+            </a:schemeClr>
+          </a:lnRef>
+          <a:fillRef idx="1">
+            <a:schemeClr val="accent1"/>
+          </a:fillRef>
+          <a:effectRef idx="0">
+            <a:schemeClr val="accent1"/>
+          </a:effectRef>
+          <a:fontRef idx="minor">
+            <a:schemeClr val="lt1"/>
+          </a:fontRef>
+        </p:style>
+        <p:txBody>
+          <a:bodyPr vertOverflow="clip" horzOverflow="clip" rtlCol="0" anchor="t"/>
+          <a:lstStyle/>
+          <a:p>
+            <a:pPr algn="l"/>
+            <a:endParaRPr lang="en-US"/>
+          </a:p>
+        </p:txBody>
+      </p:sp>
+      <p:sp>
+        <p:nvSpPr>
+          <p:cNvPr id="11" name="state_divider_3">
+            <a:extLst>
+              <a:ext uri="{FF2B5EF4-FFF2-40B4-BE49-F238E27FC236}">
+                <a16:creationId xmlns:a16="http://schemas.microsoft.com/office/drawing/2014/main" id="{683CD8B0-C5A3-407D-9456-AFDD175D0F32}"/>
+              </a:ext>
+            </a:extLst>
+          </p:cNvPr>
+          <p:cNvSpPr/>
+          <p:nvPr/>
+        </p:nvSpPr>
+        <p:spPr>
+          <a:xfrm>
+            <a:off x="9798828" y="2486025"/>
+            <a:ext cx="12700" cy="3462338"/>
+          </a:xfrm>
+          <a:prstGeom prst="rect">
+            <a:avLst/>
+          </a:prstGeom>
+          <a:solidFill>
+            <a:srgbClr val="D9D9D9"/>
+          </a:solidFill>
+          <a:ln w="19050" cap="flat" cmpd="sng" algn="ctr">
+            <a:solidFill>
+              <a:srgbClr val="156082">
+                <a:shade val="15000"/>
+                <a:alpha val="0"/>
+              </a:srgbClr>
+            </a:solidFill>
+            <a:prstDash val="solid"/>
+            <a:miter lim="800000"/>
+          </a:ln>
+        </p:spPr>
+        <p:style>
+          <a:lnRef idx="2">
+            <a:schemeClr val="accent1">
+              <a:shade val="15000"/>
+            </a:schemeClr>
+          </a:lnRef>
+          <a:fillRef idx="1">
+            <a:schemeClr val="accent1"/>
+          </a:fillRef>
+          <a:effectRef idx="0">
+            <a:schemeClr val="accent1"/>
+          </a:effectRef>
+          <a:fontRef idx="minor">
+            <a:schemeClr val="lt1"/>
+          </a:fontRef>
+        </p:style>
+        <p:txBody>
+          <a:bodyPr vertOverflow="clip" horzOverflow="clip" rtlCol="0" anchor="t"/>
+          <a:lstStyle/>
+          <a:p>
+            <a:pPr algn="l"/>
+            <a:endParaRPr lang="en-US"/>
+          </a:p>
+        </p:txBody>
+      </p:sp>
+      <p:sp>
+        <p:nvSpPr>
+          <p:cNvPr id="12" name="arrow_add">
+            <a:extLst>
+              <a:ext uri="{FF2B5EF4-FFF2-40B4-BE49-F238E27FC236}">
+                <a16:creationId xmlns:a16="http://schemas.microsoft.com/office/drawing/2014/main" id="{67D69D4A-0748-49E0-A95C-CF06E5E2589B}"/>
+              </a:ext>
+            </a:extLst>
+          </p:cNvPr>
+          <p:cNvSpPr/>
+          <p:nvPr/>
+        </p:nvSpPr>
+        <p:spPr>
+          <a:xfrm>
+            <a:off x="2615418" y="2678849"/>
+            <a:ext cx="6961160" cy="431800"/>
+          </a:xfrm>
+          <a:prstGeom prst="rightArrow">
+            <a:avLst/>
+          </a:prstGeom>
+          <a:solidFill>
+            <a:srgbClr val="7A7A7A"/>
+          </a:solidFill>
+          <a:ln w="19050" cap="flat" cmpd="sng" algn="ctr">
+            <a:solidFill>
+              <a:srgbClr val="156082">
+                <a:shade val="15000"/>
+                <a:alpha val="0"/>
+              </a:srgbClr>
+            </a:solidFill>
+            <a:prstDash val="solid"/>
+            <a:miter lim="800000"/>
+          </a:ln>
+        </p:spPr>
+        <p:style>
+          <a:lnRef idx="2">
+            <a:schemeClr val="accent1">
+              <a:shade val="15000"/>
+            </a:schemeClr>
+          </a:lnRef>
+          <a:fillRef idx="1">
+            <a:schemeClr val="accent1"/>
+          </a:fillRef>
+          <a:effectRef idx="0">
+            <a:schemeClr val="accent1"/>
+          </a:effectRef>
+          <a:fontRef idx="minor">
+            <a:schemeClr val="lt1"/>
+          </a:fontRef>
+        </p:style>
+        <p:txBody>
+          <a:bodyPr vertOverflow="clip" horzOverflow="clip" rtlCol="0" anchor="ctr" anchorCtr="0"/>
+          <a:lstStyle/>
+          <a:p>
+            <a:pPr algn="ctr"/>
+            <a:r>
+              <a:rPr lang="en-US" sz="1600" b="1" dirty="0">
+                <a:solidFill>
+                  <a:srgbClr val="FFFFFF"/>
+                </a:solidFill>
+                <a:latin typeface="Aptos"/>
+              </a:rPr>
+              <a:t>Add the file</a:t>
+            </a:r>
+          </a:p>
+        </p:txBody>
+      </p:sp>
+      <p:sp>
+        <p:nvSpPr>
+          <p:cNvPr id="13" name="arrow_edit">
+            <a:extLst>
+              <a:ext uri="{FF2B5EF4-FFF2-40B4-BE49-F238E27FC236}">
+                <a16:creationId xmlns:a16="http://schemas.microsoft.com/office/drawing/2014/main" id="{C6677DC0-CCAF-4C4F-9064-FE38759C880E}"/>
+              </a:ext>
+            </a:extLst>
+          </p:cNvPr>
+          <p:cNvSpPr/>
+          <p:nvPr/>
+        </p:nvSpPr>
+        <p:spPr>
+          <a:xfrm>
+            <a:off x="5088205" y="3397340"/>
+            <a:ext cx="2015586" cy="431800"/>
+          </a:xfrm>
+          <a:prstGeom prst="rightArrow">
+            <a:avLst/>
+          </a:prstGeom>
+          <a:solidFill>
+            <a:srgbClr val="7A7A7A"/>
+          </a:solidFill>
+          <a:ln w="19050" cap="flat" cmpd="sng" algn="ctr">
+            <a:solidFill>
+              <a:srgbClr val="156082">
+                <a:shade val="15000"/>
+                <a:alpha val="0"/>
+              </a:srgbClr>
+            </a:solidFill>
+            <a:prstDash val="solid"/>
+            <a:miter lim="800000"/>
+          </a:ln>
+        </p:spPr>
+        <p:style>
+          <a:lnRef idx="2">
+            <a:schemeClr val="accent1">
+              <a:shade val="15000"/>
+            </a:schemeClr>
+          </a:lnRef>
+          <a:fillRef idx="1">
+            <a:schemeClr val="accent1"/>
+          </a:fillRef>
+          <a:effectRef idx="0">
+            <a:schemeClr val="accent1"/>
+          </a:effectRef>
+          <a:fontRef idx="minor">
+            <a:schemeClr val="lt1"/>
+          </a:fontRef>
+        </p:style>
+        <p:txBody>
+          <a:bodyPr vertOverflow="clip" horzOverflow="clip" rtlCol="0" anchor="ctr" anchorCtr="0"/>
+          <a:lstStyle/>
+          <a:p>
+            <a:pPr algn="ctr"/>
+            <a:r>
+              <a:rPr lang="en-US" sz="1600" b="1" dirty="0">
+                <a:solidFill>
+                  <a:srgbClr val="FFFFFF"/>
+                </a:solidFill>
+                <a:latin typeface="Aptos"/>
+              </a:rPr>
+              <a:t>Edit the file</a:t>
+            </a:r>
+          </a:p>
+        </p:txBody>
+      </p:sp>
+      <p:sp>
+        <p:nvSpPr>
+          <p:cNvPr id="14" name="arrow_stage">
+            <a:extLst>
+              <a:ext uri="{FF2B5EF4-FFF2-40B4-BE49-F238E27FC236}">
+                <a16:creationId xmlns:a16="http://schemas.microsoft.com/office/drawing/2014/main" id="{3F8EAB3A-EC31-4F0B-9806-F2C33B2A48DA}"/>
+              </a:ext>
+            </a:extLst>
+          </p:cNvPr>
+          <p:cNvSpPr/>
+          <p:nvPr/>
+        </p:nvSpPr>
+        <p:spPr>
+          <a:xfrm>
+            <a:off x="7560993" y="3400516"/>
+            <a:ext cx="2015586" cy="431800"/>
+          </a:xfrm>
+          <a:prstGeom prst="rightArrow">
+            <a:avLst/>
+          </a:prstGeom>
+          <a:solidFill>
+            <a:srgbClr val="7A7A7A"/>
+          </a:solidFill>
+          <a:ln w="19050" cap="flat" cmpd="sng" algn="ctr">
+            <a:solidFill>
+              <a:srgbClr val="156082">
+                <a:shade val="15000"/>
+                <a:alpha val="0"/>
+              </a:srgbClr>
+            </a:solidFill>
+            <a:prstDash val="solid"/>
+            <a:miter lim="800000"/>
+          </a:ln>
+        </p:spPr>
+        <p:style>
+          <a:lnRef idx="2">
+            <a:schemeClr val="accent1">
+              <a:shade val="15000"/>
+            </a:schemeClr>
+          </a:lnRef>
+          <a:fillRef idx="1">
+            <a:schemeClr val="accent1"/>
+          </a:fillRef>
+          <a:effectRef idx="0">
+            <a:schemeClr val="accent1"/>
+          </a:effectRef>
+          <a:fontRef idx="minor">
+            <a:schemeClr val="lt1"/>
+          </a:fontRef>
+        </p:style>
+        <p:txBody>
+          <a:bodyPr vertOverflow="clip" horzOverflow="clip" rtlCol="0" anchor="ctr" anchorCtr="0"/>
+          <a:lstStyle/>
+          <a:p>
+            <a:pPr algn="ctr"/>
+            <a:r>
+              <a:rPr lang="en-US" sz="1600" b="1" dirty="0">
+                <a:solidFill>
+                  <a:srgbClr val="FFFFFF"/>
+                </a:solidFill>
+                <a:latin typeface="Aptos"/>
+              </a:rPr>
+              <a:t>Stage the file</a:t>
+            </a:r>
+          </a:p>
+        </p:txBody>
+      </p:sp>
+      <p:sp>
+        <p:nvSpPr>
+          <p:cNvPr id="15" name="arrow_remove">
+            <a:extLst>
+              <a:ext uri="{FF2B5EF4-FFF2-40B4-BE49-F238E27FC236}">
+                <a16:creationId xmlns:a16="http://schemas.microsoft.com/office/drawing/2014/main" id="{D1374DF3-DFB5-4F37-9468-2EF39DDFE506}"/>
+              </a:ext>
+            </a:extLst>
+          </p:cNvPr>
+          <p:cNvSpPr/>
+          <p:nvPr/>
+        </p:nvSpPr>
+        <p:spPr>
+          <a:xfrm>
+            <a:off x="2615420" y="4001294"/>
+            <a:ext cx="2015586" cy="431800"/>
+          </a:xfrm>
+          <a:prstGeom prst="leftArrow">
+            <a:avLst/>
+          </a:prstGeom>
+          <a:solidFill>
+            <a:srgbClr val="7A7A7A"/>
+          </a:solidFill>
+          <a:ln w="19050" cap="flat" cmpd="sng" algn="ctr">
+            <a:solidFill>
+              <a:srgbClr val="156082">
+                <a:shade val="15000"/>
+                <a:alpha val="0"/>
+              </a:srgbClr>
+            </a:solidFill>
+            <a:prstDash val="solid"/>
+            <a:miter lim="800000"/>
+          </a:ln>
+        </p:spPr>
+        <p:style>
+          <a:lnRef idx="2">
+            <a:schemeClr val="accent1">
+              <a:shade val="15000"/>
+            </a:schemeClr>
+          </a:lnRef>
+          <a:fillRef idx="1">
+            <a:schemeClr val="accent1"/>
+          </a:fillRef>
+          <a:effectRef idx="0">
+            <a:schemeClr val="accent1"/>
+          </a:effectRef>
+          <a:fontRef idx="minor">
+            <a:schemeClr val="lt1"/>
+          </a:fontRef>
+        </p:style>
+        <p:txBody>
+          <a:bodyPr vertOverflow="clip" horzOverflow="clip" rtlCol="0" anchor="ctr" anchorCtr="0"/>
+          <a:lstStyle/>
+          <a:p>
+            <a:pPr algn="ctr"/>
+            <a:r>
+              <a:rPr lang="en-US" sz="1600" b="1" dirty="0">
+                <a:solidFill>
+                  <a:srgbClr val="FFFFFF"/>
+                </a:solidFill>
+                <a:latin typeface="Aptos"/>
+              </a:rPr>
+              <a:t>Remove the file</a:t>
+            </a:r>
+          </a:p>
+        </p:txBody>
+      </p:sp>
+      <p:sp>
+        <p:nvSpPr>
+          <p:cNvPr id="16" name="arrow_commit">
+            <a:extLst>
+              <a:ext uri="{FF2B5EF4-FFF2-40B4-BE49-F238E27FC236}">
+                <a16:creationId xmlns:a16="http://schemas.microsoft.com/office/drawing/2014/main" id="{55746C7C-2DAB-435B-842C-877B0EE77C56}"/>
+              </a:ext>
+            </a:extLst>
+          </p:cNvPr>
+          <p:cNvSpPr/>
+          <p:nvPr/>
+        </p:nvSpPr>
+        <p:spPr>
+          <a:xfrm>
+            <a:off x="5113603" y="4773058"/>
+            <a:ext cx="4462974" cy="431800"/>
+          </a:xfrm>
+          <a:prstGeom prst="leftArrow">
+            <a:avLst/>
+          </a:prstGeom>
+          <a:solidFill>
+            <a:srgbClr val="7A7A7A"/>
+          </a:solidFill>
+          <a:ln w="19050" cap="flat" cmpd="sng" algn="ctr">
+            <a:solidFill>
+              <a:srgbClr val="156082">
+                <a:shade val="15000"/>
+                <a:alpha val="0"/>
+              </a:srgbClr>
+            </a:solidFill>
+            <a:prstDash val="solid"/>
+            <a:miter lim="800000"/>
+          </a:ln>
+        </p:spPr>
+        <p:style>
+          <a:lnRef idx="2">
+            <a:schemeClr val="accent1">
+              <a:shade val="15000"/>
+            </a:schemeClr>
+          </a:lnRef>
+          <a:fillRef idx="1">
+            <a:schemeClr val="accent1"/>
+          </a:fillRef>
+          <a:effectRef idx="0">
+            <a:schemeClr val="accent1"/>
+          </a:effectRef>
+          <a:fontRef idx="minor">
+            <a:schemeClr val="lt1"/>
+          </a:fontRef>
+        </p:style>
+        <p:txBody>
+          <a:bodyPr vertOverflow="clip" horzOverflow="clip" rtlCol="0" anchor="ctr" anchorCtr="0"/>
+          <a:lstStyle/>
+          <a:p>
+            <a:pPr algn="ctr"/>
+            <a:r>
+              <a:rPr lang="en-US" sz="1600" b="1" dirty="0">
+                <a:solidFill>
+                  <a:srgbClr val="FFFFFF"/>
+                </a:solidFill>
+                <a:latin typeface="Aptos"/>
+              </a:rPr>
+              <a:t>Commit</a:t>
+            </a:r>
+          </a:p>
+        </p:txBody>
+      </p:sp>
+      <p:sp>
+        <p:nvSpPr>
+          <p:cNvPr id="3" name="Right Brace 2">
+            <a:extLst>
+              <a:ext uri="{FF2B5EF4-FFF2-40B4-BE49-F238E27FC236}">
+                <a16:creationId xmlns:a16="http://schemas.microsoft.com/office/drawing/2014/main" id="{34461D0D-4D41-C197-C665-2D644FE02E9C}"/>
+              </a:ext>
+            </a:extLst>
+          </p:cNvPr>
+          <p:cNvSpPr/>
+          <p:nvPr/>
+        </p:nvSpPr>
+        <p:spPr>
           <a:xfrm rot="5400000">
-            <a:off x="7079104" y="3328324"/>
-            <a:ext cx="517161" cy="5697278"/>
+            <a:off x="7080160" y="3526379"/>
+            <a:ext cx="517161" cy="4945574"/>
           </a:xfrm>
           <a:prstGeom prst="rightBrace">
             <a:avLst>
               <a:gd name="adj1" fmla="val 8333"/>
-              <a:gd name="adj2" fmla="val 47369"/>
+              <a:gd name="adj2" fmla="val 50337"/>
             </a:avLst>
           </a:prstGeom>
           <a:ln w="50800"/>
@@ -6855,7 +8701,7 @@
         </p:nvSpPr>
         <p:spPr>
           <a:xfrm>
-            <a:off x="6895476" y="6396335"/>
+            <a:off x="6719112" y="6234849"/>
             <a:ext cx="1213858" cy="461665"/>
           </a:xfrm>
           <a:prstGeom prst="rect">
@@ -6873,6 +8719,62 @@
               <a:rPr lang="en-US" sz="2400" dirty="0"/>
               <a:t>Tracked</a:t>
             </a:r>
+          </a:p>
+        </p:txBody>
+      </p:sp>
+      <p:sp>
+        <p:nvSpPr>
+          <p:cNvPr id="17" name="state_divider_0">
+            <a:extLst>
+              <a:ext uri="{FF2B5EF4-FFF2-40B4-BE49-F238E27FC236}">
+                <a16:creationId xmlns:a16="http://schemas.microsoft.com/office/drawing/2014/main" id="{49C6E2D4-F6CD-4600-A318-AD2B5BDA4A2C}"/>
+              </a:ext>
+            </a:extLst>
+          </p:cNvPr>
+          <p:cNvSpPr/>
+          <p:nvPr/>
+        </p:nvSpPr>
+        <p:spPr>
+          <a:xfrm>
+            <a:off x="2380467" y="2486025"/>
+            <a:ext cx="12700" cy="3462338"/>
+          </a:xfrm>
+          <a:prstGeom prst="rect">
+            <a:avLst/>
+          </a:prstGeom>
+          <a:solidFill>
+            <a:srgbClr val="D9D9D9"/>
+          </a:solidFill>
+          <a:ln w="0" cap="flat" cmpd="sng" algn="ctr">
+            <a:solidFill>
+              <a:srgbClr val="D9D9D9"/>
+            </a:solidFill>
+            <a:prstDash val="solid"/>
+            <a:miter lim="800000"/>
+          </a:ln>
+        </p:spPr>
+        <p:style>
+          <a:lnRef idx="2">
+            <a:schemeClr val="accent1">
+              <a:shade val="15000"/>
+            </a:schemeClr>
+          </a:lnRef>
+          <a:fillRef idx="1">
+            <a:schemeClr val="accent1"/>
+          </a:fillRef>
+          <a:effectRef idx="0">
+            <a:schemeClr val="accent1"/>
+          </a:effectRef>
+          <a:fontRef idx="minor">
+            <a:schemeClr val="lt1"/>
+          </a:fontRef>
+        </p:style>
+        <p:txBody>
+          <a:bodyPr vertOverflow="clip" horzOverflow="clip" rtlCol="0" anchor="t"/>
+          <a:lstStyle/>
+          <a:p>
+            <a:pPr algn="l"/>
+            <a:endParaRPr lang="en-US"/>
           </a:p>
         </p:txBody>
       </p:sp>

</xml_diff>